<commit_message>
Add the engineering decisions and results section to the README and two slides to the deck
</commit_message>
<xml_diff>
--- a/docs/presentation/CampusSlot-final-presentation.pptx
+++ b/docs/presentation/CampusSlot-final-presentation.pptx
@@ -17,6 +17,8 @@
     <p:sldId id="265" r:id="rId17"/>
     <p:sldId id="266" r:id="rId18"/>
     <p:sldId id="267" r:id="rId19"/>
+    <p:sldId id="268" r:id="rId20"/>
+    <p:sldId id="269" r:id="rId21"/>
   </p:sldIdLst>
   <p:sldSz cx="12191695" cy="6858000" type="screen4x3"/>
   <p:notesSz cx="6858000" cy="9144000"/>
@@ -679,6 +681,146 @@
 </file>
 
 <file path=ppt/notesSlides/notesSlide12.xml><?xml version="1.0" encoding="utf-8"?>
+<p:notes xmlns:a="http://schemas.openxmlformats.org/drawingml/2006/main" xmlns:p="http://schemas.openxmlformats.org/presentationml/2006/main" xmlns:r="http://schemas.openxmlformats.org/officeDocument/2006/relationships">
+  <p:cSld>
+    <p:spTree>
+      <p:nvGrpSpPr>
+        <p:cNvPr id="1" name=""/>
+        <p:cNvGrpSpPr/>
+        <p:nvPr/>
+      </p:nvGrpSpPr>
+      <p:grpSpPr>
+        <a:xfrm>
+          <a:off x="0" y="0"/>
+          <a:ext cx="0" cy="0"/>
+          <a:chOff x="0" y="0"/>
+          <a:chExt cx="0" cy="0"/>
+        </a:xfrm>
+      </p:grpSpPr>
+      <p:sp>
+        <p:nvSpPr>
+          <p:cNvPr id="2" name="Slide Image Placeholder 1"/>
+          <p:cNvSpPr>
+            <a:spLocks noGrp="1"/>
+          </p:cNvSpPr>
+          <p:nvPr>
+            <p:ph type="sldImg" idx="2"/>
+          </p:nvPr>
+        </p:nvSpPr>
+        <p:spPr/>
+      </p:sp>
+      <p:sp>
+        <p:nvSpPr>
+          <p:cNvPr id="3" name="Notes Placeholder 2"/>
+          <p:cNvSpPr>
+            <a:spLocks noGrp="1"/>
+          </p:cNvSpPr>
+          <p:nvPr>
+            <p:ph type="body" idx="3" sz="quarter"/>
+          </p:nvPr>
+        </p:nvSpPr>
+        <p:spPr/>
+        <p:txBody>
+          <a:bodyPr/>
+          <a:lstStyle/>
+          <a:p>
+            <a:r>
+              <a:t>Meeting a checklist is the minimum. What I wanted to show is the habit behind it: measure, find the weak point, change one thing, measure again, and write down what it cost. The chart allowed no unavailable replicas during a rollout, but when I measured it, every rollout lost one or two requests. An eight second delay before a pod stops fixed that in six out of six repeats. When I killed the database, users got eighteen errors but Prometheus counted none, so my own alerts were blind to a database outage. I made the application answer with a handled error, and now all of them are counted. I also made an alert fire on purpose and resolve, and I restored a deleted table from a backup and compared a checksum. The numbers come from small samples on one laptop, and the documents say so.</a:t>
+            </a:r>
+          </a:p>
+        </p:txBody>
+      </p:sp>
+      <p:sp>
+        <p:nvSpPr>
+          <p:cNvPr id="4" name="Slide Number Placeholder 3"/>
+          <p:cNvSpPr>
+            <a:spLocks noGrp="1"/>
+          </p:cNvSpPr>
+          <p:nvPr>
+            <p:ph type="sldNum" idx="5" sz="quarter"/>
+          </p:nvPr>
+        </p:nvSpPr>
+        <p:spPr/>
+      </p:sp>
+    </p:spTree>
+  </p:cSld>
+  <p:clrMapOvr>
+    <a:masterClrMapping/>
+  </p:clrMapOvr>
+</p:notes>
+</file>
+
+<file path=ppt/notesSlides/notesSlide13.xml><?xml version="1.0" encoding="utf-8"?>
+<p:notes xmlns:a="http://schemas.openxmlformats.org/drawingml/2006/main" xmlns:p="http://schemas.openxmlformats.org/presentationml/2006/main" xmlns:r="http://schemas.openxmlformats.org/officeDocument/2006/relationships">
+  <p:cSld>
+    <p:spTree>
+      <p:nvGrpSpPr>
+        <p:cNvPr id="1" name=""/>
+        <p:cNvGrpSpPr/>
+        <p:nvPr/>
+      </p:nvGrpSpPr>
+      <p:grpSpPr>
+        <a:xfrm>
+          <a:off x="0" y="0"/>
+          <a:ext cx="0" cy="0"/>
+          <a:chOff x="0" y="0"/>
+          <a:chExt cx="0" cy="0"/>
+        </a:xfrm>
+      </p:grpSpPr>
+      <p:sp>
+        <p:nvSpPr>
+          <p:cNvPr id="2" name="Slide Image Placeholder 1"/>
+          <p:cNvSpPr>
+            <a:spLocks noGrp="1"/>
+          </p:cNvSpPr>
+          <p:nvPr>
+            <p:ph type="sldImg" idx="2"/>
+          </p:nvPr>
+        </p:nvSpPr>
+        <p:spPr/>
+      </p:sp>
+      <p:sp>
+        <p:nvSpPr>
+          <p:cNvPr id="3" name="Notes Placeholder 2"/>
+          <p:cNvSpPr>
+            <a:spLocks noGrp="1"/>
+          </p:cNvSpPr>
+          <p:nvPr>
+            <p:ph type="body" idx="3" sz="quarter"/>
+          </p:nvPr>
+        </p:nvSpPr>
+        <p:spPr/>
+        <p:txBody>
+          <a:bodyPr/>
+          <a:lstStyle/>
+          <a:p>
+            <a:r>
+              <a:t>Every change costs something, and I wrote the cost down. Waiting eight seconds before a pod stops makes every rollout slower. Signing and verifying the images adds about a minute to every pipeline run, from one pair of runs. The backup stays inside the cluster, so it protects against mistakes but not against losing the cluster. There is one database pod, so an outage of about six seconds remains, and I only made it visible. On the right is what I planned and chose not to do, so nobody has to guess. Twelve short decision records explain the reasons for the main choices, with what I would do in production.</a:t>
+            </a:r>
+          </a:p>
+        </p:txBody>
+      </p:sp>
+      <p:sp>
+        <p:nvSpPr>
+          <p:cNvPr id="4" name="Slide Number Placeholder 3"/>
+          <p:cNvSpPr>
+            <a:spLocks noGrp="1"/>
+          </p:cNvSpPr>
+          <p:nvPr>
+            <p:ph type="sldNum" idx="5" sz="quarter"/>
+          </p:nvPr>
+        </p:nvSpPr>
+        <p:spPr/>
+      </p:sp>
+    </p:spTree>
+  </p:cSld>
+  <p:clrMapOvr>
+    <a:masterClrMapping/>
+  </p:clrMapOvr>
+</p:notes>
+</file>
+
+<file path=ppt/notesSlides/notesSlide14.xml><?xml version="1.0" encoding="utf-8"?>
 <p:notes xmlns:a="http://schemas.openxmlformats.org/drawingml/2006/main" xmlns:p="http://schemas.openxmlformats.org/presentationml/2006/main" xmlns:r="http://schemas.openxmlformats.org/officeDocument/2006/relationships">
   <p:cSld>
     <p:spTree>
@@ -4437,7 +4579,7 @@
                 </a:solidFill>
                 <a:latin typeface="Calibri"/>
               </a:rPr>
-              <a:t>CampusSlot   |   Ujjwal Jain   |   1 / 12</a:t>
+              <a:t>CampusSlot   |   Ujjwal Jain   |   1 / 14</a:t>
             </a:r>
           </a:p>
         </p:txBody>
@@ -4779,7 +4921,7 @@
                 </a:solidFill>
                 <a:latin typeface="Calibri"/>
               </a:rPr>
-              <a:t>CampusSlot   |   Ujjwal Jain   |   10 / 12</a:t>
+              <a:t>CampusSlot   |   Ujjwal Jain   |   10 / 14</a:t>
             </a:r>
           </a:p>
         </p:txBody>
@@ -5225,7 +5367,7 @@
                 </a:solidFill>
                 <a:latin typeface="Calibri"/>
               </a:rPr>
-              <a:t>CampusSlot   |   Ujjwal Jain   |   11 / 12</a:t>
+              <a:t>CampusSlot   |   Ujjwal Jain   |   11 / 14</a:t>
             </a:r>
           </a:p>
         </p:txBody>
@@ -5762,7 +5904,7 @@
                 </a:solidFill>
                 <a:latin typeface="Calibri"/>
               </a:rPr>
-              <a:t>From a change to a running system</a:t>
+              <a:t>Measure, change one thing, measure again</a:t>
             </a:r>
           </a:p>
         </p:txBody>
@@ -5796,7 +5938,7 @@
                 </a:solidFill>
                 <a:latin typeface="Calibri"/>
               </a:rPr>
-              <a:t>I rehearsed the whole loop, and here is what I learned</a:t>
+              <a:t>Every improvement has a number from before and a number from after</a:t>
             </a:r>
           </a:p>
         </p:txBody>
@@ -5830,7 +5972,1369 @@
                 </a:solidFill>
                 <a:latin typeface="Calibri"/>
               </a:rPr>
-              <a:t>CampusSlot   |   Ujjwal Jain   |   12 / 12</a:t>
+              <a:t>CampusSlot   |   Ujjwal Jain   |   12 / 14</a:t>
+            </a:r>
+          </a:p>
+        </p:txBody>
+      </p:sp>
+      <p:graphicFrame>
+        <p:nvGraphicFramePr>
+          <p:cNvPr id="6" name="Table 5"/>
+          <p:cNvGraphicFramePr>
+            <a:graphicFrameLocks noGrp="1"/>
+          </p:cNvGraphicFramePr>
+          <p:nvPr/>
+        </p:nvGraphicFramePr>
+        <p:xfrm>
+          <a:off x="548640" y="1645920"/>
+          <a:ext cx="6949440" cy="2194560"/>
+        </p:xfrm>
+        <a:graphic>
+          <a:graphicData uri="http://schemas.openxmlformats.org/drawingml/2006/table">
+            <a:tbl>
+              <a:tblPr firstRow="1" bandRow="1">
+                <a:tableStyleId>{5C22544A-7EE6-4342-B048-85BDC9FD1C3A}</a:tableStyleId>
+              </a:tblPr>
+              <a:tblGrid>
+                <a:gridCol w="3291840"/>
+                <a:gridCol w="2011680"/>
+                <a:gridCol w="1645920"/>
+              </a:tblGrid>
+              <a:tr h="365760">
+                <a:tc>
+                  <a:txBody>
+                    <a:bodyPr/>
+                    <a:lstStyle/>
+                    <a:p>
+                      <a:r>
+                        <a:rPr sz="1500" b="1">
+                          <a:solidFill>
+                            <a:srgbClr val="FFFFFF"/>
+                          </a:solidFill>
+                          <a:latin typeface="Calibri"/>
+                        </a:rPr>
+                        <a:t>What I measured</a:t>
+                      </a:r>
+                    </a:p>
+                  </a:txBody>
+                  <a:tcPr marL="73152" marR="73152">
+                    <a:solidFill>
+                      <a:srgbClr val="0F766E"/>
+                    </a:solidFill>
+                  </a:tcPr>
+                </a:tc>
+                <a:tc>
+                  <a:txBody>
+                    <a:bodyPr/>
+                    <a:lstStyle/>
+                    <a:p>
+                      <a:r>
+                        <a:rPr sz="1500" b="1">
+                          <a:solidFill>
+                            <a:srgbClr val="FFFFFF"/>
+                          </a:solidFill>
+                          <a:latin typeface="Calibri"/>
+                        </a:rPr>
+                        <a:t>Before</a:t>
+                      </a:r>
+                    </a:p>
+                  </a:txBody>
+                  <a:tcPr marL="73152" marR="73152">
+                    <a:solidFill>
+                      <a:srgbClr val="0F766E"/>
+                    </a:solidFill>
+                  </a:tcPr>
+                </a:tc>
+                <a:tc>
+                  <a:txBody>
+                    <a:bodyPr/>
+                    <a:lstStyle/>
+                    <a:p>
+                      <a:r>
+                        <a:rPr sz="1500" b="1">
+                          <a:solidFill>
+                            <a:srgbClr val="FFFFFF"/>
+                          </a:solidFill>
+                          <a:latin typeface="Calibri"/>
+                        </a:rPr>
+                        <a:t>After</a:t>
+                      </a:r>
+                    </a:p>
+                  </a:txBody>
+                  <a:tcPr marL="73152" marR="73152">
+                    <a:solidFill>
+                      <a:srgbClr val="0F766E"/>
+                    </a:solidFill>
+                  </a:tcPr>
+                </a:tc>
+              </a:tr>
+              <a:tr h="365760">
+                <a:tc>
+                  <a:txBody>
+                    <a:bodyPr/>
+                    <a:lstStyle/>
+                    <a:p>
+                      <a:r>
+                        <a:rPr sz="1500">
+                          <a:solidFill>
+                            <a:srgbClr val="12302D"/>
+                          </a:solidFill>
+                          <a:latin typeface="Calibri"/>
+                        </a:rPr>
+                        <a:t>Lost requests in a rollout</a:t>
+                      </a:r>
+                    </a:p>
+                  </a:txBody>
+                  <a:tcPr marL="73152" marR="73152">
+                    <a:solidFill>
+                      <a:srgbClr val="FFFFFF"/>
+                    </a:solidFill>
+                  </a:tcPr>
+                </a:tc>
+                <a:tc>
+                  <a:txBody>
+                    <a:bodyPr/>
+                    <a:lstStyle/>
+                    <a:p>
+                      <a:r>
+                        <a:rPr sz="1500">
+                          <a:solidFill>
+                            <a:srgbClr val="12302D"/>
+                          </a:solidFill>
+                          <a:latin typeface="Calibri"/>
+                        </a:rPr>
+                        <a:t>8 of 8 rollouts</a:t>
+                      </a:r>
+                    </a:p>
+                  </a:txBody>
+                  <a:tcPr marL="73152" marR="73152">
+                    <a:solidFill>
+                      <a:srgbClr val="FFFFFF"/>
+                    </a:solidFill>
+                  </a:tcPr>
+                </a:tc>
+                <a:tc>
+                  <a:txBody>
+                    <a:bodyPr/>
+                    <a:lstStyle/>
+                    <a:p>
+                      <a:r>
+                        <a:rPr sz="1500">
+                          <a:solidFill>
+                            <a:srgbClr val="12302D"/>
+                          </a:solidFill>
+                          <a:latin typeface="Calibri"/>
+                        </a:rPr>
+                        <a:t>0 of 6</a:t>
+                      </a:r>
+                    </a:p>
+                  </a:txBody>
+                  <a:tcPr marL="73152" marR="73152">
+                    <a:solidFill>
+                      <a:srgbClr val="FFFFFF"/>
+                    </a:solidFill>
+                  </a:tcPr>
+                </a:tc>
+              </a:tr>
+              <a:tr h="365760">
+                <a:tc>
+                  <a:txBody>
+                    <a:bodyPr/>
+                    <a:lstStyle/>
+                    <a:p>
+                      <a:r>
+                        <a:rPr sz="1500">
+                          <a:solidFill>
+                            <a:srgbClr val="12302D"/>
+                          </a:solidFill>
+                          <a:latin typeface="Calibri"/>
+                        </a:rPr>
+                        <a:t>Database errors seen by alerts</a:t>
+                      </a:r>
+                    </a:p>
+                  </a:txBody>
+                  <a:tcPr marL="73152" marR="73152">
+                    <a:solidFill>
+                      <a:srgbClr val="D7ECE9"/>
+                    </a:solidFill>
+                  </a:tcPr>
+                </a:tc>
+                <a:tc>
+                  <a:txBody>
+                    <a:bodyPr/>
+                    <a:lstStyle/>
+                    <a:p>
+                      <a:r>
+                        <a:rPr sz="1500">
+                          <a:solidFill>
+                            <a:srgbClr val="12302D"/>
+                          </a:solidFill>
+                          <a:latin typeface="Calibri"/>
+                        </a:rPr>
+                        <a:t>0 of 18</a:t>
+                      </a:r>
+                    </a:p>
+                  </a:txBody>
+                  <a:tcPr marL="73152" marR="73152">
+                    <a:solidFill>
+                      <a:srgbClr val="D7ECE9"/>
+                    </a:solidFill>
+                  </a:tcPr>
+                </a:tc>
+                <a:tc>
+                  <a:txBody>
+                    <a:bodyPr/>
+                    <a:lstStyle/>
+                    <a:p>
+                      <a:r>
+                        <a:rPr sz="1500">
+                          <a:solidFill>
+                            <a:srgbClr val="12302D"/>
+                          </a:solidFill>
+                          <a:latin typeface="Calibri"/>
+                        </a:rPr>
+                        <a:t>16 of 16</a:t>
+                      </a:r>
+                    </a:p>
+                  </a:txBody>
+                  <a:tcPr marL="73152" marR="73152">
+                    <a:solidFill>
+                      <a:srgbClr val="D7ECE9"/>
+                    </a:solidFill>
+                  </a:tcPr>
+                </a:tc>
+              </a:tr>
+              <a:tr h="365760">
+                <a:tc>
+                  <a:txBody>
+                    <a:bodyPr/>
+                    <a:lstStyle/>
+                    <a:p>
+                      <a:r>
+                        <a:rPr sz="1500">
+                          <a:solidFill>
+                            <a:srgbClr val="12302D"/>
+                          </a:solidFill>
+                          <a:latin typeface="Calibri"/>
+                        </a:rPr>
+                        <a:t>Alert on a broken deploy</a:t>
+                      </a:r>
+                    </a:p>
+                  </a:txBody>
+                  <a:tcPr marL="73152" marR="73152">
+                    <a:solidFill>
+                      <a:srgbClr val="FFFFFF"/>
+                    </a:solidFill>
+                  </a:tcPr>
+                </a:tc>
+                <a:tc>
+                  <a:txBody>
+                    <a:bodyPr/>
+                    <a:lstStyle/>
+                    <a:p>
+                      <a:r>
+                        <a:rPr sz="1500">
+                          <a:solidFill>
+                            <a:srgbClr val="12302D"/>
+                          </a:solidFill>
+                          <a:latin typeface="Calibri"/>
+                        </a:rPr>
+                        <a:t>none</a:t>
+                      </a:r>
+                    </a:p>
+                  </a:txBody>
+                  <a:tcPr marL="73152" marR="73152">
+                    <a:solidFill>
+                      <a:srgbClr val="FFFFFF"/>
+                    </a:solidFill>
+                  </a:tcPr>
+                </a:tc>
+                <a:tc>
+                  <a:txBody>
+                    <a:bodyPr/>
+                    <a:lstStyle/>
+                    <a:p>
+                      <a:r>
+                        <a:rPr sz="1500">
+                          <a:solidFill>
+                            <a:srgbClr val="12302D"/>
+                          </a:solidFill>
+                          <a:latin typeface="Calibri"/>
+                        </a:rPr>
+                        <a:t>fires in 185 s</a:t>
+                      </a:r>
+                    </a:p>
+                  </a:txBody>
+                  <a:tcPr marL="73152" marR="73152">
+                    <a:solidFill>
+                      <a:srgbClr val="FFFFFF"/>
+                    </a:solidFill>
+                  </a:tcPr>
+                </a:tc>
+              </a:tr>
+              <a:tr h="365760">
+                <a:tc>
+                  <a:txBody>
+                    <a:bodyPr/>
+                    <a:lstStyle/>
+                    <a:p>
+                      <a:r>
+                        <a:rPr sz="1500">
+                          <a:solidFill>
+                            <a:srgbClr val="12302D"/>
+                          </a:solidFill>
+                          <a:latin typeface="Calibri"/>
+                        </a:rPr>
+                        <a:t>Pipeline, median</a:t>
+                      </a:r>
+                    </a:p>
+                  </a:txBody>
+                  <a:tcPr marL="73152" marR="73152">
+                    <a:solidFill>
+                      <a:srgbClr val="D7ECE9"/>
+                    </a:solidFill>
+                  </a:tcPr>
+                </a:tc>
+                <a:tc>
+                  <a:txBody>
+                    <a:bodyPr/>
+                    <a:lstStyle/>
+                    <a:p>
+                      <a:r>
+                        <a:rPr sz="1500">
+                          <a:solidFill>
+                            <a:srgbClr val="12302D"/>
+                          </a:solidFill>
+                          <a:latin typeface="Calibri"/>
+                        </a:rPr>
+                        <a:t>238 s</a:t>
+                      </a:r>
+                    </a:p>
+                  </a:txBody>
+                  <a:tcPr marL="73152" marR="73152">
+                    <a:solidFill>
+                      <a:srgbClr val="D7ECE9"/>
+                    </a:solidFill>
+                  </a:tcPr>
+                </a:tc>
+                <a:tc>
+                  <a:txBody>
+                    <a:bodyPr/>
+                    <a:lstStyle/>
+                    <a:p>
+                      <a:r>
+                        <a:rPr sz="1500">
+                          <a:solidFill>
+                            <a:srgbClr val="12302D"/>
+                          </a:solidFill>
+                          <a:latin typeface="Calibri"/>
+                        </a:rPr>
+                        <a:t>148 s</a:t>
+                      </a:r>
+                    </a:p>
+                  </a:txBody>
+                  <a:tcPr marL="73152" marR="73152">
+                    <a:solidFill>
+                      <a:srgbClr val="D7ECE9"/>
+                    </a:solidFill>
+                  </a:tcPr>
+                </a:tc>
+              </a:tr>
+              <a:tr h="365760">
+                <a:tc>
+                  <a:txBody>
+                    <a:bodyPr/>
+                    <a:lstStyle/>
+                    <a:p>
+                      <a:r>
+                        <a:rPr sz="1500">
+                          <a:solidFill>
+                            <a:srgbClr val="12302D"/>
+                          </a:solidFill>
+                          <a:latin typeface="Calibri"/>
+                        </a:rPr>
+                        <a:t>Restore after a mass delete</a:t>
+                      </a:r>
+                    </a:p>
+                  </a:txBody>
+                  <a:tcPr marL="73152" marR="73152">
+                    <a:solidFill>
+                      <a:srgbClr val="FFFFFF"/>
+                    </a:solidFill>
+                  </a:tcPr>
+                </a:tc>
+                <a:tc>
+                  <a:txBody>
+                    <a:bodyPr/>
+                    <a:lstStyle/>
+                    <a:p>
+                      <a:r>
+                        <a:rPr sz="1500">
+                          <a:solidFill>
+                            <a:srgbClr val="12302D"/>
+                          </a:solidFill>
+                          <a:latin typeface="Calibri"/>
+                        </a:rPr>
+                        <a:t>no backup</a:t>
+                      </a:r>
+                    </a:p>
+                  </a:txBody>
+                  <a:tcPr marL="73152" marR="73152">
+                    <a:solidFill>
+                      <a:srgbClr val="FFFFFF"/>
+                    </a:solidFill>
+                  </a:tcPr>
+                </a:tc>
+                <a:tc>
+                  <a:txBody>
+                    <a:bodyPr/>
+                    <a:lstStyle/>
+                    <a:p>
+                      <a:r>
+                        <a:rPr sz="1500">
+                          <a:solidFill>
+                            <a:srgbClr val="12302D"/>
+                          </a:solidFill>
+                          <a:latin typeface="Calibri"/>
+                        </a:rPr>
+                        <a:t>identical, 4 s</a:t>
+                      </a:r>
+                    </a:p>
+                  </a:txBody>
+                  <a:tcPr marL="73152" marR="73152">
+                    <a:solidFill>
+                      <a:srgbClr val="FFFFFF"/>
+                    </a:solidFill>
+                  </a:tcPr>
+                </a:tc>
+              </a:tr>
+            </a:tbl>
+          </a:graphicData>
+        </a:graphic>
+      </p:graphicFrame>
+      <p:pic>
+        <p:nvPicPr>
+          <p:cNvPr id="7" name="Picture 6" descr="alert-firing.png"/>
+          <p:cNvPicPr>
+            <a:picLocks noChangeAspect="1"/>
+          </p:cNvPicPr>
+          <p:nvPr/>
+        </p:nvPicPr>
+        <p:blipFill>
+          <a:blip r:embed="rId3"/>
+          <a:stretch>
+            <a:fillRect/>
+          </a:stretch>
+        </p:blipFill>
+        <p:spPr>
+          <a:xfrm>
+            <a:off x="7781544" y="1645920"/>
+            <a:ext cx="4096511" cy="2560320"/>
+          </a:xfrm>
+          <a:prstGeom prst="rect">
+            <a:avLst/>
+          </a:prstGeom>
+          <a:ln w="12700">
+            <a:solidFill>
+              <a:srgbClr val="B9CFCB"/>
+            </a:solidFill>
+          </a:ln>
+        </p:spPr>
+      </p:pic>
+      <p:sp>
+        <p:nvSpPr>
+          <p:cNvPr id="8" name="TextBox 7"/>
+          <p:cNvSpPr txBox="1"/>
+          <p:nvPr/>
+        </p:nvSpPr>
+        <p:spPr>
+          <a:xfrm>
+            <a:off x="7772400" y="4224527"/>
+            <a:ext cx="4114800" cy="320040"/>
+          </a:xfrm>
+          <a:prstGeom prst="rect">
+            <a:avLst/>
+          </a:prstGeom>
+          <a:noFill/>
+        </p:spPr>
+        <p:txBody>
+          <a:bodyPr wrap="square">
+            <a:spAutoFit/>
+          </a:bodyPr>
+          <a:lstStyle/>
+          <a:p>
+            <a:pPr>
+              <a:spcAft>
+                <a:spcPts val="600"/>
+              </a:spcAft>
+            </a:pPr>
+            <a:r>
+              <a:rPr sz="1100" b="0">
+                <a:solidFill>
+                  <a:srgbClr val="5B726F"/>
+                </a:solidFill>
+                <a:latin typeface="Calibri"/>
+              </a:rPr>
+              <a:t>Prometheus: the alert firing during the drill</a:t>
+            </a:r>
+          </a:p>
+        </p:txBody>
+      </p:sp>
+      <p:sp>
+        <p:nvSpPr>
+          <p:cNvPr id="9" name="TextBox 8"/>
+          <p:cNvSpPr txBox="1"/>
+          <p:nvPr/>
+        </p:nvSpPr>
+        <p:spPr>
+          <a:xfrm>
+            <a:off x="548640" y="5029200"/>
+            <a:ext cx="11155680" cy="1280160"/>
+          </a:xfrm>
+          <a:prstGeom prst="rect">
+            <a:avLst/>
+          </a:prstGeom>
+          <a:noFill/>
+        </p:spPr>
+        <p:txBody>
+          <a:bodyPr wrap="square">
+            <a:spAutoFit/>
+          </a:bodyPr>
+          <a:lstStyle/>
+          <a:p>
+            <a:pPr>
+              <a:spcAft>
+                <a:spcPts val="800"/>
+              </a:spcAft>
+            </a:pPr>
+            <a:r>
+              <a:rPr sz="1600" b="0">
+                <a:solidFill>
+                  <a:srgbClr val="12302D"/>
+                </a:solidFill>
+                <a:latin typeface="Calibri"/>
+              </a:rPr>
+              <a:t>•  The method: baseline, one change, the same measurement again, then write down the trade-off.</a:t>
+            </a:r>
+          </a:p>
+          <a:p>
+            <a:pPr>
+              <a:spcAft>
+                <a:spcPts val="800"/>
+              </a:spcAft>
+            </a:pPr>
+            <a:r>
+              <a:rPr sz="1600" b="0">
+                <a:solidFill>
+                  <a:srgbClr val="12302D"/>
+                </a:solidFill>
+                <a:latin typeface="Calibri"/>
+              </a:rPr>
+              <a:t>•  The samples are small and from one laptop. The documents in the repository say so.</a:t>
+            </a:r>
+          </a:p>
+        </p:txBody>
+      </p:sp>
+    </p:spTree>
+  </p:cSld>
+  <p:clrMapOvr>
+    <a:masterClrMapping/>
+  </p:clrMapOvr>
+</p:sld>
+</file>
+
+<file path=ppt/slides/slide13.xml><?xml version="1.0" encoding="utf-8"?>
+<p:sld xmlns:a="http://schemas.openxmlformats.org/drawingml/2006/main" xmlns:p="http://schemas.openxmlformats.org/presentationml/2006/main" xmlns:r="http://schemas.openxmlformats.org/officeDocument/2006/relationships">
+  <p:cSld>
+    <p:bg>
+      <p:bgPr>
+        <a:solidFill>
+          <a:srgbClr val="F4F7F6"/>
+        </a:solidFill>
+        <a:effectLst/>
+      </p:bgPr>
+    </p:bg>
+    <p:spTree>
+      <p:nvGrpSpPr>
+        <p:cNvPr id="1" name=""/>
+        <p:cNvGrpSpPr/>
+        <p:nvPr/>
+      </p:nvGrpSpPr>
+      <p:grpSpPr/>
+      <p:sp>
+        <p:nvSpPr>
+          <p:cNvPr id="2" name="Rectangle 1"/>
+          <p:cNvSpPr/>
+          <p:nvPr/>
+        </p:nvSpPr>
+        <p:spPr>
+          <a:xfrm>
+            <a:off x="0" y="0"/>
+            <a:ext cx="228600" cy="6858000"/>
+          </a:xfrm>
+          <a:prstGeom prst="rect">
+            <a:avLst/>
+          </a:prstGeom>
+          <a:solidFill>
+            <a:srgbClr val="0F766E"/>
+          </a:solidFill>
+          <a:ln>
+            <a:noFill/>
+          </a:ln>
+        </p:spPr>
+        <p:style>
+          <a:lnRef idx="1">
+            <a:schemeClr val="accent1"/>
+          </a:lnRef>
+          <a:fillRef idx="3">
+            <a:schemeClr val="accent1"/>
+          </a:fillRef>
+          <a:effectRef idx="2">
+            <a:schemeClr val="accent1"/>
+          </a:effectRef>
+          <a:fontRef idx="minor">
+            <a:schemeClr val="lt1"/>
+          </a:fontRef>
+        </p:style>
+        <p:txBody>
+          <a:bodyPr rtlCol="0" anchor="ctr"/>
+          <a:lstStyle/>
+          <a:p>
+            <a:pPr algn="ctr"/>
+          </a:p>
+        </p:txBody>
+      </p:sp>
+      <p:sp>
+        <p:nvSpPr>
+          <p:cNvPr id="3" name="TextBox 2"/>
+          <p:cNvSpPr txBox="1"/>
+          <p:nvPr/>
+        </p:nvSpPr>
+        <p:spPr>
+          <a:xfrm>
+            <a:off x="548640" y="320040"/>
+            <a:ext cx="11155680" cy="822960"/>
+          </a:xfrm>
+          <a:prstGeom prst="rect">
+            <a:avLst/>
+          </a:prstGeom>
+          <a:noFill/>
+        </p:spPr>
+        <p:txBody>
+          <a:bodyPr wrap="square">
+            <a:spAutoFit/>
+          </a:bodyPr>
+          <a:lstStyle/>
+          <a:p>
+            <a:r>
+              <a:rPr sz="3400" b="1">
+                <a:solidFill>
+                  <a:srgbClr val="12302D"/>
+                </a:solidFill>
+                <a:latin typeface="Calibri"/>
+              </a:rPr>
+              <a:t>Decisions, trade-offs and what I left out</a:t>
+            </a:r>
+          </a:p>
+        </p:txBody>
+      </p:sp>
+      <p:sp>
+        <p:nvSpPr>
+          <p:cNvPr id="4" name="TextBox 3"/>
+          <p:cNvSpPr txBox="1"/>
+          <p:nvPr/>
+        </p:nvSpPr>
+        <p:spPr>
+          <a:xfrm>
+            <a:off x="548640" y="1005840"/>
+            <a:ext cx="11155680" cy="457200"/>
+          </a:xfrm>
+          <a:prstGeom prst="rect">
+            <a:avLst/>
+          </a:prstGeom>
+          <a:noFill/>
+        </p:spPr>
+        <p:txBody>
+          <a:bodyPr wrap="square">
+            <a:spAutoFit/>
+          </a:bodyPr>
+          <a:lstStyle/>
+          <a:p>
+            <a:r>
+              <a:rPr sz="1800">
+                <a:solidFill>
+                  <a:srgbClr val="5B726F"/>
+                </a:solidFill>
+                <a:latin typeface="Calibri"/>
+              </a:rPr>
+              <a:t>Knowing what not to build is part of the job</a:t>
+            </a:r>
+          </a:p>
+        </p:txBody>
+      </p:sp>
+      <p:sp>
+        <p:nvSpPr>
+          <p:cNvPr id="5" name="TextBox 4"/>
+          <p:cNvSpPr txBox="1"/>
+          <p:nvPr/>
+        </p:nvSpPr>
+        <p:spPr>
+          <a:xfrm>
+            <a:off x="548640" y="6446520"/>
+            <a:ext cx="11155680" cy="320040"/>
+          </a:xfrm>
+          <a:prstGeom prst="rect">
+            <a:avLst/>
+          </a:prstGeom>
+          <a:noFill/>
+        </p:spPr>
+        <p:txBody>
+          <a:bodyPr wrap="none">
+            <a:spAutoFit/>
+          </a:bodyPr>
+          <a:lstStyle/>
+          <a:p>
+            <a:r>
+              <a:rPr sz="1100">
+                <a:solidFill>
+                  <a:srgbClr val="5B726F"/>
+                </a:solidFill>
+                <a:latin typeface="Calibri"/>
+              </a:rPr>
+              <a:t>CampusSlot   |   Ujjwal Jain   |   13 / 14</a:t>
+            </a:r>
+          </a:p>
+        </p:txBody>
+      </p:sp>
+      <p:sp>
+        <p:nvSpPr>
+          <p:cNvPr id="6" name="Rounded Rectangle 5"/>
+          <p:cNvSpPr/>
+          <p:nvPr/>
+        </p:nvSpPr>
+        <p:spPr>
+          <a:xfrm>
+            <a:off x="548640" y="1645920"/>
+            <a:ext cx="5394960" cy="868680"/>
+          </a:xfrm>
+          <a:prstGeom prst="roundRect">
+            <a:avLst>
+              <a:gd name="adj" fmla="val 12000"/>
+            </a:avLst>
+          </a:prstGeom>
+          <a:solidFill>
+            <a:srgbClr val="FFFFFF"/>
+          </a:solidFill>
+          <a:ln w="19050">
+            <a:solidFill>
+              <a:srgbClr val="0F766E"/>
+            </a:solidFill>
+          </a:ln>
+        </p:spPr>
+        <p:style>
+          <a:lnRef idx="1">
+            <a:schemeClr val="accent1"/>
+          </a:lnRef>
+          <a:fillRef idx="3">
+            <a:schemeClr val="accent1"/>
+          </a:fillRef>
+          <a:effectRef idx="2">
+            <a:schemeClr val="accent1"/>
+          </a:effectRef>
+          <a:fontRef idx="minor">
+            <a:schemeClr val="lt1"/>
+          </a:fontRef>
+        </p:style>
+        <p:txBody>
+          <a:bodyPr rtlCol="0" anchor="ctr" wrap="square" lIns="73152" rIns="73152"/>
+          <a:lstStyle/>
+          <a:p>
+            <a:pPr algn="ctr"/>
+            <a:r>
+              <a:rPr sz="1600" b="1">
+                <a:solidFill>
+                  <a:srgbClr val="12302D"/>
+                </a:solidFill>
+                <a:latin typeface="Calibri"/>
+              </a:rPr>
+              <a:t>8 s longer per pod in every rollout</a:t>
+            </a:r>
+          </a:p>
+          <a:p>
+            <a:pPr algn="ctr"/>
+            <a:r>
+              <a:rPr sz="1200">
+                <a:solidFill>
+                  <a:srgbClr val="5B726F"/>
+                </a:solidFill>
+                <a:latin typeface="Calibri"/>
+              </a:rPr>
+              <a:t>the price of losing no requests</a:t>
+            </a:r>
+          </a:p>
+        </p:txBody>
+      </p:sp>
+      <p:sp>
+        <p:nvSpPr>
+          <p:cNvPr id="7" name="Rounded Rectangle 6"/>
+          <p:cNvSpPr/>
+          <p:nvPr/>
+        </p:nvSpPr>
+        <p:spPr>
+          <a:xfrm>
+            <a:off x="548640" y="2651760"/>
+            <a:ext cx="5394960" cy="868680"/>
+          </a:xfrm>
+          <a:prstGeom prst="roundRect">
+            <a:avLst>
+              <a:gd name="adj" fmla="val 12000"/>
+            </a:avLst>
+          </a:prstGeom>
+          <a:solidFill>
+            <a:srgbClr val="FFFFFF"/>
+          </a:solidFill>
+          <a:ln w="19050">
+            <a:solidFill>
+              <a:srgbClr val="0F766E"/>
+            </a:solidFill>
+          </a:ln>
+        </p:spPr>
+        <p:style>
+          <a:lnRef idx="1">
+            <a:schemeClr val="accent1"/>
+          </a:lnRef>
+          <a:fillRef idx="3">
+            <a:schemeClr val="accent1"/>
+          </a:fillRef>
+          <a:effectRef idx="2">
+            <a:schemeClr val="accent1"/>
+          </a:effectRef>
+          <a:fontRef idx="minor">
+            <a:schemeClr val="lt1"/>
+          </a:fontRef>
+        </p:style>
+        <p:txBody>
+          <a:bodyPr rtlCol="0" anchor="ctr" wrap="square" lIns="73152" rIns="73152"/>
+          <a:lstStyle/>
+          <a:p>
+            <a:pPr algn="ctr"/>
+            <a:r>
+              <a:rPr sz="1600" b="1">
+                <a:solidFill>
+                  <a:srgbClr val="12302D"/>
+                </a:solidFill>
+                <a:latin typeface="Calibri"/>
+              </a:rPr>
+              <a:t>About 59 s longer per pipeline run</a:t>
+            </a:r>
+          </a:p>
+          <a:p>
+            <a:pPr algn="ctr"/>
+            <a:r>
+              <a:rPr sz="1200">
+                <a:solidFill>
+                  <a:srgbClr val="5B726F"/>
+                </a:solidFill>
+                <a:latin typeface="Calibri"/>
+              </a:rPr>
+              <a:t>the price of signed, verified images (one pair of runs)</a:t>
+            </a:r>
+          </a:p>
+        </p:txBody>
+      </p:sp>
+      <p:sp>
+        <p:nvSpPr>
+          <p:cNvPr id="8" name="Rounded Rectangle 7"/>
+          <p:cNvSpPr/>
+          <p:nvPr/>
+        </p:nvSpPr>
+        <p:spPr>
+          <a:xfrm>
+            <a:off x="548640" y="3657600"/>
+            <a:ext cx="5394960" cy="868680"/>
+          </a:xfrm>
+          <a:prstGeom prst="roundRect">
+            <a:avLst>
+              <a:gd name="adj" fmla="val 12000"/>
+            </a:avLst>
+          </a:prstGeom>
+          <a:solidFill>
+            <a:srgbClr val="FFFFFF"/>
+          </a:solidFill>
+          <a:ln w="19050">
+            <a:solidFill>
+              <a:srgbClr val="0F766E"/>
+            </a:solidFill>
+          </a:ln>
+        </p:spPr>
+        <p:style>
+          <a:lnRef idx="1">
+            <a:schemeClr val="accent1"/>
+          </a:lnRef>
+          <a:fillRef idx="3">
+            <a:schemeClr val="accent1"/>
+          </a:fillRef>
+          <a:effectRef idx="2">
+            <a:schemeClr val="accent1"/>
+          </a:effectRef>
+          <a:fontRef idx="minor">
+            <a:schemeClr val="lt1"/>
+          </a:fontRef>
+        </p:style>
+        <p:txBody>
+          <a:bodyPr rtlCol="0" anchor="ctr" wrap="square" lIns="73152" rIns="73152"/>
+          <a:lstStyle/>
+          <a:p>
+            <a:pPr algn="ctr"/>
+            <a:r>
+              <a:rPr sz="1600" b="1">
+                <a:solidFill>
+                  <a:srgbClr val="12302D"/>
+                </a:solidFill>
+                <a:latin typeface="Calibri"/>
+              </a:rPr>
+              <a:t>Backup stays in the same cluster</a:t>
+            </a:r>
+          </a:p>
+          <a:p>
+            <a:pPr algn="ctr"/>
+            <a:r>
+              <a:rPr sz="1200">
+                <a:solidFill>
+                  <a:srgbClr val="5B726F"/>
+                </a:solidFill>
+                <a:latin typeface="Calibri"/>
+              </a:rPr>
+              <a:t>covers mistakes, not the loss of the cluster</a:t>
+            </a:r>
+          </a:p>
+        </p:txBody>
+      </p:sp>
+      <p:sp>
+        <p:nvSpPr>
+          <p:cNvPr id="9" name="Rounded Rectangle 8"/>
+          <p:cNvSpPr/>
+          <p:nvPr/>
+        </p:nvSpPr>
+        <p:spPr>
+          <a:xfrm>
+            <a:off x="548640" y="4663440"/>
+            <a:ext cx="5394960" cy="868680"/>
+          </a:xfrm>
+          <a:prstGeom prst="roundRect">
+            <a:avLst>
+              <a:gd name="adj" fmla="val 12000"/>
+            </a:avLst>
+          </a:prstGeom>
+          <a:solidFill>
+            <a:srgbClr val="FFFFFF"/>
+          </a:solidFill>
+          <a:ln w="19050">
+            <a:solidFill>
+              <a:srgbClr val="0F766E"/>
+            </a:solidFill>
+          </a:ln>
+        </p:spPr>
+        <p:style>
+          <a:lnRef idx="1">
+            <a:schemeClr val="accent1"/>
+          </a:lnRef>
+          <a:fillRef idx="3">
+            <a:schemeClr val="accent1"/>
+          </a:fillRef>
+          <a:effectRef idx="2">
+            <a:schemeClr val="accent1"/>
+          </a:effectRef>
+          <a:fontRef idx="minor">
+            <a:schemeClr val="lt1"/>
+          </a:fontRef>
+        </p:style>
+        <p:txBody>
+          <a:bodyPr rtlCol="0" anchor="ctr" wrap="square" lIns="73152" rIns="73152"/>
+          <a:lstStyle/>
+          <a:p>
+            <a:pPr algn="ctr"/>
+            <a:r>
+              <a:rPr sz="1600" b="1">
+                <a:solidFill>
+                  <a:srgbClr val="12302D"/>
+                </a:solidFill>
+                <a:latin typeface="Calibri"/>
+              </a:rPr>
+              <a:t>One database pod</a:t>
+            </a:r>
+          </a:p>
+          <a:p>
+            <a:pPr algn="ctr"/>
+            <a:r>
+              <a:rPr sz="1200">
+                <a:solidFill>
+                  <a:srgbClr val="5B726F"/>
+                </a:solidFill>
+                <a:latin typeface="Calibri"/>
+              </a:rPr>
+              <a:t>a 6 s outage remains, now visible to the alerts</a:t>
+            </a:r>
+          </a:p>
+        </p:txBody>
+      </p:sp>
+      <p:sp>
+        <p:nvSpPr>
+          <p:cNvPr id="10" name="TextBox 9"/>
+          <p:cNvSpPr txBox="1"/>
+          <p:nvPr/>
+        </p:nvSpPr>
+        <p:spPr>
+          <a:xfrm>
+            <a:off x="6309360" y="1554480"/>
+            <a:ext cx="5577840" cy="4206240"/>
+          </a:xfrm>
+          <a:prstGeom prst="rect">
+            <a:avLst/>
+          </a:prstGeom>
+          <a:noFill/>
+        </p:spPr>
+        <p:txBody>
+          <a:bodyPr wrap="square">
+            <a:spAutoFit/>
+          </a:bodyPr>
+          <a:lstStyle/>
+          <a:p>
+            <a:pPr>
+              <a:spcAft>
+                <a:spcPts val="800"/>
+              </a:spcAft>
+            </a:pPr>
+            <a:r>
+              <a:rPr sz="1800" b="1">
+                <a:solidFill>
+                  <a:srgbClr val="12302D"/>
+                </a:solidFill>
+                <a:latin typeface="Calibri"/>
+              </a:rPr>
+              <a:t>•  Not done, on purpose</a:t>
+            </a:r>
+          </a:p>
+          <a:p>
+            <a:pPr>
+              <a:spcAft>
+                <a:spcPts val="800"/>
+              </a:spcAft>
+            </a:pPr>
+            <a:r>
+              <a:rPr sz="1800" b="0">
+                <a:solidFill>
+                  <a:srgbClr val="12302D"/>
+                </a:solidFill>
+                <a:latin typeface="Calibri"/>
+              </a:rPr>
+              <a:t>•  Load test and tuning</a:t>
+            </a:r>
+          </a:p>
+          <a:p>
+            <a:pPr>
+              <a:spcAft>
+                <a:spcPts val="800"/>
+              </a:spcAft>
+            </a:pPr>
+            <a:r>
+              <a:rPr sz="1800" b="0">
+                <a:solidFill>
+                  <a:srgbClr val="12302D"/>
+                </a:solidFill>
+                <a:latin typeface="Calibri"/>
+              </a:rPr>
+              <a:t>•  200 thousand row query plans</a:t>
+            </a:r>
+          </a:p>
+          <a:p>
+            <a:pPr>
+              <a:spcAft>
+                <a:spcPts val="800"/>
+              </a:spcAft>
+            </a:pPr>
+            <a:r>
+              <a:rPr sz="1800" b="0">
+                <a:solidFill>
+                  <a:srgbClr val="12302D"/>
+                </a:solidFill>
+                <a:latin typeface="Calibri"/>
+              </a:rPr>
+              <a:t>•  Right-sizing from measured usage</a:t>
+            </a:r>
+          </a:p>
+          <a:p>
+            <a:pPr>
+              <a:spcAft>
+                <a:spcPts val="800"/>
+              </a:spcAft>
+            </a:pPr>
+            <a:r>
+              <a:rPr sz="1800" b="0">
+                <a:solidFill>
+                  <a:srgbClr val="12302D"/>
+                </a:solidFill>
+                <a:latin typeface="Calibri"/>
+              </a:rPr>
+              <a:t>•  Rollback drill</a:t>
+            </a:r>
+          </a:p>
+          <a:p>
+            <a:pPr>
+              <a:spcAft>
+                <a:spcPts val="800"/>
+              </a:spcAft>
+            </a:pPr>
+            <a:r>
+              <a:rPr sz="1800" b="0">
+                <a:solidFill>
+                  <a:srgbClr val="12302D"/>
+                </a:solidFill>
+                <a:latin typeface="Calibri"/>
+              </a:rPr>
+              <a:t>•  Automated promotion</a:t>
+            </a:r>
+          </a:p>
+          <a:p>
+            <a:pPr>
+              <a:spcAft>
+                <a:spcPts val="800"/>
+              </a:spcAft>
+            </a:pPr>
+            <a:r>
+              <a:rPr sz="1800" b="0">
+                <a:solidFill>
+                  <a:srgbClr val="12302D"/>
+                </a:solidFill>
+                <a:latin typeface="Calibri"/>
+              </a:rPr>
+              <a:t>•  Network policies</a:t>
+            </a:r>
+          </a:p>
+          <a:p>
+            <a:pPr>
+              <a:spcAft>
+                <a:spcPts val="800"/>
+              </a:spcAft>
+            </a:pPr>
+            <a:r>
+              <a:rPr sz="1800" b="0">
+                <a:solidFill>
+                  <a:srgbClr val="12302D"/>
+                </a:solidFill>
+                <a:latin typeface="Calibri"/>
+              </a:rPr>
+              <a:t>•  Alert delivery (no Alertmanager)</a:t>
+            </a:r>
+          </a:p>
+        </p:txBody>
+      </p:sp>
+      <p:sp>
+        <p:nvSpPr>
+          <p:cNvPr id="11" name="TextBox 10"/>
+          <p:cNvSpPr txBox="1"/>
+          <p:nvPr/>
+        </p:nvSpPr>
+        <p:spPr>
+          <a:xfrm>
+            <a:off x="548640" y="5760720"/>
+            <a:ext cx="11155680" cy="548640"/>
+          </a:xfrm>
+          <a:prstGeom prst="rect">
+            <a:avLst/>
+          </a:prstGeom>
+          <a:noFill/>
+        </p:spPr>
+        <p:txBody>
+          <a:bodyPr wrap="square">
+            <a:spAutoFit/>
+          </a:bodyPr>
+          <a:lstStyle/>
+          <a:p>
+            <a:pPr>
+              <a:spcAft>
+                <a:spcPts val="600"/>
+              </a:spcAft>
+            </a:pPr>
+            <a:r>
+              <a:rPr sz="1400" b="0">
+                <a:solidFill>
+                  <a:srgbClr val="5B726F"/>
+                </a:solidFill>
+                <a:latin typeface="Calibri"/>
+              </a:rPr>
+              <a:t>12 decision records in docs/adr explain the choices and what I would do in production.</a:t>
+            </a:r>
+          </a:p>
+        </p:txBody>
+      </p:sp>
+    </p:spTree>
+  </p:cSld>
+  <p:clrMapOvr>
+    <a:masterClrMapping/>
+  </p:clrMapOvr>
+</p:sld>
+</file>
+
+<file path=ppt/slides/slide14.xml><?xml version="1.0" encoding="utf-8"?>
+<p:sld xmlns:a="http://schemas.openxmlformats.org/drawingml/2006/main" xmlns:p="http://schemas.openxmlformats.org/presentationml/2006/main" xmlns:r="http://schemas.openxmlformats.org/officeDocument/2006/relationships">
+  <p:cSld>
+    <p:bg>
+      <p:bgPr>
+        <a:solidFill>
+          <a:srgbClr val="F4F7F6"/>
+        </a:solidFill>
+        <a:effectLst/>
+      </p:bgPr>
+    </p:bg>
+    <p:spTree>
+      <p:nvGrpSpPr>
+        <p:cNvPr id="1" name=""/>
+        <p:cNvGrpSpPr/>
+        <p:nvPr/>
+      </p:nvGrpSpPr>
+      <p:grpSpPr/>
+      <p:sp>
+        <p:nvSpPr>
+          <p:cNvPr id="2" name="Rectangle 1"/>
+          <p:cNvSpPr/>
+          <p:nvPr/>
+        </p:nvSpPr>
+        <p:spPr>
+          <a:xfrm>
+            <a:off x="0" y="0"/>
+            <a:ext cx="228600" cy="6858000"/>
+          </a:xfrm>
+          <a:prstGeom prst="rect">
+            <a:avLst/>
+          </a:prstGeom>
+          <a:solidFill>
+            <a:srgbClr val="0F766E"/>
+          </a:solidFill>
+          <a:ln>
+            <a:noFill/>
+          </a:ln>
+        </p:spPr>
+        <p:style>
+          <a:lnRef idx="1">
+            <a:schemeClr val="accent1"/>
+          </a:lnRef>
+          <a:fillRef idx="3">
+            <a:schemeClr val="accent1"/>
+          </a:fillRef>
+          <a:effectRef idx="2">
+            <a:schemeClr val="accent1"/>
+          </a:effectRef>
+          <a:fontRef idx="minor">
+            <a:schemeClr val="lt1"/>
+          </a:fontRef>
+        </p:style>
+        <p:txBody>
+          <a:bodyPr rtlCol="0" anchor="ctr"/>
+          <a:lstStyle/>
+          <a:p>
+            <a:pPr algn="ctr"/>
+          </a:p>
+        </p:txBody>
+      </p:sp>
+      <p:sp>
+        <p:nvSpPr>
+          <p:cNvPr id="3" name="TextBox 2"/>
+          <p:cNvSpPr txBox="1"/>
+          <p:nvPr/>
+        </p:nvSpPr>
+        <p:spPr>
+          <a:xfrm>
+            <a:off x="548640" y="320040"/>
+            <a:ext cx="11155680" cy="822960"/>
+          </a:xfrm>
+          <a:prstGeom prst="rect">
+            <a:avLst/>
+          </a:prstGeom>
+          <a:noFill/>
+        </p:spPr>
+        <p:txBody>
+          <a:bodyPr wrap="square">
+            <a:spAutoFit/>
+          </a:bodyPr>
+          <a:lstStyle/>
+          <a:p>
+            <a:r>
+              <a:rPr sz="3400" b="1">
+                <a:solidFill>
+                  <a:srgbClr val="12302D"/>
+                </a:solidFill>
+                <a:latin typeface="Calibri"/>
+              </a:rPr>
+              <a:t>From a change to a running system</a:t>
+            </a:r>
+          </a:p>
+        </p:txBody>
+      </p:sp>
+      <p:sp>
+        <p:nvSpPr>
+          <p:cNvPr id="4" name="TextBox 3"/>
+          <p:cNvSpPr txBox="1"/>
+          <p:nvPr/>
+        </p:nvSpPr>
+        <p:spPr>
+          <a:xfrm>
+            <a:off x="548640" y="1005840"/>
+            <a:ext cx="11155680" cy="457200"/>
+          </a:xfrm>
+          <a:prstGeom prst="rect">
+            <a:avLst/>
+          </a:prstGeom>
+          <a:noFill/>
+        </p:spPr>
+        <p:txBody>
+          <a:bodyPr wrap="square">
+            <a:spAutoFit/>
+          </a:bodyPr>
+          <a:lstStyle/>
+          <a:p>
+            <a:r>
+              <a:rPr sz="1800">
+                <a:solidFill>
+                  <a:srgbClr val="5B726F"/>
+                </a:solidFill>
+                <a:latin typeface="Calibri"/>
+              </a:rPr>
+              <a:t>I rehearsed the whole loop, and here is what I learned</a:t>
+            </a:r>
+          </a:p>
+        </p:txBody>
+      </p:sp>
+      <p:sp>
+        <p:nvSpPr>
+          <p:cNvPr id="5" name="TextBox 4"/>
+          <p:cNvSpPr txBox="1"/>
+          <p:nvPr/>
+        </p:nvSpPr>
+        <p:spPr>
+          <a:xfrm>
+            <a:off x="548640" y="6446520"/>
+            <a:ext cx="11155680" cy="320040"/>
+          </a:xfrm>
+          <a:prstGeom prst="rect">
+            <a:avLst/>
+          </a:prstGeom>
+          <a:noFill/>
+        </p:spPr>
+        <p:txBody>
+          <a:bodyPr wrap="none">
+            <a:spAutoFit/>
+          </a:bodyPr>
+          <a:lstStyle/>
+          <a:p>
+            <a:r>
+              <a:rPr sz="1100">
+                <a:solidFill>
+                  <a:srgbClr val="5B726F"/>
+                </a:solidFill>
+                <a:latin typeface="Calibri"/>
+              </a:rPr>
+              <a:t>CampusSlot   |   Ujjwal Jain   |   14 / 14</a:t>
             </a:r>
           </a:p>
         </p:txBody>
@@ -6899,7 +8403,7 @@
                 </a:solidFill>
                 <a:latin typeface="Calibri"/>
               </a:rPr>
-              <a:t>CampusSlot   |   Ujjwal Jain   |   2 / 12</a:t>
+              <a:t>CampusSlot   |   Ujjwal Jain   |   2 / 14</a:t>
             </a:r>
           </a:p>
         </p:txBody>
@@ -8234,7 +9738,7 @@
                 </a:solidFill>
                 <a:latin typeface="Calibri"/>
               </a:rPr>
-              <a:t>CampusSlot   |   Ujjwal Jain   |   3 / 12</a:t>
+              <a:t>CampusSlot   |   Ujjwal Jain   |   3 / 14</a:t>
             </a:r>
           </a:p>
         </p:txBody>
@@ -8649,7 +10153,7 @@
                 </a:solidFill>
                 <a:latin typeface="Calibri"/>
               </a:rPr>
-              <a:t>58 meaningful commits, each one a small step that can be explained</a:t>
+              <a:t>71 meaningful commits, each one a small step that can be explained</a:t>
             </a:r>
           </a:p>
         </p:txBody>
@@ -8683,7 +10187,7 @@
                 </a:solidFill>
                 <a:latin typeface="Calibri"/>
               </a:rPr>
-              <a:t>CampusSlot   |   Ujjwal Jain   |   4 / 12</a:t>
+              <a:t>CampusSlot   |   Ujjwal Jain   |   4 / 14</a:t>
             </a:r>
           </a:p>
         </p:txBody>
@@ -9105,7 +10609,7 @@
                 </a:solidFill>
                 <a:latin typeface="Calibri"/>
               </a:rPr>
-              <a:t>CampusSlot   |   Ujjwal Jain   |   5 / 12</a:t>
+              <a:t>CampusSlot   |   Ujjwal Jain   |   5 / 14</a:t>
             </a:r>
           </a:p>
         </p:txBody>
@@ -9551,7 +11055,7 @@
                 </a:solidFill>
                 <a:latin typeface="Calibri"/>
               </a:rPr>
-              <a:t>CampusSlot   |   Ujjwal Jain   |   6 / 12</a:t>
+              <a:t>CampusSlot   |   Ujjwal Jain   |   6 / 14</a:t>
             </a:r>
           </a:p>
         </p:txBody>
@@ -10154,7 +11658,7 @@
                 </a:solidFill>
                 <a:latin typeface="Calibri"/>
               </a:rPr>
-              <a:t>CampusSlot   |   Ujjwal Jain   |   7 / 12</a:t>
+              <a:t>CampusSlot   |   Ujjwal Jain   |   7 / 14</a:t>
             </a:r>
           </a:p>
         </p:txBody>
@@ -10648,7 +12152,7 @@
                 </a:solidFill>
                 <a:latin typeface="Calibri"/>
               </a:rPr>
-              <a:t>CampusSlot   |   Ujjwal Jain   |   8 / 12</a:t>
+              <a:t>CampusSlot   |   Ujjwal Jain   |   8 / 14</a:t>
             </a:r>
           </a:p>
         </p:txBody>
@@ -11210,7 +12714,7 @@
                 </a:solidFill>
                 <a:latin typeface="Calibri"/>
               </a:rPr>
-              <a:t>CampusSlot   |   Ujjwal Jain   |   9 / 12</a:t>
+              <a:t>CampusSlot   |   Ujjwal Jain   |   9 / 14</a:t>
             </a:r>
           </a:p>
         </p:txBody>

</xml_diff>

<commit_message>
README section on engineering decisions and results, two new slides (#7)
* Add the engineering decisions and results section to the README and two slides to the deck

* Fix the slide description in the README
</commit_message>
<xml_diff>
--- a/docs/presentation/CampusSlot-final-presentation.pptx
+++ b/docs/presentation/CampusSlot-final-presentation.pptx
@@ -17,6 +17,8 @@
     <p:sldId id="265" r:id="rId17"/>
     <p:sldId id="266" r:id="rId18"/>
     <p:sldId id="267" r:id="rId19"/>
+    <p:sldId id="268" r:id="rId20"/>
+    <p:sldId id="269" r:id="rId21"/>
   </p:sldIdLst>
   <p:sldSz cx="12191695" cy="6858000" type="screen4x3"/>
   <p:notesSz cx="6858000" cy="9144000"/>
@@ -679,6 +681,146 @@
 </file>
 
 <file path=ppt/notesSlides/notesSlide12.xml><?xml version="1.0" encoding="utf-8"?>
+<p:notes xmlns:a="http://schemas.openxmlformats.org/drawingml/2006/main" xmlns:p="http://schemas.openxmlformats.org/presentationml/2006/main" xmlns:r="http://schemas.openxmlformats.org/officeDocument/2006/relationships">
+  <p:cSld>
+    <p:spTree>
+      <p:nvGrpSpPr>
+        <p:cNvPr id="1" name=""/>
+        <p:cNvGrpSpPr/>
+        <p:nvPr/>
+      </p:nvGrpSpPr>
+      <p:grpSpPr>
+        <a:xfrm>
+          <a:off x="0" y="0"/>
+          <a:ext cx="0" cy="0"/>
+          <a:chOff x="0" y="0"/>
+          <a:chExt cx="0" cy="0"/>
+        </a:xfrm>
+      </p:grpSpPr>
+      <p:sp>
+        <p:nvSpPr>
+          <p:cNvPr id="2" name="Slide Image Placeholder 1"/>
+          <p:cNvSpPr>
+            <a:spLocks noGrp="1"/>
+          </p:cNvSpPr>
+          <p:nvPr>
+            <p:ph type="sldImg" idx="2"/>
+          </p:nvPr>
+        </p:nvSpPr>
+        <p:spPr/>
+      </p:sp>
+      <p:sp>
+        <p:nvSpPr>
+          <p:cNvPr id="3" name="Notes Placeholder 2"/>
+          <p:cNvSpPr>
+            <a:spLocks noGrp="1"/>
+          </p:cNvSpPr>
+          <p:nvPr>
+            <p:ph type="body" idx="3" sz="quarter"/>
+          </p:nvPr>
+        </p:nvSpPr>
+        <p:spPr/>
+        <p:txBody>
+          <a:bodyPr/>
+          <a:lstStyle/>
+          <a:p>
+            <a:r>
+              <a:t>Meeting a checklist is the minimum. What I wanted to show is the habit behind it: measure, find the weak point, change one thing, measure again, and write down what it cost. The chart allowed no unavailable replicas during a rollout, but when I measured it, every rollout lost one or two requests. An eight second delay before a pod stops fixed that in six out of six repeats. When I killed the database, users got eighteen errors but Prometheus counted none, so my own alerts were blind to a database outage. I made the application answer with a handled error, and now all of them are counted. I also made an alert fire on purpose and resolve, and I restored a deleted table from a backup and compared a checksum. The numbers come from small samples on one laptop, and the documents say so.</a:t>
+            </a:r>
+          </a:p>
+        </p:txBody>
+      </p:sp>
+      <p:sp>
+        <p:nvSpPr>
+          <p:cNvPr id="4" name="Slide Number Placeholder 3"/>
+          <p:cNvSpPr>
+            <a:spLocks noGrp="1"/>
+          </p:cNvSpPr>
+          <p:nvPr>
+            <p:ph type="sldNum" idx="5" sz="quarter"/>
+          </p:nvPr>
+        </p:nvSpPr>
+        <p:spPr/>
+      </p:sp>
+    </p:spTree>
+  </p:cSld>
+  <p:clrMapOvr>
+    <a:masterClrMapping/>
+  </p:clrMapOvr>
+</p:notes>
+</file>
+
+<file path=ppt/notesSlides/notesSlide13.xml><?xml version="1.0" encoding="utf-8"?>
+<p:notes xmlns:a="http://schemas.openxmlformats.org/drawingml/2006/main" xmlns:p="http://schemas.openxmlformats.org/presentationml/2006/main" xmlns:r="http://schemas.openxmlformats.org/officeDocument/2006/relationships">
+  <p:cSld>
+    <p:spTree>
+      <p:nvGrpSpPr>
+        <p:cNvPr id="1" name=""/>
+        <p:cNvGrpSpPr/>
+        <p:nvPr/>
+      </p:nvGrpSpPr>
+      <p:grpSpPr>
+        <a:xfrm>
+          <a:off x="0" y="0"/>
+          <a:ext cx="0" cy="0"/>
+          <a:chOff x="0" y="0"/>
+          <a:chExt cx="0" cy="0"/>
+        </a:xfrm>
+      </p:grpSpPr>
+      <p:sp>
+        <p:nvSpPr>
+          <p:cNvPr id="2" name="Slide Image Placeholder 1"/>
+          <p:cNvSpPr>
+            <a:spLocks noGrp="1"/>
+          </p:cNvSpPr>
+          <p:nvPr>
+            <p:ph type="sldImg" idx="2"/>
+          </p:nvPr>
+        </p:nvSpPr>
+        <p:spPr/>
+      </p:sp>
+      <p:sp>
+        <p:nvSpPr>
+          <p:cNvPr id="3" name="Notes Placeholder 2"/>
+          <p:cNvSpPr>
+            <a:spLocks noGrp="1"/>
+          </p:cNvSpPr>
+          <p:nvPr>
+            <p:ph type="body" idx="3" sz="quarter"/>
+          </p:nvPr>
+        </p:nvSpPr>
+        <p:spPr/>
+        <p:txBody>
+          <a:bodyPr/>
+          <a:lstStyle/>
+          <a:p>
+            <a:r>
+              <a:t>Every change costs something, and I wrote the cost down. Waiting eight seconds before a pod stops makes every rollout slower. Signing and verifying the images adds about a minute to every pipeline run, from one pair of runs. The backup stays inside the cluster, so it protects against mistakes but not against losing the cluster. There is one database pod, so an outage of about six seconds remains, and I only made it visible. On the right is what I planned and chose not to do, so nobody has to guess. Twelve short decision records explain the reasons for the main choices, with what I would do in production.</a:t>
+            </a:r>
+          </a:p>
+        </p:txBody>
+      </p:sp>
+      <p:sp>
+        <p:nvSpPr>
+          <p:cNvPr id="4" name="Slide Number Placeholder 3"/>
+          <p:cNvSpPr>
+            <a:spLocks noGrp="1"/>
+          </p:cNvSpPr>
+          <p:nvPr>
+            <p:ph type="sldNum" idx="5" sz="quarter"/>
+          </p:nvPr>
+        </p:nvSpPr>
+        <p:spPr/>
+      </p:sp>
+    </p:spTree>
+  </p:cSld>
+  <p:clrMapOvr>
+    <a:masterClrMapping/>
+  </p:clrMapOvr>
+</p:notes>
+</file>
+
+<file path=ppt/notesSlides/notesSlide14.xml><?xml version="1.0" encoding="utf-8"?>
 <p:notes xmlns:a="http://schemas.openxmlformats.org/drawingml/2006/main" xmlns:p="http://schemas.openxmlformats.org/presentationml/2006/main" xmlns:r="http://schemas.openxmlformats.org/officeDocument/2006/relationships">
   <p:cSld>
     <p:spTree>
@@ -4437,7 +4579,7 @@
                 </a:solidFill>
                 <a:latin typeface="Calibri"/>
               </a:rPr>
-              <a:t>CampusSlot   |   Ujjwal Jain   |   1 / 12</a:t>
+              <a:t>CampusSlot   |   Ujjwal Jain   |   1 / 14</a:t>
             </a:r>
           </a:p>
         </p:txBody>
@@ -4779,7 +4921,7 @@
                 </a:solidFill>
                 <a:latin typeface="Calibri"/>
               </a:rPr>
-              <a:t>CampusSlot   |   Ujjwal Jain   |   10 / 12</a:t>
+              <a:t>CampusSlot   |   Ujjwal Jain   |   10 / 14</a:t>
             </a:r>
           </a:p>
         </p:txBody>
@@ -5225,7 +5367,7 @@
                 </a:solidFill>
                 <a:latin typeface="Calibri"/>
               </a:rPr>
-              <a:t>CampusSlot   |   Ujjwal Jain   |   11 / 12</a:t>
+              <a:t>CampusSlot   |   Ujjwal Jain   |   11 / 14</a:t>
             </a:r>
           </a:p>
         </p:txBody>
@@ -5762,7 +5904,7 @@
                 </a:solidFill>
                 <a:latin typeface="Calibri"/>
               </a:rPr>
-              <a:t>From a change to a running system</a:t>
+              <a:t>Measure, change one thing, measure again</a:t>
             </a:r>
           </a:p>
         </p:txBody>
@@ -5796,7 +5938,7 @@
                 </a:solidFill>
                 <a:latin typeface="Calibri"/>
               </a:rPr>
-              <a:t>I rehearsed the whole loop, and here is what I learned</a:t>
+              <a:t>Every improvement has a number from before and a number from after</a:t>
             </a:r>
           </a:p>
         </p:txBody>
@@ -5830,7 +5972,1369 @@
                 </a:solidFill>
                 <a:latin typeface="Calibri"/>
               </a:rPr>
-              <a:t>CampusSlot   |   Ujjwal Jain   |   12 / 12</a:t>
+              <a:t>CampusSlot   |   Ujjwal Jain   |   12 / 14</a:t>
+            </a:r>
+          </a:p>
+        </p:txBody>
+      </p:sp>
+      <p:graphicFrame>
+        <p:nvGraphicFramePr>
+          <p:cNvPr id="6" name="Table 5"/>
+          <p:cNvGraphicFramePr>
+            <a:graphicFrameLocks noGrp="1"/>
+          </p:cNvGraphicFramePr>
+          <p:nvPr/>
+        </p:nvGraphicFramePr>
+        <p:xfrm>
+          <a:off x="548640" y="1645920"/>
+          <a:ext cx="6949440" cy="2194560"/>
+        </p:xfrm>
+        <a:graphic>
+          <a:graphicData uri="http://schemas.openxmlformats.org/drawingml/2006/table">
+            <a:tbl>
+              <a:tblPr firstRow="1" bandRow="1">
+                <a:tableStyleId>{5C22544A-7EE6-4342-B048-85BDC9FD1C3A}</a:tableStyleId>
+              </a:tblPr>
+              <a:tblGrid>
+                <a:gridCol w="3291840"/>
+                <a:gridCol w="2011680"/>
+                <a:gridCol w="1645920"/>
+              </a:tblGrid>
+              <a:tr h="365760">
+                <a:tc>
+                  <a:txBody>
+                    <a:bodyPr/>
+                    <a:lstStyle/>
+                    <a:p>
+                      <a:r>
+                        <a:rPr sz="1500" b="1">
+                          <a:solidFill>
+                            <a:srgbClr val="FFFFFF"/>
+                          </a:solidFill>
+                          <a:latin typeface="Calibri"/>
+                        </a:rPr>
+                        <a:t>What I measured</a:t>
+                      </a:r>
+                    </a:p>
+                  </a:txBody>
+                  <a:tcPr marL="73152" marR="73152">
+                    <a:solidFill>
+                      <a:srgbClr val="0F766E"/>
+                    </a:solidFill>
+                  </a:tcPr>
+                </a:tc>
+                <a:tc>
+                  <a:txBody>
+                    <a:bodyPr/>
+                    <a:lstStyle/>
+                    <a:p>
+                      <a:r>
+                        <a:rPr sz="1500" b="1">
+                          <a:solidFill>
+                            <a:srgbClr val="FFFFFF"/>
+                          </a:solidFill>
+                          <a:latin typeface="Calibri"/>
+                        </a:rPr>
+                        <a:t>Before</a:t>
+                      </a:r>
+                    </a:p>
+                  </a:txBody>
+                  <a:tcPr marL="73152" marR="73152">
+                    <a:solidFill>
+                      <a:srgbClr val="0F766E"/>
+                    </a:solidFill>
+                  </a:tcPr>
+                </a:tc>
+                <a:tc>
+                  <a:txBody>
+                    <a:bodyPr/>
+                    <a:lstStyle/>
+                    <a:p>
+                      <a:r>
+                        <a:rPr sz="1500" b="1">
+                          <a:solidFill>
+                            <a:srgbClr val="FFFFFF"/>
+                          </a:solidFill>
+                          <a:latin typeface="Calibri"/>
+                        </a:rPr>
+                        <a:t>After</a:t>
+                      </a:r>
+                    </a:p>
+                  </a:txBody>
+                  <a:tcPr marL="73152" marR="73152">
+                    <a:solidFill>
+                      <a:srgbClr val="0F766E"/>
+                    </a:solidFill>
+                  </a:tcPr>
+                </a:tc>
+              </a:tr>
+              <a:tr h="365760">
+                <a:tc>
+                  <a:txBody>
+                    <a:bodyPr/>
+                    <a:lstStyle/>
+                    <a:p>
+                      <a:r>
+                        <a:rPr sz="1500">
+                          <a:solidFill>
+                            <a:srgbClr val="12302D"/>
+                          </a:solidFill>
+                          <a:latin typeface="Calibri"/>
+                        </a:rPr>
+                        <a:t>Lost requests in a rollout</a:t>
+                      </a:r>
+                    </a:p>
+                  </a:txBody>
+                  <a:tcPr marL="73152" marR="73152">
+                    <a:solidFill>
+                      <a:srgbClr val="FFFFFF"/>
+                    </a:solidFill>
+                  </a:tcPr>
+                </a:tc>
+                <a:tc>
+                  <a:txBody>
+                    <a:bodyPr/>
+                    <a:lstStyle/>
+                    <a:p>
+                      <a:r>
+                        <a:rPr sz="1500">
+                          <a:solidFill>
+                            <a:srgbClr val="12302D"/>
+                          </a:solidFill>
+                          <a:latin typeface="Calibri"/>
+                        </a:rPr>
+                        <a:t>8 of 8 rollouts</a:t>
+                      </a:r>
+                    </a:p>
+                  </a:txBody>
+                  <a:tcPr marL="73152" marR="73152">
+                    <a:solidFill>
+                      <a:srgbClr val="FFFFFF"/>
+                    </a:solidFill>
+                  </a:tcPr>
+                </a:tc>
+                <a:tc>
+                  <a:txBody>
+                    <a:bodyPr/>
+                    <a:lstStyle/>
+                    <a:p>
+                      <a:r>
+                        <a:rPr sz="1500">
+                          <a:solidFill>
+                            <a:srgbClr val="12302D"/>
+                          </a:solidFill>
+                          <a:latin typeface="Calibri"/>
+                        </a:rPr>
+                        <a:t>0 of 6</a:t>
+                      </a:r>
+                    </a:p>
+                  </a:txBody>
+                  <a:tcPr marL="73152" marR="73152">
+                    <a:solidFill>
+                      <a:srgbClr val="FFFFFF"/>
+                    </a:solidFill>
+                  </a:tcPr>
+                </a:tc>
+              </a:tr>
+              <a:tr h="365760">
+                <a:tc>
+                  <a:txBody>
+                    <a:bodyPr/>
+                    <a:lstStyle/>
+                    <a:p>
+                      <a:r>
+                        <a:rPr sz="1500">
+                          <a:solidFill>
+                            <a:srgbClr val="12302D"/>
+                          </a:solidFill>
+                          <a:latin typeface="Calibri"/>
+                        </a:rPr>
+                        <a:t>Database errors seen by alerts</a:t>
+                      </a:r>
+                    </a:p>
+                  </a:txBody>
+                  <a:tcPr marL="73152" marR="73152">
+                    <a:solidFill>
+                      <a:srgbClr val="D7ECE9"/>
+                    </a:solidFill>
+                  </a:tcPr>
+                </a:tc>
+                <a:tc>
+                  <a:txBody>
+                    <a:bodyPr/>
+                    <a:lstStyle/>
+                    <a:p>
+                      <a:r>
+                        <a:rPr sz="1500">
+                          <a:solidFill>
+                            <a:srgbClr val="12302D"/>
+                          </a:solidFill>
+                          <a:latin typeface="Calibri"/>
+                        </a:rPr>
+                        <a:t>0 of 18</a:t>
+                      </a:r>
+                    </a:p>
+                  </a:txBody>
+                  <a:tcPr marL="73152" marR="73152">
+                    <a:solidFill>
+                      <a:srgbClr val="D7ECE9"/>
+                    </a:solidFill>
+                  </a:tcPr>
+                </a:tc>
+                <a:tc>
+                  <a:txBody>
+                    <a:bodyPr/>
+                    <a:lstStyle/>
+                    <a:p>
+                      <a:r>
+                        <a:rPr sz="1500">
+                          <a:solidFill>
+                            <a:srgbClr val="12302D"/>
+                          </a:solidFill>
+                          <a:latin typeface="Calibri"/>
+                        </a:rPr>
+                        <a:t>16 of 16</a:t>
+                      </a:r>
+                    </a:p>
+                  </a:txBody>
+                  <a:tcPr marL="73152" marR="73152">
+                    <a:solidFill>
+                      <a:srgbClr val="D7ECE9"/>
+                    </a:solidFill>
+                  </a:tcPr>
+                </a:tc>
+              </a:tr>
+              <a:tr h="365760">
+                <a:tc>
+                  <a:txBody>
+                    <a:bodyPr/>
+                    <a:lstStyle/>
+                    <a:p>
+                      <a:r>
+                        <a:rPr sz="1500">
+                          <a:solidFill>
+                            <a:srgbClr val="12302D"/>
+                          </a:solidFill>
+                          <a:latin typeface="Calibri"/>
+                        </a:rPr>
+                        <a:t>Alert on a broken deploy</a:t>
+                      </a:r>
+                    </a:p>
+                  </a:txBody>
+                  <a:tcPr marL="73152" marR="73152">
+                    <a:solidFill>
+                      <a:srgbClr val="FFFFFF"/>
+                    </a:solidFill>
+                  </a:tcPr>
+                </a:tc>
+                <a:tc>
+                  <a:txBody>
+                    <a:bodyPr/>
+                    <a:lstStyle/>
+                    <a:p>
+                      <a:r>
+                        <a:rPr sz="1500">
+                          <a:solidFill>
+                            <a:srgbClr val="12302D"/>
+                          </a:solidFill>
+                          <a:latin typeface="Calibri"/>
+                        </a:rPr>
+                        <a:t>none</a:t>
+                      </a:r>
+                    </a:p>
+                  </a:txBody>
+                  <a:tcPr marL="73152" marR="73152">
+                    <a:solidFill>
+                      <a:srgbClr val="FFFFFF"/>
+                    </a:solidFill>
+                  </a:tcPr>
+                </a:tc>
+                <a:tc>
+                  <a:txBody>
+                    <a:bodyPr/>
+                    <a:lstStyle/>
+                    <a:p>
+                      <a:r>
+                        <a:rPr sz="1500">
+                          <a:solidFill>
+                            <a:srgbClr val="12302D"/>
+                          </a:solidFill>
+                          <a:latin typeface="Calibri"/>
+                        </a:rPr>
+                        <a:t>fires in 185 s</a:t>
+                      </a:r>
+                    </a:p>
+                  </a:txBody>
+                  <a:tcPr marL="73152" marR="73152">
+                    <a:solidFill>
+                      <a:srgbClr val="FFFFFF"/>
+                    </a:solidFill>
+                  </a:tcPr>
+                </a:tc>
+              </a:tr>
+              <a:tr h="365760">
+                <a:tc>
+                  <a:txBody>
+                    <a:bodyPr/>
+                    <a:lstStyle/>
+                    <a:p>
+                      <a:r>
+                        <a:rPr sz="1500">
+                          <a:solidFill>
+                            <a:srgbClr val="12302D"/>
+                          </a:solidFill>
+                          <a:latin typeface="Calibri"/>
+                        </a:rPr>
+                        <a:t>Pipeline, median</a:t>
+                      </a:r>
+                    </a:p>
+                  </a:txBody>
+                  <a:tcPr marL="73152" marR="73152">
+                    <a:solidFill>
+                      <a:srgbClr val="D7ECE9"/>
+                    </a:solidFill>
+                  </a:tcPr>
+                </a:tc>
+                <a:tc>
+                  <a:txBody>
+                    <a:bodyPr/>
+                    <a:lstStyle/>
+                    <a:p>
+                      <a:r>
+                        <a:rPr sz="1500">
+                          <a:solidFill>
+                            <a:srgbClr val="12302D"/>
+                          </a:solidFill>
+                          <a:latin typeface="Calibri"/>
+                        </a:rPr>
+                        <a:t>238 s</a:t>
+                      </a:r>
+                    </a:p>
+                  </a:txBody>
+                  <a:tcPr marL="73152" marR="73152">
+                    <a:solidFill>
+                      <a:srgbClr val="D7ECE9"/>
+                    </a:solidFill>
+                  </a:tcPr>
+                </a:tc>
+                <a:tc>
+                  <a:txBody>
+                    <a:bodyPr/>
+                    <a:lstStyle/>
+                    <a:p>
+                      <a:r>
+                        <a:rPr sz="1500">
+                          <a:solidFill>
+                            <a:srgbClr val="12302D"/>
+                          </a:solidFill>
+                          <a:latin typeface="Calibri"/>
+                        </a:rPr>
+                        <a:t>148 s</a:t>
+                      </a:r>
+                    </a:p>
+                  </a:txBody>
+                  <a:tcPr marL="73152" marR="73152">
+                    <a:solidFill>
+                      <a:srgbClr val="D7ECE9"/>
+                    </a:solidFill>
+                  </a:tcPr>
+                </a:tc>
+              </a:tr>
+              <a:tr h="365760">
+                <a:tc>
+                  <a:txBody>
+                    <a:bodyPr/>
+                    <a:lstStyle/>
+                    <a:p>
+                      <a:r>
+                        <a:rPr sz="1500">
+                          <a:solidFill>
+                            <a:srgbClr val="12302D"/>
+                          </a:solidFill>
+                          <a:latin typeface="Calibri"/>
+                        </a:rPr>
+                        <a:t>Restore after a mass delete</a:t>
+                      </a:r>
+                    </a:p>
+                  </a:txBody>
+                  <a:tcPr marL="73152" marR="73152">
+                    <a:solidFill>
+                      <a:srgbClr val="FFFFFF"/>
+                    </a:solidFill>
+                  </a:tcPr>
+                </a:tc>
+                <a:tc>
+                  <a:txBody>
+                    <a:bodyPr/>
+                    <a:lstStyle/>
+                    <a:p>
+                      <a:r>
+                        <a:rPr sz="1500">
+                          <a:solidFill>
+                            <a:srgbClr val="12302D"/>
+                          </a:solidFill>
+                          <a:latin typeface="Calibri"/>
+                        </a:rPr>
+                        <a:t>no backup</a:t>
+                      </a:r>
+                    </a:p>
+                  </a:txBody>
+                  <a:tcPr marL="73152" marR="73152">
+                    <a:solidFill>
+                      <a:srgbClr val="FFFFFF"/>
+                    </a:solidFill>
+                  </a:tcPr>
+                </a:tc>
+                <a:tc>
+                  <a:txBody>
+                    <a:bodyPr/>
+                    <a:lstStyle/>
+                    <a:p>
+                      <a:r>
+                        <a:rPr sz="1500">
+                          <a:solidFill>
+                            <a:srgbClr val="12302D"/>
+                          </a:solidFill>
+                          <a:latin typeface="Calibri"/>
+                        </a:rPr>
+                        <a:t>identical, 4 s</a:t>
+                      </a:r>
+                    </a:p>
+                  </a:txBody>
+                  <a:tcPr marL="73152" marR="73152">
+                    <a:solidFill>
+                      <a:srgbClr val="FFFFFF"/>
+                    </a:solidFill>
+                  </a:tcPr>
+                </a:tc>
+              </a:tr>
+            </a:tbl>
+          </a:graphicData>
+        </a:graphic>
+      </p:graphicFrame>
+      <p:pic>
+        <p:nvPicPr>
+          <p:cNvPr id="7" name="Picture 6" descr="alert-firing.png"/>
+          <p:cNvPicPr>
+            <a:picLocks noChangeAspect="1"/>
+          </p:cNvPicPr>
+          <p:nvPr/>
+        </p:nvPicPr>
+        <p:blipFill>
+          <a:blip r:embed="rId3"/>
+          <a:stretch>
+            <a:fillRect/>
+          </a:stretch>
+        </p:blipFill>
+        <p:spPr>
+          <a:xfrm>
+            <a:off x="7781544" y="1645920"/>
+            <a:ext cx="4096511" cy="2560320"/>
+          </a:xfrm>
+          <a:prstGeom prst="rect">
+            <a:avLst/>
+          </a:prstGeom>
+          <a:ln w="12700">
+            <a:solidFill>
+              <a:srgbClr val="B9CFCB"/>
+            </a:solidFill>
+          </a:ln>
+        </p:spPr>
+      </p:pic>
+      <p:sp>
+        <p:nvSpPr>
+          <p:cNvPr id="8" name="TextBox 7"/>
+          <p:cNvSpPr txBox="1"/>
+          <p:nvPr/>
+        </p:nvSpPr>
+        <p:spPr>
+          <a:xfrm>
+            <a:off x="7772400" y="4224527"/>
+            <a:ext cx="4114800" cy="320040"/>
+          </a:xfrm>
+          <a:prstGeom prst="rect">
+            <a:avLst/>
+          </a:prstGeom>
+          <a:noFill/>
+        </p:spPr>
+        <p:txBody>
+          <a:bodyPr wrap="square">
+            <a:spAutoFit/>
+          </a:bodyPr>
+          <a:lstStyle/>
+          <a:p>
+            <a:pPr>
+              <a:spcAft>
+                <a:spcPts val="600"/>
+              </a:spcAft>
+            </a:pPr>
+            <a:r>
+              <a:rPr sz="1100" b="0">
+                <a:solidFill>
+                  <a:srgbClr val="5B726F"/>
+                </a:solidFill>
+                <a:latin typeface="Calibri"/>
+              </a:rPr>
+              <a:t>Prometheus: the alert firing during the drill</a:t>
+            </a:r>
+          </a:p>
+        </p:txBody>
+      </p:sp>
+      <p:sp>
+        <p:nvSpPr>
+          <p:cNvPr id="9" name="TextBox 8"/>
+          <p:cNvSpPr txBox="1"/>
+          <p:nvPr/>
+        </p:nvSpPr>
+        <p:spPr>
+          <a:xfrm>
+            <a:off x="548640" y="5029200"/>
+            <a:ext cx="11155680" cy="1280160"/>
+          </a:xfrm>
+          <a:prstGeom prst="rect">
+            <a:avLst/>
+          </a:prstGeom>
+          <a:noFill/>
+        </p:spPr>
+        <p:txBody>
+          <a:bodyPr wrap="square">
+            <a:spAutoFit/>
+          </a:bodyPr>
+          <a:lstStyle/>
+          <a:p>
+            <a:pPr>
+              <a:spcAft>
+                <a:spcPts val="800"/>
+              </a:spcAft>
+            </a:pPr>
+            <a:r>
+              <a:rPr sz="1600" b="0">
+                <a:solidFill>
+                  <a:srgbClr val="12302D"/>
+                </a:solidFill>
+                <a:latin typeface="Calibri"/>
+              </a:rPr>
+              <a:t>•  The method: baseline, one change, the same measurement again, then write down the trade-off.</a:t>
+            </a:r>
+          </a:p>
+          <a:p>
+            <a:pPr>
+              <a:spcAft>
+                <a:spcPts val="800"/>
+              </a:spcAft>
+            </a:pPr>
+            <a:r>
+              <a:rPr sz="1600" b="0">
+                <a:solidFill>
+                  <a:srgbClr val="12302D"/>
+                </a:solidFill>
+                <a:latin typeface="Calibri"/>
+              </a:rPr>
+              <a:t>•  The samples are small and from one laptop. The documents in the repository say so.</a:t>
+            </a:r>
+          </a:p>
+        </p:txBody>
+      </p:sp>
+    </p:spTree>
+  </p:cSld>
+  <p:clrMapOvr>
+    <a:masterClrMapping/>
+  </p:clrMapOvr>
+</p:sld>
+</file>
+
+<file path=ppt/slides/slide13.xml><?xml version="1.0" encoding="utf-8"?>
+<p:sld xmlns:a="http://schemas.openxmlformats.org/drawingml/2006/main" xmlns:p="http://schemas.openxmlformats.org/presentationml/2006/main" xmlns:r="http://schemas.openxmlformats.org/officeDocument/2006/relationships">
+  <p:cSld>
+    <p:bg>
+      <p:bgPr>
+        <a:solidFill>
+          <a:srgbClr val="F4F7F6"/>
+        </a:solidFill>
+        <a:effectLst/>
+      </p:bgPr>
+    </p:bg>
+    <p:spTree>
+      <p:nvGrpSpPr>
+        <p:cNvPr id="1" name=""/>
+        <p:cNvGrpSpPr/>
+        <p:nvPr/>
+      </p:nvGrpSpPr>
+      <p:grpSpPr/>
+      <p:sp>
+        <p:nvSpPr>
+          <p:cNvPr id="2" name="Rectangle 1"/>
+          <p:cNvSpPr/>
+          <p:nvPr/>
+        </p:nvSpPr>
+        <p:spPr>
+          <a:xfrm>
+            <a:off x="0" y="0"/>
+            <a:ext cx="228600" cy="6858000"/>
+          </a:xfrm>
+          <a:prstGeom prst="rect">
+            <a:avLst/>
+          </a:prstGeom>
+          <a:solidFill>
+            <a:srgbClr val="0F766E"/>
+          </a:solidFill>
+          <a:ln>
+            <a:noFill/>
+          </a:ln>
+        </p:spPr>
+        <p:style>
+          <a:lnRef idx="1">
+            <a:schemeClr val="accent1"/>
+          </a:lnRef>
+          <a:fillRef idx="3">
+            <a:schemeClr val="accent1"/>
+          </a:fillRef>
+          <a:effectRef idx="2">
+            <a:schemeClr val="accent1"/>
+          </a:effectRef>
+          <a:fontRef idx="minor">
+            <a:schemeClr val="lt1"/>
+          </a:fontRef>
+        </p:style>
+        <p:txBody>
+          <a:bodyPr rtlCol="0" anchor="ctr"/>
+          <a:lstStyle/>
+          <a:p>
+            <a:pPr algn="ctr"/>
+          </a:p>
+        </p:txBody>
+      </p:sp>
+      <p:sp>
+        <p:nvSpPr>
+          <p:cNvPr id="3" name="TextBox 2"/>
+          <p:cNvSpPr txBox="1"/>
+          <p:nvPr/>
+        </p:nvSpPr>
+        <p:spPr>
+          <a:xfrm>
+            <a:off x="548640" y="320040"/>
+            <a:ext cx="11155680" cy="822960"/>
+          </a:xfrm>
+          <a:prstGeom prst="rect">
+            <a:avLst/>
+          </a:prstGeom>
+          <a:noFill/>
+        </p:spPr>
+        <p:txBody>
+          <a:bodyPr wrap="square">
+            <a:spAutoFit/>
+          </a:bodyPr>
+          <a:lstStyle/>
+          <a:p>
+            <a:r>
+              <a:rPr sz="3400" b="1">
+                <a:solidFill>
+                  <a:srgbClr val="12302D"/>
+                </a:solidFill>
+                <a:latin typeface="Calibri"/>
+              </a:rPr>
+              <a:t>Decisions, trade-offs and what I left out</a:t>
+            </a:r>
+          </a:p>
+        </p:txBody>
+      </p:sp>
+      <p:sp>
+        <p:nvSpPr>
+          <p:cNvPr id="4" name="TextBox 3"/>
+          <p:cNvSpPr txBox="1"/>
+          <p:nvPr/>
+        </p:nvSpPr>
+        <p:spPr>
+          <a:xfrm>
+            <a:off x="548640" y="1005840"/>
+            <a:ext cx="11155680" cy="457200"/>
+          </a:xfrm>
+          <a:prstGeom prst="rect">
+            <a:avLst/>
+          </a:prstGeom>
+          <a:noFill/>
+        </p:spPr>
+        <p:txBody>
+          <a:bodyPr wrap="square">
+            <a:spAutoFit/>
+          </a:bodyPr>
+          <a:lstStyle/>
+          <a:p>
+            <a:r>
+              <a:rPr sz="1800">
+                <a:solidFill>
+                  <a:srgbClr val="5B726F"/>
+                </a:solidFill>
+                <a:latin typeface="Calibri"/>
+              </a:rPr>
+              <a:t>Knowing what not to build is part of the job</a:t>
+            </a:r>
+          </a:p>
+        </p:txBody>
+      </p:sp>
+      <p:sp>
+        <p:nvSpPr>
+          <p:cNvPr id="5" name="TextBox 4"/>
+          <p:cNvSpPr txBox="1"/>
+          <p:nvPr/>
+        </p:nvSpPr>
+        <p:spPr>
+          <a:xfrm>
+            <a:off x="548640" y="6446520"/>
+            <a:ext cx="11155680" cy="320040"/>
+          </a:xfrm>
+          <a:prstGeom prst="rect">
+            <a:avLst/>
+          </a:prstGeom>
+          <a:noFill/>
+        </p:spPr>
+        <p:txBody>
+          <a:bodyPr wrap="none">
+            <a:spAutoFit/>
+          </a:bodyPr>
+          <a:lstStyle/>
+          <a:p>
+            <a:r>
+              <a:rPr sz="1100">
+                <a:solidFill>
+                  <a:srgbClr val="5B726F"/>
+                </a:solidFill>
+                <a:latin typeface="Calibri"/>
+              </a:rPr>
+              <a:t>CampusSlot   |   Ujjwal Jain   |   13 / 14</a:t>
+            </a:r>
+          </a:p>
+        </p:txBody>
+      </p:sp>
+      <p:sp>
+        <p:nvSpPr>
+          <p:cNvPr id="6" name="Rounded Rectangle 5"/>
+          <p:cNvSpPr/>
+          <p:nvPr/>
+        </p:nvSpPr>
+        <p:spPr>
+          <a:xfrm>
+            <a:off x="548640" y="1645920"/>
+            <a:ext cx="5394960" cy="868680"/>
+          </a:xfrm>
+          <a:prstGeom prst="roundRect">
+            <a:avLst>
+              <a:gd name="adj" fmla="val 12000"/>
+            </a:avLst>
+          </a:prstGeom>
+          <a:solidFill>
+            <a:srgbClr val="FFFFFF"/>
+          </a:solidFill>
+          <a:ln w="19050">
+            <a:solidFill>
+              <a:srgbClr val="0F766E"/>
+            </a:solidFill>
+          </a:ln>
+        </p:spPr>
+        <p:style>
+          <a:lnRef idx="1">
+            <a:schemeClr val="accent1"/>
+          </a:lnRef>
+          <a:fillRef idx="3">
+            <a:schemeClr val="accent1"/>
+          </a:fillRef>
+          <a:effectRef idx="2">
+            <a:schemeClr val="accent1"/>
+          </a:effectRef>
+          <a:fontRef idx="minor">
+            <a:schemeClr val="lt1"/>
+          </a:fontRef>
+        </p:style>
+        <p:txBody>
+          <a:bodyPr rtlCol="0" anchor="ctr" wrap="square" lIns="73152" rIns="73152"/>
+          <a:lstStyle/>
+          <a:p>
+            <a:pPr algn="ctr"/>
+            <a:r>
+              <a:rPr sz="1600" b="1">
+                <a:solidFill>
+                  <a:srgbClr val="12302D"/>
+                </a:solidFill>
+                <a:latin typeface="Calibri"/>
+              </a:rPr>
+              <a:t>8 s longer per pod in every rollout</a:t>
+            </a:r>
+          </a:p>
+          <a:p>
+            <a:pPr algn="ctr"/>
+            <a:r>
+              <a:rPr sz="1200">
+                <a:solidFill>
+                  <a:srgbClr val="5B726F"/>
+                </a:solidFill>
+                <a:latin typeface="Calibri"/>
+              </a:rPr>
+              <a:t>the price of losing no requests</a:t>
+            </a:r>
+          </a:p>
+        </p:txBody>
+      </p:sp>
+      <p:sp>
+        <p:nvSpPr>
+          <p:cNvPr id="7" name="Rounded Rectangle 6"/>
+          <p:cNvSpPr/>
+          <p:nvPr/>
+        </p:nvSpPr>
+        <p:spPr>
+          <a:xfrm>
+            <a:off x="548640" y="2651760"/>
+            <a:ext cx="5394960" cy="868680"/>
+          </a:xfrm>
+          <a:prstGeom prst="roundRect">
+            <a:avLst>
+              <a:gd name="adj" fmla="val 12000"/>
+            </a:avLst>
+          </a:prstGeom>
+          <a:solidFill>
+            <a:srgbClr val="FFFFFF"/>
+          </a:solidFill>
+          <a:ln w="19050">
+            <a:solidFill>
+              <a:srgbClr val="0F766E"/>
+            </a:solidFill>
+          </a:ln>
+        </p:spPr>
+        <p:style>
+          <a:lnRef idx="1">
+            <a:schemeClr val="accent1"/>
+          </a:lnRef>
+          <a:fillRef idx="3">
+            <a:schemeClr val="accent1"/>
+          </a:fillRef>
+          <a:effectRef idx="2">
+            <a:schemeClr val="accent1"/>
+          </a:effectRef>
+          <a:fontRef idx="minor">
+            <a:schemeClr val="lt1"/>
+          </a:fontRef>
+        </p:style>
+        <p:txBody>
+          <a:bodyPr rtlCol="0" anchor="ctr" wrap="square" lIns="73152" rIns="73152"/>
+          <a:lstStyle/>
+          <a:p>
+            <a:pPr algn="ctr"/>
+            <a:r>
+              <a:rPr sz="1600" b="1">
+                <a:solidFill>
+                  <a:srgbClr val="12302D"/>
+                </a:solidFill>
+                <a:latin typeface="Calibri"/>
+              </a:rPr>
+              <a:t>About 59 s longer per pipeline run</a:t>
+            </a:r>
+          </a:p>
+          <a:p>
+            <a:pPr algn="ctr"/>
+            <a:r>
+              <a:rPr sz="1200">
+                <a:solidFill>
+                  <a:srgbClr val="5B726F"/>
+                </a:solidFill>
+                <a:latin typeface="Calibri"/>
+              </a:rPr>
+              <a:t>the price of signed, verified images (one pair of runs)</a:t>
+            </a:r>
+          </a:p>
+        </p:txBody>
+      </p:sp>
+      <p:sp>
+        <p:nvSpPr>
+          <p:cNvPr id="8" name="Rounded Rectangle 7"/>
+          <p:cNvSpPr/>
+          <p:nvPr/>
+        </p:nvSpPr>
+        <p:spPr>
+          <a:xfrm>
+            <a:off x="548640" y="3657600"/>
+            <a:ext cx="5394960" cy="868680"/>
+          </a:xfrm>
+          <a:prstGeom prst="roundRect">
+            <a:avLst>
+              <a:gd name="adj" fmla="val 12000"/>
+            </a:avLst>
+          </a:prstGeom>
+          <a:solidFill>
+            <a:srgbClr val="FFFFFF"/>
+          </a:solidFill>
+          <a:ln w="19050">
+            <a:solidFill>
+              <a:srgbClr val="0F766E"/>
+            </a:solidFill>
+          </a:ln>
+        </p:spPr>
+        <p:style>
+          <a:lnRef idx="1">
+            <a:schemeClr val="accent1"/>
+          </a:lnRef>
+          <a:fillRef idx="3">
+            <a:schemeClr val="accent1"/>
+          </a:fillRef>
+          <a:effectRef idx="2">
+            <a:schemeClr val="accent1"/>
+          </a:effectRef>
+          <a:fontRef idx="minor">
+            <a:schemeClr val="lt1"/>
+          </a:fontRef>
+        </p:style>
+        <p:txBody>
+          <a:bodyPr rtlCol="0" anchor="ctr" wrap="square" lIns="73152" rIns="73152"/>
+          <a:lstStyle/>
+          <a:p>
+            <a:pPr algn="ctr"/>
+            <a:r>
+              <a:rPr sz="1600" b="1">
+                <a:solidFill>
+                  <a:srgbClr val="12302D"/>
+                </a:solidFill>
+                <a:latin typeface="Calibri"/>
+              </a:rPr>
+              <a:t>Backup stays in the same cluster</a:t>
+            </a:r>
+          </a:p>
+          <a:p>
+            <a:pPr algn="ctr"/>
+            <a:r>
+              <a:rPr sz="1200">
+                <a:solidFill>
+                  <a:srgbClr val="5B726F"/>
+                </a:solidFill>
+                <a:latin typeface="Calibri"/>
+              </a:rPr>
+              <a:t>covers mistakes, not the loss of the cluster</a:t>
+            </a:r>
+          </a:p>
+        </p:txBody>
+      </p:sp>
+      <p:sp>
+        <p:nvSpPr>
+          <p:cNvPr id="9" name="Rounded Rectangle 8"/>
+          <p:cNvSpPr/>
+          <p:nvPr/>
+        </p:nvSpPr>
+        <p:spPr>
+          <a:xfrm>
+            <a:off x="548640" y="4663440"/>
+            <a:ext cx="5394960" cy="868680"/>
+          </a:xfrm>
+          <a:prstGeom prst="roundRect">
+            <a:avLst>
+              <a:gd name="adj" fmla="val 12000"/>
+            </a:avLst>
+          </a:prstGeom>
+          <a:solidFill>
+            <a:srgbClr val="FFFFFF"/>
+          </a:solidFill>
+          <a:ln w="19050">
+            <a:solidFill>
+              <a:srgbClr val="0F766E"/>
+            </a:solidFill>
+          </a:ln>
+        </p:spPr>
+        <p:style>
+          <a:lnRef idx="1">
+            <a:schemeClr val="accent1"/>
+          </a:lnRef>
+          <a:fillRef idx="3">
+            <a:schemeClr val="accent1"/>
+          </a:fillRef>
+          <a:effectRef idx="2">
+            <a:schemeClr val="accent1"/>
+          </a:effectRef>
+          <a:fontRef idx="minor">
+            <a:schemeClr val="lt1"/>
+          </a:fontRef>
+        </p:style>
+        <p:txBody>
+          <a:bodyPr rtlCol="0" anchor="ctr" wrap="square" lIns="73152" rIns="73152"/>
+          <a:lstStyle/>
+          <a:p>
+            <a:pPr algn="ctr"/>
+            <a:r>
+              <a:rPr sz="1600" b="1">
+                <a:solidFill>
+                  <a:srgbClr val="12302D"/>
+                </a:solidFill>
+                <a:latin typeface="Calibri"/>
+              </a:rPr>
+              <a:t>One database pod</a:t>
+            </a:r>
+          </a:p>
+          <a:p>
+            <a:pPr algn="ctr"/>
+            <a:r>
+              <a:rPr sz="1200">
+                <a:solidFill>
+                  <a:srgbClr val="5B726F"/>
+                </a:solidFill>
+                <a:latin typeface="Calibri"/>
+              </a:rPr>
+              <a:t>a 6 s outage remains, now visible to the alerts</a:t>
+            </a:r>
+          </a:p>
+        </p:txBody>
+      </p:sp>
+      <p:sp>
+        <p:nvSpPr>
+          <p:cNvPr id="10" name="TextBox 9"/>
+          <p:cNvSpPr txBox="1"/>
+          <p:nvPr/>
+        </p:nvSpPr>
+        <p:spPr>
+          <a:xfrm>
+            <a:off x="6309360" y="1554480"/>
+            <a:ext cx="5577840" cy="4206240"/>
+          </a:xfrm>
+          <a:prstGeom prst="rect">
+            <a:avLst/>
+          </a:prstGeom>
+          <a:noFill/>
+        </p:spPr>
+        <p:txBody>
+          <a:bodyPr wrap="square">
+            <a:spAutoFit/>
+          </a:bodyPr>
+          <a:lstStyle/>
+          <a:p>
+            <a:pPr>
+              <a:spcAft>
+                <a:spcPts val="800"/>
+              </a:spcAft>
+            </a:pPr>
+            <a:r>
+              <a:rPr sz="1800" b="1">
+                <a:solidFill>
+                  <a:srgbClr val="12302D"/>
+                </a:solidFill>
+                <a:latin typeface="Calibri"/>
+              </a:rPr>
+              <a:t>•  Not done, on purpose</a:t>
+            </a:r>
+          </a:p>
+          <a:p>
+            <a:pPr>
+              <a:spcAft>
+                <a:spcPts val="800"/>
+              </a:spcAft>
+            </a:pPr>
+            <a:r>
+              <a:rPr sz="1800" b="0">
+                <a:solidFill>
+                  <a:srgbClr val="12302D"/>
+                </a:solidFill>
+                <a:latin typeface="Calibri"/>
+              </a:rPr>
+              <a:t>•  Load test and tuning</a:t>
+            </a:r>
+          </a:p>
+          <a:p>
+            <a:pPr>
+              <a:spcAft>
+                <a:spcPts val="800"/>
+              </a:spcAft>
+            </a:pPr>
+            <a:r>
+              <a:rPr sz="1800" b="0">
+                <a:solidFill>
+                  <a:srgbClr val="12302D"/>
+                </a:solidFill>
+                <a:latin typeface="Calibri"/>
+              </a:rPr>
+              <a:t>•  200 thousand row query plans</a:t>
+            </a:r>
+          </a:p>
+          <a:p>
+            <a:pPr>
+              <a:spcAft>
+                <a:spcPts val="800"/>
+              </a:spcAft>
+            </a:pPr>
+            <a:r>
+              <a:rPr sz="1800" b="0">
+                <a:solidFill>
+                  <a:srgbClr val="12302D"/>
+                </a:solidFill>
+                <a:latin typeface="Calibri"/>
+              </a:rPr>
+              <a:t>•  Right-sizing from measured usage</a:t>
+            </a:r>
+          </a:p>
+          <a:p>
+            <a:pPr>
+              <a:spcAft>
+                <a:spcPts val="800"/>
+              </a:spcAft>
+            </a:pPr>
+            <a:r>
+              <a:rPr sz="1800" b="0">
+                <a:solidFill>
+                  <a:srgbClr val="12302D"/>
+                </a:solidFill>
+                <a:latin typeface="Calibri"/>
+              </a:rPr>
+              <a:t>•  Rollback drill</a:t>
+            </a:r>
+          </a:p>
+          <a:p>
+            <a:pPr>
+              <a:spcAft>
+                <a:spcPts val="800"/>
+              </a:spcAft>
+            </a:pPr>
+            <a:r>
+              <a:rPr sz="1800" b="0">
+                <a:solidFill>
+                  <a:srgbClr val="12302D"/>
+                </a:solidFill>
+                <a:latin typeface="Calibri"/>
+              </a:rPr>
+              <a:t>•  Automated promotion</a:t>
+            </a:r>
+          </a:p>
+          <a:p>
+            <a:pPr>
+              <a:spcAft>
+                <a:spcPts val="800"/>
+              </a:spcAft>
+            </a:pPr>
+            <a:r>
+              <a:rPr sz="1800" b="0">
+                <a:solidFill>
+                  <a:srgbClr val="12302D"/>
+                </a:solidFill>
+                <a:latin typeface="Calibri"/>
+              </a:rPr>
+              <a:t>•  Network policies</a:t>
+            </a:r>
+          </a:p>
+          <a:p>
+            <a:pPr>
+              <a:spcAft>
+                <a:spcPts val="800"/>
+              </a:spcAft>
+            </a:pPr>
+            <a:r>
+              <a:rPr sz="1800" b="0">
+                <a:solidFill>
+                  <a:srgbClr val="12302D"/>
+                </a:solidFill>
+                <a:latin typeface="Calibri"/>
+              </a:rPr>
+              <a:t>•  Alert delivery (no Alertmanager)</a:t>
+            </a:r>
+          </a:p>
+        </p:txBody>
+      </p:sp>
+      <p:sp>
+        <p:nvSpPr>
+          <p:cNvPr id="11" name="TextBox 10"/>
+          <p:cNvSpPr txBox="1"/>
+          <p:nvPr/>
+        </p:nvSpPr>
+        <p:spPr>
+          <a:xfrm>
+            <a:off x="548640" y="5760720"/>
+            <a:ext cx="11155680" cy="548640"/>
+          </a:xfrm>
+          <a:prstGeom prst="rect">
+            <a:avLst/>
+          </a:prstGeom>
+          <a:noFill/>
+        </p:spPr>
+        <p:txBody>
+          <a:bodyPr wrap="square">
+            <a:spAutoFit/>
+          </a:bodyPr>
+          <a:lstStyle/>
+          <a:p>
+            <a:pPr>
+              <a:spcAft>
+                <a:spcPts val="600"/>
+              </a:spcAft>
+            </a:pPr>
+            <a:r>
+              <a:rPr sz="1400" b="0">
+                <a:solidFill>
+                  <a:srgbClr val="5B726F"/>
+                </a:solidFill>
+                <a:latin typeface="Calibri"/>
+              </a:rPr>
+              <a:t>12 decision records in docs/adr explain the choices and what I would do in production.</a:t>
+            </a:r>
+          </a:p>
+        </p:txBody>
+      </p:sp>
+    </p:spTree>
+  </p:cSld>
+  <p:clrMapOvr>
+    <a:masterClrMapping/>
+  </p:clrMapOvr>
+</p:sld>
+</file>
+
+<file path=ppt/slides/slide14.xml><?xml version="1.0" encoding="utf-8"?>
+<p:sld xmlns:a="http://schemas.openxmlformats.org/drawingml/2006/main" xmlns:p="http://schemas.openxmlformats.org/presentationml/2006/main" xmlns:r="http://schemas.openxmlformats.org/officeDocument/2006/relationships">
+  <p:cSld>
+    <p:bg>
+      <p:bgPr>
+        <a:solidFill>
+          <a:srgbClr val="F4F7F6"/>
+        </a:solidFill>
+        <a:effectLst/>
+      </p:bgPr>
+    </p:bg>
+    <p:spTree>
+      <p:nvGrpSpPr>
+        <p:cNvPr id="1" name=""/>
+        <p:cNvGrpSpPr/>
+        <p:nvPr/>
+      </p:nvGrpSpPr>
+      <p:grpSpPr/>
+      <p:sp>
+        <p:nvSpPr>
+          <p:cNvPr id="2" name="Rectangle 1"/>
+          <p:cNvSpPr/>
+          <p:nvPr/>
+        </p:nvSpPr>
+        <p:spPr>
+          <a:xfrm>
+            <a:off x="0" y="0"/>
+            <a:ext cx="228600" cy="6858000"/>
+          </a:xfrm>
+          <a:prstGeom prst="rect">
+            <a:avLst/>
+          </a:prstGeom>
+          <a:solidFill>
+            <a:srgbClr val="0F766E"/>
+          </a:solidFill>
+          <a:ln>
+            <a:noFill/>
+          </a:ln>
+        </p:spPr>
+        <p:style>
+          <a:lnRef idx="1">
+            <a:schemeClr val="accent1"/>
+          </a:lnRef>
+          <a:fillRef idx="3">
+            <a:schemeClr val="accent1"/>
+          </a:fillRef>
+          <a:effectRef idx="2">
+            <a:schemeClr val="accent1"/>
+          </a:effectRef>
+          <a:fontRef idx="minor">
+            <a:schemeClr val="lt1"/>
+          </a:fontRef>
+        </p:style>
+        <p:txBody>
+          <a:bodyPr rtlCol="0" anchor="ctr"/>
+          <a:lstStyle/>
+          <a:p>
+            <a:pPr algn="ctr"/>
+          </a:p>
+        </p:txBody>
+      </p:sp>
+      <p:sp>
+        <p:nvSpPr>
+          <p:cNvPr id="3" name="TextBox 2"/>
+          <p:cNvSpPr txBox="1"/>
+          <p:nvPr/>
+        </p:nvSpPr>
+        <p:spPr>
+          <a:xfrm>
+            <a:off x="548640" y="320040"/>
+            <a:ext cx="11155680" cy="822960"/>
+          </a:xfrm>
+          <a:prstGeom prst="rect">
+            <a:avLst/>
+          </a:prstGeom>
+          <a:noFill/>
+        </p:spPr>
+        <p:txBody>
+          <a:bodyPr wrap="square">
+            <a:spAutoFit/>
+          </a:bodyPr>
+          <a:lstStyle/>
+          <a:p>
+            <a:r>
+              <a:rPr sz="3400" b="1">
+                <a:solidFill>
+                  <a:srgbClr val="12302D"/>
+                </a:solidFill>
+                <a:latin typeface="Calibri"/>
+              </a:rPr>
+              <a:t>From a change to a running system</a:t>
+            </a:r>
+          </a:p>
+        </p:txBody>
+      </p:sp>
+      <p:sp>
+        <p:nvSpPr>
+          <p:cNvPr id="4" name="TextBox 3"/>
+          <p:cNvSpPr txBox="1"/>
+          <p:nvPr/>
+        </p:nvSpPr>
+        <p:spPr>
+          <a:xfrm>
+            <a:off x="548640" y="1005840"/>
+            <a:ext cx="11155680" cy="457200"/>
+          </a:xfrm>
+          <a:prstGeom prst="rect">
+            <a:avLst/>
+          </a:prstGeom>
+          <a:noFill/>
+        </p:spPr>
+        <p:txBody>
+          <a:bodyPr wrap="square">
+            <a:spAutoFit/>
+          </a:bodyPr>
+          <a:lstStyle/>
+          <a:p>
+            <a:r>
+              <a:rPr sz="1800">
+                <a:solidFill>
+                  <a:srgbClr val="5B726F"/>
+                </a:solidFill>
+                <a:latin typeface="Calibri"/>
+              </a:rPr>
+              <a:t>I rehearsed the whole loop, and here is what I learned</a:t>
+            </a:r>
+          </a:p>
+        </p:txBody>
+      </p:sp>
+      <p:sp>
+        <p:nvSpPr>
+          <p:cNvPr id="5" name="TextBox 4"/>
+          <p:cNvSpPr txBox="1"/>
+          <p:nvPr/>
+        </p:nvSpPr>
+        <p:spPr>
+          <a:xfrm>
+            <a:off x="548640" y="6446520"/>
+            <a:ext cx="11155680" cy="320040"/>
+          </a:xfrm>
+          <a:prstGeom prst="rect">
+            <a:avLst/>
+          </a:prstGeom>
+          <a:noFill/>
+        </p:spPr>
+        <p:txBody>
+          <a:bodyPr wrap="none">
+            <a:spAutoFit/>
+          </a:bodyPr>
+          <a:lstStyle/>
+          <a:p>
+            <a:r>
+              <a:rPr sz="1100">
+                <a:solidFill>
+                  <a:srgbClr val="5B726F"/>
+                </a:solidFill>
+                <a:latin typeface="Calibri"/>
+              </a:rPr>
+              <a:t>CampusSlot   |   Ujjwal Jain   |   14 / 14</a:t>
             </a:r>
           </a:p>
         </p:txBody>
@@ -6899,7 +8403,7 @@
                 </a:solidFill>
                 <a:latin typeface="Calibri"/>
               </a:rPr>
-              <a:t>CampusSlot   |   Ujjwal Jain   |   2 / 12</a:t>
+              <a:t>CampusSlot   |   Ujjwal Jain   |   2 / 14</a:t>
             </a:r>
           </a:p>
         </p:txBody>
@@ -8234,7 +9738,7 @@
                 </a:solidFill>
                 <a:latin typeface="Calibri"/>
               </a:rPr>
-              <a:t>CampusSlot   |   Ujjwal Jain   |   3 / 12</a:t>
+              <a:t>CampusSlot   |   Ujjwal Jain   |   3 / 14</a:t>
             </a:r>
           </a:p>
         </p:txBody>
@@ -8649,7 +10153,7 @@
                 </a:solidFill>
                 <a:latin typeface="Calibri"/>
               </a:rPr>
-              <a:t>58 meaningful commits, each one a small step that can be explained</a:t>
+              <a:t>71 meaningful commits, each one a small step that can be explained</a:t>
             </a:r>
           </a:p>
         </p:txBody>
@@ -8683,7 +10187,7 @@
                 </a:solidFill>
                 <a:latin typeface="Calibri"/>
               </a:rPr>
-              <a:t>CampusSlot   |   Ujjwal Jain   |   4 / 12</a:t>
+              <a:t>CampusSlot   |   Ujjwal Jain   |   4 / 14</a:t>
             </a:r>
           </a:p>
         </p:txBody>
@@ -9105,7 +10609,7 @@
                 </a:solidFill>
                 <a:latin typeface="Calibri"/>
               </a:rPr>
-              <a:t>CampusSlot   |   Ujjwal Jain   |   5 / 12</a:t>
+              <a:t>CampusSlot   |   Ujjwal Jain   |   5 / 14</a:t>
             </a:r>
           </a:p>
         </p:txBody>
@@ -9551,7 +11055,7 @@
                 </a:solidFill>
                 <a:latin typeface="Calibri"/>
               </a:rPr>
-              <a:t>CampusSlot   |   Ujjwal Jain   |   6 / 12</a:t>
+              <a:t>CampusSlot   |   Ujjwal Jain   |   6 / 14</a:t>
             </a:r>
           </a:p>
         </p:txBody>
@@ -10154,7 +11658,7 @@
                 </a:solidFill>
                 <a:latin typeface="Calibri"/>
               </a:rPr>
-              <a:t>CampusSlot   |   Ujjwal Jain   |   7 / 12</a:t>
+              <a:t>CampusSlot   |   Ujjwal Jain   |   7 / 14</a:t>
             </a:r>
           </a:p>
         </p:txBody>
@@ -10648,7 +12152,7 @@
                 </a:solidFill>
                 <a:latin typeface="Calibri"/>
               </a:rPr>
-              <a:t>CampusSlot   |   Ujjwal Jain   |   8 / 12</a:t>
+              <a:t>CampusSlot   |   Ujjwal Jain   |   8 / 14</a:t>
             </a:r>
           </a:p>
         </p:txBody>
@@ -11210,7 +12714,7 @@
                 </a:solidFill>
                 <a:latin typeface="Calibri"/>
               </a:rPr>
-              <a:t>CampusSlot   |   Ujjwal Jain   |   9 / 12</a:t>
+              <a:t>CampusSlot   |   Ujjwal Jain   |   9 / 14</a:t>
             </a:r>
           </a:p>
         </p:txBody>

</xml_diff>

<commit_message>
Use all three measured runs for the supply chain cost, regenerate the deck
</commit_message>
<xml_diff>
--- a/docs/presentation/CampusSlot-final-presentation.pptx
+++ b/docs/presentation/CampusSlot-final-presentation.pptx
@@ -795,7 +795,7 @@
           <a:lstStyle/>
           <a:p>
             <a:r>
-              <a:t>Every change costs something, and I wrote the cost down. Waiting eight seconds before a pod stops makes every rollout slower. Signing and verifying the images adds about a minute to every pipeline run, from one pair of runs. The backup stays inside the cluster, so it protects against mistakes but not against losing the cluster. There is one database pod, so an outage of about six seconds remains, and I only made it visible. On the right is what I planned and chose not to do, so nobody has to guess. Twelve short decision records explain the reasons for the main choices, with what I would do in production.</a:t>
+              <a:t>Every change costs something, and I wrote the cost down. Waiting eight seconds before a pod stops makes every rollout slower. Signing and verifying the images adds about a minute to every pipeline run, from three runs. The backup stays inside the cluster, so it protects against mistakes but not against losing the cluster. There is one database pod, so an outage of about six seconds remains, and I only made it visible. On the right is what I planned and chose not to do, so nobody has to guess. Twelve short decision records explain the reasons for the main choices, with what I would do in production.</a:t>
             </a:r>
           </a:p>
         </p:txBody>
@@ -6825,7 +6825,7 @@
                 </a:solidFill>
                 <a:latin typeface="Calibri"/>
               </a:rPr>
-              <a:t>About 59 s longer per pipeline run</a:t>
+              <a:t>About a minute longer per pipeline run</a:t>
             </a:r>
           </a:p>
           <a:p>
@@ -6837,7 +6837,7 @@
                 </a:solidFill>
                 <a:latin typeface="Calibri"/>
               </a:rPr>
-              <a:t>the price of signed, verified images (one pair of runs)</a:t>
+              <a:t>the price of signed, verified images (143 s vs 202 s and 214 s)</a:t>
             </a:r>
           </a:p>
         </p:txBody>
@@ -10153,7 +10153,7 @@
                 </a:solidFill>
                 <a:latin typeface="Calibri"/>
               </a:rPr>
-              <a:t>71 meaningful commits, each one a small step that can be explained</a:t>
+              <a:t>74 meaningful commits, each one a small step that can be explained</a:t>
             </a:r>
           </a:p>
         </p:txBody>

</xml_diff>

<commit_message>
Record the final cleanup check and the AWS credit (#10)
* Record the third cleanup check and the final AWS credit

* Use all three measured runs for the supply chain cost, regenerate the deck
</commit_message>
<xml_diff>
--- a/docs/presentation/CampusSlot-final-presentation.pptx
+++ b/docs/presentation/CampusSlot-final-presentation.pptx
@@ -795,7 +795,7 @@
           <a:lstStyle/>
           <a:p>
             <a:r>
-              <a:t>Every change costs something, and I wrote the cost down. Waiting eight seconds before a pod stops makes every rollout slower. Signing and verifying the images adds about a minute to every pipeline run, from one pair of runs. The backup stays inside the cluster, so it protects against mistakes but not against losing the cluster. There is one database pod, so an outage of about six seconds remains, and I only made it visible. On the right is what I planned and chose not to do, so nobody has to guess. Twelve short decision records explain the reasons for the main choices, with what I would do in production.</a:t>
+              <a:t>Every change costs something, and I wrote the cost down. Waiting eight seconds before a pod stops makes every rollout slower. Signing and verifying the images adds about a minute to every pipeline run, from three runs. The backup stays inside the cluster, so it protects against mistakes but not against losing the cluster. There is one database pod, so an outage of about six seconds remains, and I only made it visible. On the right is what I planned and chose not to do, so nobody has to guess. Twelve short decision records explain the reasons for the main choices, with what I would do in production.</a:t>
             </a:r>
           </a:p>
         </p:txBody>
@@ -6825,7 +6825,7 @@
                 </a:solidFill>
                 <a:latin typeface="Calibri"/>
               </a:rPr>
-              <a:t>About 59 s longer per pipeline run</a:t>
+              <a:t>About a minute longer per pipeline run</a:t>
             </a:r>
           </a:p>
           <a:p>
@@ -6837,7 +6837,7 @@
                 </a:solidFill>
                 <a:latin typeface="Calibri"/>
               </a:rPr>
-              <a:t>the price of signed, verified images (one pair of runs)</a:t>
+              <a:t>the price of signed, verified images (143 s vs 202 s and 214 s)</a:t>
             </a:r>
           </a:p>
         </p:txBody>
@@ -10153,7 +10153,7 @@
                 </a:solidFill>
                 <a:latin typeface="Calibri"/>
               </a:rPr>
-              <a:t>71 meaningful commits, each one a small step that can be explained</a:t>
+              <a:t>74 meaningful commits, each one a small step that can be explained</a:t>
             </a:r>
           </a:p>
         </p:txBody>

</xml_diff>

<commit_message>
Measure query cost at scale, load test one pod and size the pods from measurements
Queries: the overlap check, day view and statistics read the whole table (2469 pages at
200 thousand bookings). A range operator and a GiST index (migration 0004) bring it to 30 pages,
flat as the table grows.

Load test: one pod was throttled at its 500m CPU limit. 1000m gives 342 instead of 153 requests
per second. Two workers and an ETag were tried and rejected.

Sizing: requests set from measured usage and the autoscaler target moved to 70 percent. The same
60 requests per second now needs 2 pods instead of 5.
</commit_message>
<xml_diff>
--- a/docs/presentation/CampusSlot-final-presentation.pptx
+++ b/docs/presentation/CampusSlot-final-presentation.pptx
@@ -19,6 +19,7 @@
     <p:sldId id="267" r:id="rId19"/>
     <p:sldId id="268" r:id="rId20"/>
     <p:sldId id="269" r:id="rId21"/>
+    <p:sldId id="270" r:id="rId22"/>
   </p:sldIdLst>
   <p:sldSz cx="12191695" cy="6858000" type="screen4x3"/>
   <p:notesSz cx="6858000" cy="9144000"/>
@@ -795,7 +796,7 @@
           <a:lstStyle/>
           <a:p>
             <a:r>
-              <a:t>Every change costs something, and I wrote the cost down. Waiting eight seconds before a pod stops makes every rollout slower. Signing and verifying the images adds about a minute to every pipeline run, from three runs. The backup stays inside the cluster, so it protects against mistakes but not against losing the cluster. There is one database pod, so an outage of about six seconds remains, and I only made it visible. On the right is what I planned and chose not to do, so nobody has to guess. Twelve short decision records explain the reasons for the main choices, with what I would do in production.</a:t>
+              <a:t>Every change costs something, and I wrote the cost down. Waiting eight seconds before a pod stops makes every rollout slower. Signing and verifying the images adds about a minute to every pipeline run, from three runs. The backup stays inside the cluster, so it protects against mistakes but not against losing the cluster. There is one database pod, so an outage of about six seconds remains, and I only made it visible. On the right is what I planned and chose not to do, so nobody has to guess. Fourteen short decision records explain the reasons for the main choices, with what I would do in production.</a:t>
             </a:r>
           </a:p>
         </p:txBody>
@@ -821,6 +822,76 @@
 </file>
 
 <file path=ppt/notesSlides/notesSlide14.xml><?xml version="1.0" encoding="utf-8"?>
+<p:notes xmlns:a="http://schemas.openxmlformats.org/drawingml/2006/main" xmlns:p="http://schemas.openxmlformats.org/presentationml/2006/main" xmlns:r="http://schemas.openxmlformats.org/officeDocument/2006/relationships">
+  <p:cSld>
+    <p:spTree>
+      <p:nvGrpSpPr>
+        <p:cNvPr id="1" name=""/>
+        <p:cNvGrpSpPr/>
+        <p:nvPr/>
+      </p:nvGrpSpPr>
+      <p:grpSpPr>
+        <a:xfrm>
+          <a:off x="0" y="0"/>
+          <a:ext cx="0" cy="0"/>
+          <a:chOff x="0" y="0"/>
+          <a:chExt cx="0" cy="0"/>
+        </a:xfrm>
+      </p:grpSpPr>
+      <p:sp>
+        <p:nvSpPr>
+          <p:cNvPr id="2" name="Slide Image Placeholder 1"/>
+          <p:cNvSpPr>
+            <a:spLocks noGrp="1"/>
+          </p:cNvSpPr>
+          <p:nvPr>
+            <p:ph type="sldImg" idx="2"/>
+          </p:nvPr>
+        </p:nvSpPr>
+        <p:spPr/>
+      </p:sp>
+      <p:sp>
+        <p:nvSpPr>
+          <p:cNvPr id="3" name="Notes Placeholder 2"/>
+          <p:cNvSpPr>
+            <a:spLocks noGrp="1"/>
+          </p:cNvSpPr>
+          <p:nvPr>
+            <p:ph type="body" idx="3" sz="quarter"/>
+          </p:nvPr>
+        </p:nvSpPr>
+        <p:spPr/>
+        <p:txBody>
+          <a:bodyPr/>
+          <a:lstStyle/>
+          <a:p>
+            <a:r>
+              <a:t>I wanted to know what happens when the data and the traffic grow, so I measured instead of guessing. With 200 thousand bookings, the question 'which bookings overlap this time' read the whole table, about two and a half thousand pages, and the cost grew with the table. Writing the same question as a range, with an index made for ranges, cut it to thirty pages and kept it flat. Through the application, the day view went from 21 to 113 requests per second. Then I loaded one pod until it stopped. It was throttled by the CPU limit I had written without measuring. Doubling the limit made it more than twice as fast. I also tried two ideas that I expected to help, more worker processes and caching, and neither did anything, so I removed them from the code. Finally, I sized the CPU and memory from what the pods really use. My old request was so low that 60 requests per second made the autoscaler run five pods, and with the measured request it runs two, with the same CPU reserved and a third of the memory. The sample sizes are small and the machine is a shared laptop cluster, and the documents say so.</a:t>
+            </a:r>
+          </a:p>
+        </p:txBody>
+      </p:sp>
+      <p:sp>
+        <p:nvSpPr>
+          <p:cNvPr id="4" name="Slide Number Placeholder 3"/>
+          <p:cNvSpPr>
+            <a:spLocks noGrp="1"/>
+          </p:cNvSpPr>
+          <p:nvPr>
+            <p:ph type="sldNum" idx="5" sz="quarter"/>
+          </p:nvPr>
+        </p:nvSpPr>
+        <p:spPr/>
+      </p:sp>
+    </p:spTree>
+  </p:cSld>
+  <p:clrMapOvr>
+    <a:masterClrMapping/>
+  </p:clrMapOvr>
+</p:notes>
+</file>
+
+<file path=ppt/notesSlides/notesSlide15.xml><?xml version="1.0" encoding="utf-8"?>
 <p:notes xmlns:a="http://schemas.openxmlformats.org/drawingml/2006/main" xmlns:p="http://schemas.openxmlformats.org/presentationml/2006/main" xmlns:r="http://schemas.openxmlformats.org/officeDocument/2006/relationships">
   <p:cSld>
     <p:spTree>
@@ -4579,7 +4650,7 @@
                 </a:solidFill>
                 <a:latin typeface="Calibri"/>
               </a:rPr>
-              <a:t>CampusSlot   |   Ujjwal Jain   |   1 / 14</a:t>
+              <a:t>CampusSlot   |   Ujjwal Jain   |   1 / 15</a:t>
             </a:r>
           </a:p>
         </p:txBody>
@@ -4921,7 +4992,7 @@
                 </a:solidFill>
                 <a:latin typeface="Calibri"/>
               </a:rPr>
-              <a:t>CampusSlot   |   Ujjwal Jain   |   10 / 14</a:t>
+              <a:t>CampusSlot   |   Ujjwal Jain   |   10 / 15</a:t>
             </a:r>
           </a:p>
         </p:txBody>
@@ -5367,7 +5438,7 @@
                 </a:solidFill>
                 <a:latin typeface="Calibri"/>
               </a:rPr>
-              <a:t>CampusSlot   |   Ujjwal Jain   |   11 / 14</a:t>
+              <a:t>CampusSlot   |   Ujjwal Jain   |   11 / 15</a:t>
             </a:r>
           </a:p>
         </p:txBody>
@@ -5972,7 +6043,7 @@
                 </a:solidFill>
                 <a:latin typeface="Calibri"/>
               </a:rPr>
-              <a:t>CampusSlot   |   Ujjwal Jain   |   12 / 14</a:t>
+              <a:t>CampusSlot   |   Ujjwal Jain   |   12 / 15</a:t>
             </a:r>
           </a:p>
         </p:txBody>
@@ -6701,7 +6772,7 @@
                 </a:solidFill>
                 <a:latin typeface="Calibri"/>
               </a:rPr>
-              <a:t>CampusSlot   |   Ujjwal Jain   |   13 / 14</a:t>
+              <a:t>CampusSlot   |   Ujjwal Jain   |   13 / 15</a:t>
             </a:r>
           </a:p>
         </p:txBody>
@@ -7028,7 +7099,7 @@
                 </a:solidFill>
                 <a:latin typeface="Calibri"/>
               </a:rPr>
-              <a:t>•  Load test and tuning</a:t>
+              <a:t>•  Rollback drill</a:t>
             </a:r>
           </a:p>
           <a:p>
@@ -7044,7 +7115,7 @@
                 </a:solidFill>
                 <a:latin typeface="Calibri"/>
               </a:rPr>
-              <a:t>•  200 thousand row query plans</a:t>
+              <a:t>•  Automated promotion</a:t>
             </a:r>
           </a:p>
           <a:p>
@@ -7060,7 +7131,7 @@
                 </a:solidFill>
                 <a:latin typeface="Calibri"/>
               </a:rPr>
-              <a:t>•  Right-sizing from measured usage</a:t>
+              <a:t>•  Network policies</a:t>
             </a:r>
           </a:p>
           <a:p>
@@ -7076,7 +7147,7 @@
                 </a:solidFill>
                 <a:latin typeface="Calibri"/>
               </a:rPr>
-              <a:t>•  Rollback drill</a:t>
+              <a:t>•  Alert delivery (no Alertmanager)</a:t>
             </a:r>
           </a:p>
           <a:p>
@@ -7092,7 +7163,7 @@
                 </a:solidFill>
                 <a:latin typeface="Calibri"/>
               </a:rPr>
-              <a:t>•  Automated promotion</a:t>
+              <a:t>•  Write-heavy load test</a:t>
             </a:r>
           </a:p>
           <a:p>
@@ -7108,7 +7179,7 @@
                 </a:solidFill>
                 <a:latin typeface="Calibri"/>
               </a:rPr>
-              <a:t>•  Network policies</a:t>
+              <a:t>•  Why two workers gave no gain</a:t>
             </a:r>
           </a:p>
           <a:p>
@@ -7124,7 +7195,7 @@
                 </a:solidFill>
                 <a:latin typeface="Calibri"/>
               </a:rPr>
-              <a:t>•  Alert delivery (no Alertmanager)</a:t>
+              <a:t>•  Backups outside the cluster</a:t>
             </a:r>
           </a:p>
         </p:txBody>
@@ -7163,7 +7234,7 @@
                 </a:solidFill>
                 <a:latin typeface="Calibri"/>
               </a:rPr>
-              <a:t>12 decision records in docs/adr explain the choices and what I would do in production.</a:t>
+              <a:t>14 decision records in docs/adr explain the choices and what I would do in production.</a:t>
             </a:r>
           </a:p>
         </p:txBody>
@@ -7266,7 +7337,7 @@
                 </a:solidFill>
                 <a:latin typeface="Calibri"/>
               </a:rPr>
-              <a:t>From a change to a running system</a:t>
+              <a:t>Does it hold up when it grows?</a:t>
             </a:r>
           </a:p>
         </p:txBody>
@@ -7300,7 +7371,7 @@
                 </a:solidFill>
                 <a:latin typeface="Calibri"/>
               </a:rPr>
-              <a:t>I rehearsed the whole loop, and here is what I learned</a:t>
+              <a:t>I loaded 200 thousand bookings, loaded one pod to its limit, and sized the pods from measurements</a:t>
             </a:r>
           </a:p>
         </p:txBody>
@@ -7334,7 +7405,755 @@
                 </a:solidFill>
                 <a:latin typeface="Calibri"/>
               </a:rPr>
-              <a:t>CampusSlot   |   Ujjwal Jain   |   14 / 14</a:t>
+              <a:t>CampusSlot   |   Ujjwal Jain   |   14 / 15</a:t>
+            </a:r>
+          </a:p>
+        </p:txBody>
+      </p:sp>
+      <p:graphicFrame>
+        <p:nvGraphicFramePr>
+          <p:cNvPr id="6" name="Table 5"/>
+          <p:cNvGraphicFramePr>
+            <a:graphicFrameLocks noGrp="1"/>
+          </p:cNvGraphicFramePr>
+          <p:nvPr/>
+        </p:nvGraphicFramePr>
+        <p:xfrm>
+          <a:off x="548640" y="1737360"/>
+          <a:ext cx="7498080" cy="2194560"/>
+        </p:xfrm>
+        <a:graphic>
+          <a:graphicData uri="http://schemas.openxmlformats.org/drawingml/2006/table">
+            <a:tbl>
+              <a:tblPr firstRow="1" bandRow="1">
+                <a:tableStyleId>{5C22544A-7EE6-4342-B048-85BDC9FD1C3A}</a:tableStyleId>
+              </a:tblPr>
+              <a:tblGrid>
+                <a:gridCol w="4023360"/>
+                <a:gridCol w="1737360"/>
+                <a:gridCol w="1737360"/>
+              </a:tblGrid>
+              <a:tr h="365760">
+                <a:tc>
+                  <a:txBody>
+                    <a:bodyPr/>
+                    <a:lstStyle/>
+                    <a:p>
+                      <a:r>
+                        <a:rPr sz="1500" b="1">
+                          <a:solidFill>
+                            <a:srgbClr val="FFFFFF"/>
+                          </a:solidFill>
+                          <a:latin typeface="Calibri"/>
+                        </a:rPr>
+                        <a:t>What I measured</a:t>
+                      </a:r>
+                    </a:p>
+                  </a:txBody>
+                  <a:tcPr marL="73152" marR="73152">
+                    <a:solidFill>
+                      <a:srgbClr val="0F766E"/>
+                    </a:solidFill>
+                  </a:tcPr>
+                </a:tc>
+                <a:tc>
+                  <a:txBody>
+                    <a:bodyPr/>
+                    <a:lstStyle/>
+                    <a:p>
+                      <a:r>
+                        <a:rPr sz="1500" b="1">
+                          <a:solidFill>
+                            <a:srgbClr val="FFFFFF"/>
+                          </a:solidFill>
+                          <a:latin typeface="Calibri"/>
+                        </a:rPr>
+                        <a:t>Before</a:t>
+                      </a:r>
+                    </a:p>
+                  </a:txBody>
+                  <a:tcPr marL="73152" marR="73152">
+                    <a:solidFill>
+                      <a:srgbClr val="0F766E"/>
+                    </a:solidFill>
+                  </a:tcPr>
+                </a:tc>
+                <a:tc>
+                  <a:txBody>
+                    <a:bodyPr/>
+                    <a:lstStyle/>
+                    <a:p>
+                      <a:r>
+                        <a:rPr sz="1500" b="1">
+                          <a:solidFill>
+                            <a:srgbClr val="FFFFFF"/>
+                          </a:solidFill>
+                          <a:latin typeface="Calibri"/>
+                        </a:rPr>
+                        <a:t>After</a:t>
+                      </a:r>
+                    </a:p>
+                  </a:txBody>
+                  <a:tcPr marL="73152" marR="73152">
+                    <a:solidFill>
+                      <a:srgbClr val="0F766E"/>
+                    </a:solidFill>
+                  </a:tcPr>
+                </a:tc>
+              </a:tr>
+              <a:tr h="365760">
+                <a:tc>
+                  <a:txBody>
+                    <a:bodyPr/>
+                    <a:lstStyle/>
+                    <a:p>
+                      <a:r>
+                        <a:rPr sz="1500">
+                          <a:solidFill>
+                            <a:srgbClr val="12302D"/>
+                          </a:solidFill>
+                          <a:latin typeface="Calibri"/>
+                        </a:rPr>
+                        <a:t>Pages read, overlap check, 200k rows</a:t>
+                      </a:r>
+                    </a:p>
+                  </a:txBody>
+                  <a:tcPr marL="73152" marR="73152">
+                    <a:solidFill>
+                      <a:srgbClr val="FFFFFF"/>
+                    </a:solidFill>
+                  </a:tcPr>
+                </a:tc>
+                <a:tc>
+                  <a:txBody>
+                    <a:bodyPr/>
+                    <a:lstStyle/>
+                    <a:p>
+                      <a:r>
+                        <a:rPr sz="1500">
+                          <a:solidFill>
+                            <a:srgbClr val="12302D"/>
+                          </a:solidFill>
+                          <a:latin typeface="Calibri"/>
+                        </a:rPr>
+                        <a:t>2469</a:t>
+                      </a:r>
+                    </a:p>
+                  </a:txBody>
+                  <a:tcPr marL="73152" marR="73152">
+                    <a:solidFill>
+                      <a:srgbClr val="FFFFFF"/>
+                    </a:solidFill>
+                  </a:tcPr>
+                </a:tc>
+                <a:tc>
+                  <a:txBody>
+                    <a:bodyPr/>
+                    <a:lstStyle/>
+                    <a:p>
+                      <a:r>
+                        <a:rPr sz="1500">
+                          <a:solidFill>
+                            <a:srgbClr val="12302D"/>
+                          </a:solidFill>
+                          <a:latin typeface="Calibri"/>
+                        </a:rPr>
+                        <a:t>30</a:t>
+                      </a:r>
+                    </a:p>
+                  </a:txBody>
+                  <a:tcPr marL="73152" marR="73152">
+                    <a:solidFill>
+                      <a:srgbClr val="FFFFFF"/>
+                    </a:solidFill>
+                  </a:tcPr>
+                </a:tc>
+              </a:tr>
+              <a:tr h="365760">
+                <a:tc>
+                  <a:txBody>
+                    <a:bodyPr/>
+                    <a:lstStyle/>
+                    <a:p>
+                      <a:r>
+                        <a:rPr sz="1500">
+                          <a:solidFill>
+                            <a:srgbClr val="12302D"/>
+                          </a:solidFill>
+                          <a:latin typeface="Calibri"/>
+                        </a:rPr>
+                        <a:t>Day view, all rooms, 200k rows</a:t>
+                      </a:r>
+                    </a:p>
+                  </a:txBody>
+                  <a:tcPr marL="73152" marR="73152">
+                    <a:solidFill>
+                      <a:srgbClr val="D7ECE9"/>
+                    </a:solidFill>
+                  </a:tcPr>
+                </a:tc>
+                <a:tc>
+                  <a:txBody>
+                    <a:bodyPr/>
+                    <a:lstStyle/>
+                    <a:p>
+                      <a:r>
+                        <a:rPr sz="1500">
+                          <a:solidFill>
+                            <a:srgbClr val="12302D"/>
+                          </a:solidFill>
+                          <a:latin typeface="Calibri"/>
+                        </a:rPr>
+                        <a:t>21 req/s</a:t>
+                      </a:r>
+                    </a:p>
+                  </a:txBody>
+                  <a:tcPr marL="73152" marR="73152">
+                    <a:solidFill>
+                      <a:srgbClr val="D7ECE9"/>
+                    </a:solidFill>
+                  </a:tcPr>
+                </a:tc>
+                <a:tc>
+                  <a:txBody>
+                    <a:bodyPr/>
+                    <a:lstStyle/>
+                    <a:p>
+                      <a:r>
+                        <a:rPr sz="1500">
+                          <a:solidFill>
+                            <a:srgbClr val="12302D"/>
+                          </a:solidFill>
+                          <a:latin typeface="Calibri"/>
+                        </a:rPr>
+                        <a:t>113 req/s</a:t>
+                      </a:r>
+                    </a:p>
+                  </a:txBody>
+                  <a:tcPr marL="73152" marR="73152">
+                    <a:solidFill>
+                      <a:srgbClr val="D7ECE9"/>
+                    </a:solidFill>
+                  </a:tcPr>
+                </a:tc>
+              </a:tr>
+              <a:tr h="365760">
+                <a:tc>
+                  <a:txBody>
+                    <a:bodyPr/>
+                    <a:lstStyle/>
+                    <a:p>
+                      <a:r>
+                        <a:rPr sz="1500">
+                          <a:solidFill>
+                            <a:srgbClr val="12302D"/>
+                          </a:solidFill>
+                          <a:latin typeface="Calibri"/>
+                        </a:rPr>
+                        <a:t>One backend pod, room list</a:t>
+                      </a:r>
+                    </a:p>
+                  </a:txBody>
+                  <a:tcPr marL="73152" marR="73152">
+                    <a:solidFill>
+                      <a:srgbClr val="FFFFFF"/>
+                    </a:solidFill>
+                  </a:tcPr>
+                </a:tc>
+                <a:tc>
+                  <a:txBody>
+                    <a:bodyPr/>
+                    <a:lstStyle/>
+                    <a:p>
+                      <a:r>
+                        <a:rPr sz="1500">
+                          <a:solidFill>
+                            <a:srgbClr val="12302D"/>
+                          </a:solidFill>
+                          <a:latin typeface="Calibri"/>
+                        </a:rPr>
+                        <a:t>153 req/s</a:t>
+                      </a:r>
+                    </a:p>
+                  </a:txBody>
+                  <a:tcPr marL="73152" marR="73152">
+                    <a:solidFill>
+                      <a:srgbClr val="FFFFFF"/>
+                    </a:solidFill>
+                  </a:tcPr>
+                </a:tc>
+                <a:tc>
+                  <a:txBody>
+                    <a:bodyPr/>
+                    <a:lstStyle/>
+                    <a:p>
+                      <a:r>
+                        <a:rPr sz="1500">
+                          <a:solidFill>
+                            <a:srgbClr val="12302D"/>
+                          </a:solidFill>
+                          <a:latin typeface="Calibri"/>
+                        </a:rPr>
+                        <a:t>342 req/s</a:t>
+                      </a:r>
+                    </a:p>
+                  </a:txBody>
+                  <a:tcPr marL="73152" marR="73152">
+                    <a:solidFill>
+                      <a:srgbClr val="FFFFFF"/>
+                    </a:solidFill>
+                  </a:tcPr>
+                </a:tc>
+              </a:tr>
+              <a:tr h="365760">
+                <a:tc>
+                  <a:txBody>
+                    <a:bodyPr/>
+                    <a:lstStyle/>
+                    <a:p>
+                      <a:r>
+                        <a:rPr sz="1500">
+                          <a:solidFill>
+                            <a:srgbClr val="12302D"/>
+                          </a:solidFill>
+                          <a:latin typeface="Calibri"/>
+                        </a:rPr>
+                        <a:t>Pods needed for 60 req/s</a:t>
+                      </a:r>
+                    </a:p>
+                  </a:txBody>
+                  <a:tcPr marL="73152" marR="73152">
+                    <a:solidFill>
+                      <a:srgbClr val="D7ECE9"/>
+                    </a:solidFill>
+                  </a:tcPr>
+                </a:tc>
+                <a:tc>
+                  <a:txBody>
+                    <a:bodyPr/>
+                    <a:lstStyle/>
+                    <a:p>
+                      <a:r>
+                        <a:rPr sz="1500">
+                          <a:solidFill>
+                            <a:srgbClr val="12302D"/>
+                          </a:solidFill>
+                          <a:latin typeface="Calibri"/>
+                        </a:rPr>
+                        <a:t>5</a:t>
+                      </a:r>
+                    </a:p>
+                  </a:txBody>
+                  <a:tcPr marL="73152" marR="73152">
+                    <a:solidFill>
+                      <a:srgbClr val="D7ECE9"/>
+                    </a:solidFill>
+                  </a:tcPr>
+                </a:tc>
+                <a:tc>
+                  <a:txBody>
+                    <a:bodyPr/>
+                    <a:lstStyle/>
+                    <a:p>
+                      <a:r>
+                        <a:rPr sz="1500">
+                          <a:solidFill>
+                            <a:srgbClr val="12302D"/>
+                          </a:solidFill>
+                          <a:latin typeface="Calibri"/>
+                        </a:rPr>
+                        <a:t>2</a:t>
+                      </a:r>
+                    </a:p>
+                  </a:txBody>
+                  <a:tcPr marL="73152" marR="73152">
+                    <a:solidFill>
+                      <a:srgbClr val="D7ECE9"/>
+                    </a:solidFill>
+                  </a:tcPr>
+                </a:tc>
+              </a:tr>
+              <a:tr h="365760">
+                <a:tc>
+                  <a:txBody>
+                    <a:bodyPr/>
+                    <a:lstStyle/>
+                    <a:p>
+                      <a:r>
+                        <a:rPr sz="1500">
+                          <a:solidFill>
+                            <a:srgbClr val="12302D"/>
+                          </a:solidFill>
+                          <a:latin typeface="Calibri"/>
+                        </a:rPr>
+                        <a:t>Memory reserved for those pods</a:t>
+                      </a:r>
+                    </a:p>
+                  </a:txBody>
+                  <a:tcPr marL="73152" marR="73152">
+                    <a:solidFill>
+                      <a:srgbClr val="FFFFFF"/>
+                    </a:solidFill>
+                  </a:tcPr>
+                </a:tc>
+                <a:tc>
+                  <a:txBody>
+                    <a:bodyPr/>
+                    <a:lstStyle/>
+                    <a:p>
+                      <a:r>
+                        <a:rPr sz="1500">
+                          <a:solidFill>
+                            <a:srgbClr val="12302D"/>
+                          </a:solidFill>
+                          <a:latin typeface="Calibri"/>
+                        </a:rPr>
+                        <a:t>640 MiB</a:t>
+                      </a:r>
+                    </a:p>
+                  </a:txBody>
+                  <a:tcPr marL="73152" marR="73152">
+                    <a:solidFill>
+                      <a:srgbClr val="FFFFFF"/>
+                    </a:solidFill>
+                  </a:tcPr>
+                </a:tc>
+                <a:tc>
+                  <a:txBody>
+                    <a:bodyPr/>
+                    <a:lstStyle/>
+                    <a:p>
+                      <a:r>
+                        <a:rPr sz="1500">
+                          <a:solidFill>
+                            <a:srgbClr val="12302D"/>
+                          </a:solidFill>
+                          <a:latin typeface="Calibri"/>
+                        </a:rPr>
+                        <a:t>192 MiB</a:t>
+                      </a:r>
+                    </a:p>
+                  </a:txBody>
+                  <a:tcPr marL="73152" marR="73152">
+                    <a:solidFill>
+                      <a:srgbClr val="FFFFFF"/>
+                    </a:solidFill>
+                  </a:tcPr>
+                </a:tc>
+              </a:tr>
+            </a:tbl>
+          </a:graphicData>
+        </a:graphic>
+      </p:graphicFrame>
+      <p:sp>
+        <p:nvSpPr>
+          <p:cNvPr id="7" name="TextBox 6"/>
+          <p:cNvSpPr txBox="1"/>
+          <p:nvPr/>
+        </p:nvSpPr>
+        <p:spPr>
+          <a:xfrm>
+            <a:off x="8412480" y="1737360"/>
+            <a:ext cx="3474720" cy="3291840"/>
+          </a:xfrm>
+          <a:prstGeom prst="rect">
+            <a:avLst/>
+          </a:prstGeom>
+          <a:noFill/>
+        </p:spPr>
+        <p:txBody>
+          <a:bodyPr wrap="square">
+            <a:spAutoFit/>
+          </a:bodyPr>
+          <a:lstStyle/>
+          <a:p>
+            <a:pPr>
+              <a:spcAft>
+                <a:spcPts val="800"/>
+              </a:spcAft>
+            </a:pPr>
+            <a:r>
+              <a:rPr sz="1500" b="1">
+                <a:solidFill>
+                  <a:srgbClr val="12302D"/>
+                </a:solidFill>
+                <a:latin typeface="Calibri"/>
+              </a:rPr>
+              <a:t>•  Tried and rejected</a:t>
+            </a:r>
+          </a:p>
+          <a:p>
+            <a:pPr>
+              <a:spcAft>
+                <a:spcPts val="800"/>
+              </a:spcAft>
+            </a:pPr>
+            <a:r>
+              <a:rPr sz="1500" b="0">
+                <a:solidFill>
+                  <a:srgbClr val="12302D"/>
+                </a:solidFill>
+                <a:latin typeface="Calibri"/>
+              </a:rPr>
+              <a:t>•  Two workers: no gain, twice the memory, wrong metrics</a:t>
+            </a:r>
+          </a:p>
+          <a:p>
+            <a:pPr>
+              <a:spcAft>
+                <a:spcPts val="800"/>
+              </a:spcAft>
+            </a:pPr>
+            <a:r>
+              <a:rPr sz="1500" b="0">
+                <a:solidFill>
+                  <a:srgbClr val="12302D"/>
+                </a:solidFill>
+                <a:latin typeface="Calibri"/>
+              </a:rPr>
+              <a:t>•  ETag on the room list: no gain</a:t>
+            </a:r>
+          </a:p>
+          <a:p>
+            <a:pPr>
+              <a:spcAft>
+                <a:spcPts val="800"/>
+              </a:spcAft>
+            </a:pPr>
+            <a:r>
+              <a:rPr sz="1500" b="0">
+                <a:solidFill>
+                  <a:srgbClr val="12302D"/>
+                </a:solidFill>
+                <a:latin typeface="Calibri"/>
+              </a:rPr>
+              <a:t>•  Both removed from the code</a:t>
+            </a:r>
+          </a:p>
+        </p:txBody>
+      </p:sp>
+      <p:sp>
+        <p:nvSpPr>
+          <p:cNvPr id="8" name="TextBox 7"/>
+          <p:cNvSpPr txBox="1"/>
+          <p:nvPr/>
+        </p:nvSpPr>
+        <p:spPr>
+          <a:xfrm>
+            <a:off x="548640" y="5029200"/>
+            <a:ext cx="11155680" cy="1280160"/>
+          </a:xfrm>
+          <a:prstGeom prst="rect">
+            <a:avLst/>
+          </a:prstGeom>
+          <a:noFill/>
+        </p:spPr>
+        <p:txBody>
+          <a:bodyPr wrap="square">
+            <a:spAutoFit/>
+          </a:bodyPr>
+          <a:lstStyle/>
+          <a:p>
+            <a:pPr>
+              <a:spcAft>
+                <a:spcPts val="800"/>
+              </a:spcAft>
+            </a:pPr>
+            <a:r>
+              <a:rPr sz="1600" b="0">
+                <a:solidFill>
+                  <a:srgbClr val="12302D"/>
+                </a:solidFill>
+                <a:latin typeface="Calibri"/>
+              </a:rPr>
+              <a:t>•  The CPU limit that I wrote without measuring was the first bottleneck.</a:t>
+            </a:r>
+          </a:p>
+          <a:p>
+            <a:pPr>
+              <a:spcAft>
+                <a:spcPts val="800"/>
+              </a:spcAft>
+            </a:pPr>
+            <a:r>
+              <a:rPr sz="1600" b="0">
+                <a:solidFill>
+                  <a:srgbClr val="12302D"/>
+                </a:solidFill>
+                <a:latin typeface="Calibri"/>
+              </a:rPr>
+              <a:t>•  Right-sizing did not shrink everything: the CPU request went up, because the old one was too low.</a:t>
+            </a:r>
+          </a:p>
+        </p:txBody>
+      </p:sp>
+    </p:spTree>
+  </p:cSld>
+  <p:clrMapOvr>
+    <a:masterClrMapping/>
+  </p:clrMapOvr>
+</p:sld>
+</file>
+
+<file path=ppt/slides/slide15.xml><?xml version="1.0" encoding="utf-8"?>
+<p:sld xmlns:a="http://schemas.openxmlformats.org/drawingml/2006/main" xmlns:p="http://schemas.openxmlformats.org/presentationml/2006/main" xmlns:r="http://schemas.openxmlformats.org/officeDocument/2006/relationships">
+  <p:cSld>
+    <p:bg>
+      <p:bgPr>
+        <a:solidFill>
+          <a:srgbClr val="F4F7F6"/>
+        </a:solidFill>
+        <a:effectLst/>
+      </p:bgPr>
+    </p:bg>
+    <p:spTree>
+      <p:nvGrpSpPr>
+        <p:cNvPr id="1" name=""/>
+        <p:cNvGrpSpPr/>
+        <p:nvPr/>
+      </p:nvGrpSpPr>
+      <p:grpSpPr/>
+      <p:sp>
+        <p:nvSpPr>
+          <p:cNvPr id="2" name="Rectangle 1"/>
+          <p:cNvSpPr/>
+          <p:nvPr/>
+        </p:nvSpPr>
+        <p:spPr>
+          <a:xfrm>
+            <a:off x="0" y="0"/>
+            <a:ext cx="228600" cy="6858000"/>
+          </a:xfrm>
+          <a:prstGeom prst="rect">
+            <a:avLst/>
+          </a:prstGeom>
+          <a:solidFill>
+            <a:srgbClr val="0F766E"/>
+          </a:solidFill>
+          <a:ln>
+            <a:noFill/>
+          </a:ln>
+        </p:spPr>
+        <p:style>
+          <a:lnRef idx="1">
+            <a:schemeClr val="accent1"/>
+          </a:lnRef>
+          <a:fillRef idx="3">
+            <a:schemeClr val="accent1"/>
+          </a:fillRef>
+          <a:effectRef idx="2">
+            <a:schemeClr val="accent1"/>
+          </a:effectRef>
+          <a:fontRef idx="minor">
+            <a:schemeClr val="lt1"/>
+          </a:fontRef>
+        </p:style>
+        <p:txBody>
+          <a:bodyPr rtlCol="0" anchor="ctr"/>
+          <a:lstStyle/>
+          <a:p>
+            <a:pPr algn="ctr"/>
+          </a:p>
+        </p:txBody>
+      </p:sp>
+      <p:sp>
+        <p:nvSpPr>
+          <p:cNvPr id="3" name="TextBox 2"/>
+          <p:cNvSpPr txBox="1"/>
+          <p:nvPr/>
+        </p:nvSpPr>
+        <p:spPr>
+          <a:xfrm>
+            <a:off x="548640" y="320040"/>
+            <a:ext cx="11155680" cy="822960"/>
+          </a:xfrm>
+          <a:prstGeom prst="rect">
+            <a:avLst/>
+          </a:prstGeom>
+          <a:noFill/>
+        </p:spPr>
+        <p:txBody>
+          <a:bodyPr wrap="square">
+            <a:spAutoFit/>
+          </a:bodyPr>
+          <a:lstStyle/>
+          <a:p>
+            <a:r>
+              <a:rPr sz="3400" b="1">
+                <a:solidFill>
+                  <a:srgbClr val="12302D"/>
+                </a:solidFill>
+                <a:latin typeface="Calibri"/>
+              </a:rPr>
+              <a:t>From a change to a running system</a:t>
+            </a:r>
+          </a:p>
+        </p:txBody>
+      </p:sp>
+      <p:sp>
+        <p:nvSpPr>
+          <p:cNvPr id="4" name="TextBox 3"/>
+          <p:cNvSpPr txBox="1"/>
+          <p:nvPr/>
+        </p:nvSpPr>
+        <p:spPr>
+          <a:xfrm>
+            <a:off x="548640" y="1005840"/>
+            <a:ext cx="11155680" cy="457200"/>
+          </a:xfrm>
+          <a:prstGeom prst="rect">
+            <a:avLst/>
+          </a:prstGeom>
+          <a:noFill/>
+        </p:spPr>
+        <p:txBody>
+          <a:bodyPr wrap="square">
+            <a:spAutoFit/>
+          </a:bodyPr>
+          <a:lstStyle/>
+          <a:p>
+            <a:r>
+              <a:rPr sz="1800">
+                <a:solidFill>
+                  <a:srgbClr val="5B726F"/>
+                </a:solidFill>
+                <a:latin typeface="Calibri"/>
+              </a:rPr>
+              <a:t>I rehearsed the whole loop, and here is what I learned</a:t>
+            </a:r>
+          </a:p>
+        </p:txBody>
+      </p:sp>
+      <p:sp>
+        <p:nvSpPr>
+          <p:cNvPr id="5" name="TextBox 4"/>
+          <p:cNvSpPr txBox="1"/>
+          <p:nvPr/>
+        </p:nvSpPr>
+        <p:spPr>
+          <a:xfrm>
+            <a:off x="548640" y="6446520"/>
+            <a:ext cx="11155680" cy="320040"/>
+          </a:xfrm>
+          <a:prstGeom prst="rect">
+            <a:avLst/>
+          </a:prstGeom>
+          <a:noFill/>
+        </p:spPr>
+        <p:txBody>
+          <a:bodyPr wrap="none">
+            <a:spAutoFit/>
+          </a:bodyPr>
+          <a:lstStyle/>
+          <a:p>
+            <a:r>
+              <a:rPr sz="1100">
+                <a:solidFill>
+                  <a:srgbClr val="5B726F"/>
+                </a:solidFill>
+                <a:latin typeface="Calibri"/>
+              </a:rPr>
+              <a:t>CampusSlot   |   Ujjwal Jain   |   15 / 15</a:t>
             </a:r>
           </a:p>
         </p:txBody>
@@ -8403,7 +9222,7 @@
                 </a:solidFill>
                 <a:latin typeface="Calibri"/>
               </a:rPr>
-              <a:t>CampusSlot   |   Ujjwal Jain   |   2 / 14</a:t>
+              <a:t>CampusSlot   |   Ujjwal Jain   |   2 / 15</a:t>
             </a:r>
           </a:p>
         </p:txBody>
@@ -9738,7 +10557,7 @@
                 </a:solidFill>
                 <a:latin typeface="Calibri"/>
               </a:rPr>
-              <a:t>CampusSlot   |   Ujjwal Jain   |   3 / 14</a:t>
+              <a:t>CampusSlot   |   Ujjwal Jain   |   3 / 15</a:t>
             </a:r>
           </a:p>
         </p:txBody>
@@ -10187,7 +11006,7 @@
                 </a:solidFill>
                 <a:latin typeface="Calibri"/>
               </a:rPr>
-              <a:t>CampusSlot   |   Ujjwal Jain   |   4 / 14</a:t>
+              <a:t>CampusSlot   |   Ujjwal Jain   |   4 / 15</a:t>
             </a:r>
           </a:p>
         </p:txBody>
@@ -10609,7 +11428,7 @@
                 </a:solidFill>
                 <a:latin typeface="Calibri"/>
               </a:rPr>
-              <a:t>CampusSlot   |   Ujjwal Jain   |   5 / 14</a:t>
+              <a:t>CampusSlot   |   Ujjwal Jain   |   5 / 15</a:t>
             </a:r>
           </a:p>
         </p:txBody>
@@ -11055,7 +11874,7 @@
                 </a:solidFill>
                 <a:latin typeface="Calibri"/>
               </a:rPr>
-              <a:t>CampusSlot   |   Ujjwal Jain   |   6 / 14</a:t>
+              <a:t>CampusSlot   |   Ujjwal Jain   |   6 / 15</a:t>
             </a:r>
           </a:p>
         </p:txBody>
@@ -11658,7 +12477,7 @@
                 </a:solidFill>
                 <a:latin typeface="Calibri"/>
               </a:rPr>
-              <a:t>CampusSlot   |   Ujjwal Jain   |   7 / 14</a:t>
+              <a:t>CampusSlot   |   Ujjwal Jain   |   7 / 15</a:t>
             </a:r>
           </a:p>
         </p:txBody>
@@ -12152,7 +12971,7 @@
                 </a:solidFill>
                 <a:latin typeface="Calibri"/>
               </a:rPr>
-              <a:t>CampusSlot   |   Ujjwal Jain   |   8 / 14</a:t>
+              <a:t>CampusSlot   |   Ujjwal Jain   |   8 / 15</a:t>
             </a:r>
           </a:p>
         </p:txBody>
@@ -12714,7 +13533,7 @@
                 </a:solidFill>
                 <a:latin typeface="Calibri"/>
               </a:rPr>
-              <a:t>CampusSlot   |   Ujjwal Jain   |   9 / 14</a:t>
+              <a:t>CampusSlot   |   Ujjwal Jain   |   9 / 15</a:t>
             </a:r>
           </a:p>
         </p:txBody>

</xml_diff>

<commit_message>
Measure query cost at scale, load test one pod and size the pods from measurements (#11)
Queries: the overlap check, day view and statistics read the whole table (2469 pages at
200 thousand bookings). A range operator and a GiST index (migration 0004) bring it to 30 pages,
flat as the table grows.

Load test: one pod was throttled at its 500m CPU limit. 1000m gives 342 instead of 153 requests
per second. Two workers and an ETag were tried and rejected.

Sizing: requests set from measured usage and the autoscaler target moved to 70 percent. The same
60 requests per second now needs 2 pods instead of 5.
</commit_message>
<xml_diff>
--- a/docs/presentation/CampusSlot-final-presentation.pptx
+++ b/docs/presentation/CampusSlot-final-presentation.pptx
@@ -19,6 +19,7 @@
     <p:sldId id="267" r:id="rId19"/>
     <p:sldId id="268" r:id="rId20"/>
     <p:sldId id="269" r:id="rId21"/>
+    <p:sldId id="270" r:id="rId22"/>
   </p:sldIdLst>
   <p:sldSz cx="12191695" cy="6858000" type="screen4x3"/>
   <p:notesSz cx="6858000" cy="9144000"/>
@@ -795,7 +796,7 @@
           <a:lstStyle/>
           <a:p>
             <a:r>
-              <a:t>Every change costs something, and I wrote the cost down. Waiting eight seconds before a pod stops makes every rollout slower. Signing and verifying the images adds about a minute to every pipeline run, from three runs. The backup stays inside the cluster, so it protects against mistakes but not against losing the cluster. There is one database pod, so an outage of about six seconds remains, and I only made it visible. On the right is what I planned and chose not to do, so nobody has to guess. Twelve short decision records explain the reasons for the main choices, with what I would do in production.</a:t>
+              <a:t>Every change costs something, and I wrote the cost down. Waiting eight seconds before a pod stops makes every rollout slower. Signing and verifying the images adds about a minute to every pipeline run, from three runs. The backup stays inside the cluster, so it protects against mistakes but not against losing the cluster. There is one database pod, so an outage of about six seconds remains, and I only made it visible. On the right is what I planned and chose not to do, so nobody has to guess. Fourteen short decision records explain the reasons for the main choices, with what I would do in production.</a:t>
             </a:r>
           </a:p>
         </p:txBody>
@@ -821,6 +822,76 @@
 </file>
 
 <file path=ppt/notesSlides/notesSlide14.xml><?xml version="1.0" encoding="utf-8"?>
+<p:notes xmlns:a="http://schemas.openxmlformats.org/drawingml/2006/main" xmlns:p="http://schemas.openxmlformats.org/presentationml/2006/main" xmlns:r="http://schemas.openxmlformats.org/officeDocument/2006/relationships">
+  <p:cSld>
+    <p:spTree>
+      <p:nvGrpSpPr>
+        <p:cNvPr id="1" name=""/>
+        <p:cNvGrpSpPr/>
+        <p:nvPr/>
+      </p:nvGrpSpPr>
+      <p:grpSpPr>
+        <a:xfrm>
+          <a:off x="0" y="0"/>
+          <a:ext cx="0" cy="0"/>
+          <a:chOff x="0" y="0"/>
+          <a:chExt cx="0" cy="0"/>
+        </a:xfrm>
+      </p:grpSpPr>
+      <p:sp>
+        <p:nvSpPr>
+          <p:cNvPr id="2" name="Slide Image Placeholder 1"/>
+          <p:cNvSpPr>
+            <a:spLocks noGrp="1"/>
+          </p:cNvSpPr>
+          <p:nvPr>
+            <p:ph type="sldImg" idx="2"/>
+          </p:nvPr>
+        </p:nvSpPr>
+        <p:spPr/>
+      </p:sp>
+      <p:sp>
+        <p:nvSpPr>
+          <p:cNvPr id="3" name="Notes Placeholder 2"/>
+          <p:cNvSpPr>
+            <a:spLocks noGrp="1"/>
+          </p:cNvSpPr>
+          <p:nvPr>
+            <p:ph type="body" idx="3" sz="quarter"/>
+          </p:nvPr>
+        </p:nvSpPr>
+        <p:spPr/>
+        <p:txBody>
+          <a:bodyPr/>
+          <a:lstStyle/>
+          <a:p>
+            <a:r>
+              <a:t>I wanted to know what happens when the data and the traffic grow, so I measured instead of guessing. With 200 thousand bookings, the question 'which bookings overlap this time' read the whole table, about two and a half thousand pages, and the cost grew with the table. Writing the same question as a range, with an index made for ranges, cut it to thirty pages and kept it flat. Through the application, the day view went from 21 to 113 requests per second. Then I loaded one pod until it stopped. It was throttled by the CPU limit I had written without measuring. Doubling the limit made it more than twice as fast. I also tried two ideas that I expected to help, more worker processes and caching, and neither did anything, so I removed them from the code. Finally, I sized the CPU and memory from what the pods really use. My old request was so low that 60 requests per second made the autoscaler run five pods, and with the measured request it runs two, with the same CPU reserved and a third of the memory. The sample sizes are small and the machine is a shared laptop cluster, and the documents say so.</a:t>
+            </a:r>
+          </a:p>
+        </p:txBody>
+      </p:sp>
+      <p:sp>
+        <p:nvSpPr>
+          <p:cNvPr id="4" name="Slide Number Placeholder 3"/>
+          <p:cNvSpPr>
+            <a:spLocks noGrp="1"/>
+          </p:cNvSpPr>
+          <p:nvPr>
+            <p:ph type="sldNum" idx="5" sz="quarter"/>
+          </p:nvPr>
+        </p:nvSpPr>
+        <p:spPr/>
+      </p:sp>
+    </p:spTree>
+  </p:cSld>
+  <p:clrMapOvr>
+    <a:masterClrMapping/>
+  </p:clrMapOvr>
+</p:notes>
+</file>
+
+<file path=ppt/notesSlides/notesSlide15.xml><?xml version="1.0" encoding="utf-8"?>
 <p:notes xmlns:a="http://schemas.openxmlformats.org/drawingml/2006/main" xmlns:p="http://schemas.openxmlformats.org/presentationml/2006/main" xmlns:r="http://schemas.openxmlformats.org/officeDocument/2006/relationships">
   <p:cSld>
     <p:spTree>
@@ -4579,7 +4650,7 @@
                 </a:solidFill>
                 <a:latin typeface="Calibri"/>
               </a:rPr>
-              <a:t>CampusSlot   |   Ujjwal Jain   |   1 / 14</a:t>
+              <a:t>CampusSlot   |   Ujjwal Jain   |   1 / 15</a:t>
             </a:r>
           </a:p>
         </p:txBody>
@@ -4921,7 +4992,7 @@
                 </a:solidFill>
                 <a:latin typeface="Calibri"/>
               </a:rPr>
-              <a:t>CampusSlot   |   Ujjwal Jain   |   10 / 14</a:t>
+              <a:t>CampusSlot   |   Ujjwal Jain   |   10 / 15</a:t>
             </a:r>
           </a:p>
         </p:txBody>
@@ -5367,7 +5438,7 @@
                 </a:solidFill>
                 <a:latin typeface="Calibri"/>
               </a:rPr>
-              <a:t>CampusSlot   |   Ujjwal Jain   |   11 / 14</a:t>
+              <a:t>CampusSlot   |   Ujjwal Jain   |   11 / 15</a:t>
             </a:r>
           </a:p>
         </p:txBody>
@@ -5972,7 +6043,7 @@
                 </a:solidFill>
                 <a:latin typeface="Calibri"/>
               </a:rPr>
-              <a:t>CampusSlot   |   Ujjwal Jain   |   12 / 14</a:t>
+              <a:t>CampusSlot   |   Ujjwal Jain   |   12 / 15</a:t>
             </a:r>
           </a:p>
         </p:txBody>
@@ -6701,7 +6772,7 @@
                 </a:solidFill>
                 <a:latin typeface="Calibri"/>
               </a:rPr>
-              <a:t>CampusSlot   |   Ujjwal Jain   |   13 / 14</a:t>
+              <a:t>CampusSlot   |   Ujjwal Jain   |   13 / 15</a:t>
             </a:r>
           </a:p>
         </p:txBody>
@@ -7028,7 +7099,7 @@
                 </a:solidFill>
                 <a:latin typeface="Calibri"/>
               </a:rPr>
-              <a:t>•  Load test and tuning</a:t>
+              <a:t>•  Rollback drill</a:t>
             </a:r>
           </a:p>
           <a:p>
@@ -7044,7 +7115,7 @@
                 </a:solidFill>
                 <a:latin typeface="Calibri"/>
               </a:rPr>
-              <a:t>•  200 thousand row query plans</a:t>
+              <a:t>•  Automated promotion</a:t>
             </a:r>
           </a:p>
           <a:p>
@@ -7060,7 +7131,7 @@
                 </a:solidFill>
                 <a:latin typeface="Calibri"/>
               </a:rPr>
-              <a:t>•  Right-sizing from measured usage</a:t>
+              <a:t>•  Network policies</a:t>
             </a:r>
           </a:p>
           <a:p>
@@ -7076,7 +7147,7 @@
                 </a:solidFill>
                 <a:latin typeface="Calibri"/>
               </a:rPr>
-              <a:t>•  Rollback drill</a:t>
+              <a:t>•  Alert delivery (no Alertmanager)</a:t>
             </a:r>
           </a:p>
           <a:p>
@@ -7092,7 +7163,7 @@
                 </a:solidFill>
                 <a:latin typeface="Calibri"/>
               </a:rPr>
-              <a:t>•  Automated promotion</a:t>
+              <a:t>•  Write-heavy load test</a:t>
             </a:r>
           </a:p>
           <a:p>
@@ -7108,7 +7179,7 @@
                 </a:solidFill>
                 <a:latin typeface="Calibri"/>
               </a:rPr>
-              <a:t>•  Network policies</a:t>
+              <a:t>•  Why two workers gave no gain</a:t>
             </a:r>
           </a:p>
           <a:p>
@@ -7124,7 +7195,7 @@
                 </a:solidFill>
                 <a:latin typeface="Calibri"/>
               </a:rPr>
-              <a:t>•  Alert delivery (no Alertmanager)</a:t>
+              <a:t>•  Backups outside the cluster</a:t>
             </a:r>
           </a:p>
         </p:txBody>
@@ -7163,7 +7234,7 @@
                 </a:solidFill>
                 <a:latin typeface="Calibri"/>
               </a:rPr>
-              <a:t>12 decision records in docs/adr explain the choices and what I would do in production.</a:t>
+              <a:t>14 decision records in docs/adr explain the choices and what I would do in production.</a:t>
             </a:r>
           </a:p>
         </p:txBody>
@@ -7266,7 +7337,7 @@
                 </a:solidFill>
                 <a:latin typeface="Calibri"/>
               </a:rPr>
-              <a:t>From a change to a running system</a:t>
+              <a:t>Does it hold up when it grows?</a:t>
             </a:r>
           </a:p>
         </p:txBody>
@@ -7300,7 +7371,7 @@
                 </a:solidFill>
                 <a:latin typeface="Calibri"/>
               </a:rPr>
-              <a:t>I rehearsed the whole loop, and here is what I learned</a:t>
+              <a:t>I loaded 200 thousand bookings, loaded one pod to its limit, and sized the pods from measurements</a:t>
             </a:r>
           </a:p>
         </p:txBody>
@@ -7334,7 +7405,755 @@
                 </a:solidFill>
                 <a:latin typeface="Calibri"/>
               </a:rPr>
-              <a:t>CampusSlot   |   Ujjwal Jain   |   14 / 14</a:t>
+              <a:t>CampusSlot   |   Ujjwal Jain   |   14 / 15</a:t>
+            </a:r>
+          </a:p>
+        </p:txBody>
+      </p:sp>
+      <p:graphicFrame>
+        <p:nvGraphicFramePr>
+          <p:cNvPr id="6" name="Table 5"/>
+          <p:cNvGraphicFramePr>
+            <a:graphicFrameLocks noGrp="1"/>
+          </p:cNvGraphicFramePr>
+          <p:nvPr/>
+        </p:nvGraphicFramePr>
+        <p:xfrm>
+          <a:off x="548640" y="1737360"/>
+          <a:ext cx="7498080" cy="2194560"/>
+        </p:xfrm>
+        <a:graphic>
+          <a:graphicData uri="http://schemas.openxmlformats.org/drawingml/2006/table">
+            <a:tbl>
+              <a:tblPr firstRow="1" bandRow="1">
+                <a:tableStyleId>{5C22544A-7EE6-4342-B048-85BDC9FD1C3A}</a:tableStyleId>
+              </a:tblPr>
+              <a:tblGrid>
+                <a:gridCol w="4023360"/>
+                <a:gridCol w="1737360"/>
+                <a:gridCol w="1737360"/>
+              </a:tblGrid>
+              <a:tr h="365760">
+                <a:tc>
+                  <a:txBody>
+                    <a:bodyPr/>
+                    <a:lstStyle/>
+                    <a:p>
+                      <a:r>
+                        <a:rPr sz="1500" b="1">
+                          <a:solidFill>
+                            <a:srgbClr val="FFFFFF"/>
+                          </a:solidFill>
+                          <a:latin typeface="Calibri"/>
+                        </a:rPr>
+                        <a:t>What I measured</a:t>
+                      </a:r>
+                    </a:p>
+                  </a:txBody>
+                  <a:tcPr marL="73152" marR="73152">
+                    <a:solidFill>
+                      <a:srgbClr val="0F766E"/>
+                    </a:solidFill>
+                  </a:tcPr>
+                </a:tc>
+                <a:tc>
+                  <a:txBody>
+                    <a:bodyPr/>
+                    <a:lstStyle/>
+                    <a:p>
+                      <a:r>
+                        <a:rPr sz="1500" b="1">
+                          <a:solidFill>
+                            <a:srgbClr val="FFFFFF"/>
+                          </a:solidFill>
+                          <a:latin typeface="Calibri"/>
+                        </a:rPr>
+                        <a:t>Before</a:t>
+                      </a:r>
+                    </a:p>
+                  </a:txBody>
+                  <a:tcPr marL="73152" marR="73152">
+                    <a:solidFill>
+                      <a:srgbClr val="0F766E"/>
+                    </a:solidFill>
+                  </a:tcPr>
+                </a:tc>
+                <a:tc>
+                  <a:txBody>
+                    <a:bodyPr/>
+                    <a:lstStyle/>
+                    <a:p>
+                      <a:r>
+                        <a:rPr sz="1500" b="1">
+                          <a:solidFill>
+                            <a:srgbClr val="FFFFFF"/>
+                          </a:solidFill>
+                          <a:latin typeface="Calibri"/>
+                        </a:rPr>
+                        <a:t>After</a:t>
+                      </a:r>
+                    </a:p>
+                  </a:txBody>
+                  <a:tcPr marL="73152" marR="73152">
+                    <a:solidFill>
+                      <a:srgbClr val="0F766E"/>
+                    </a:solidFill>
+                  </a:tcPr>
+                </a:tc>
+              </a:tr>
+              <a:tr h="365760">
+                <a:tc>
+                  <a:txBody>
+                    <a:bodyPr/>
+                    <a:lstStyle/>
+                    <a:p>
+                      <a:r>
+                        <a:rPr sz="1500">
+                          <a:solidFill>
+                            <a:srgbClr val="12302D"/>
+                          </a:solidFill>
+                          <a:latin typeface="Calibri"/>
+                        </a:rPr>
+                        <a:t>Pages read, overlap check, 200k rows</a:t>
+                      </a:r>
+                    </a:p>
+                  </a:txBody>
+                  <a:tcPr marL="73152" marR="73152">
+                    <a:solidFill>
+                      <a:srgbClr val="FFFFFF"/>
+                    </a:solidFill>
+                  </a:tcPr>
+                </a:tc>
+                <a:tc>
+                  <a:txBody>
+                    <a:bodyPr/>
+                    <a:lstStyle/>
+                    <a:p>
+                      <a:r>
+                        <a:rPr sz="1500">
+                          <a:solidFill>
+                            <a:srgbClr val="12302D"/>
+                          </a:solidFill>
+                          <a:latin typeface="Calibri"/>
+                        </a:rPr>
+                        <a:t>2469</a:t>
+                      </a:r>
+                    </a:p>
+                  </a:txBody>
+                  <a:tcPr marL="73152" marR="73152">
+                    <a:solidFill>
+                      <a:srgbClr val="FFFFFF"/>
+                    </a:solidFill>
+                  </a:tcPr>
+                </a:tc>
+                <a:tc>
+                  <a:txBody>
+                    <a:bodyPr/>
+                    <a:lstStyle/>
+                    <a:p>
+                      <a:r>
+                        <a:rPr sz="1500">
+                          <a:solidFill>
+                            <a:srgbClr val="12302D"/>
+                          </a:solidFill>
+                          <a:latin typeface="Calibri"/>
+                        </a:rPr>
+                        <a:t>30</a:t>
+                      </a:r>
+                    </a:p>
+                  </a:txBody>
+                  <a:tcPr marL="73152" marR="73152">
+                    <a:solidFill>
+                      <a:srgbClr val="FFFFFF"/>
+                    </a:solidFill>
+                  </a:tcPr>
+                </a:tc>
+              </a:tr>
+              <a:tr h="365760">
+                <a:tc>
+                  <a:txBody>
+                    <a:bodyPr/>
+                    <a:lstStyle/>
+                    <a:p>
+                      <a:r>
+                        <a:rPr sz="1500">
+                          <a:solidFill>
+                            <a:srgbClr val="12302D"/>
+                          </a:solidFill>
+                          <a:latin typeface="Calibri"/>
+                        </a:rPr>
+                        <a:t>Day view, all rooms, 200k rows</a:t>
+                      </a:r>
+                    </a:p>
+                  </a:txBody>
+                  <a:tcPr marL="73152" marR="73152">
+                    <a:solidFill>
+                      <a:srgbClr val="D7ECE9"/>
+                    </a:solidFill>
+                  </a:tcPr>
+                </a:tc>
+                <a:tc>
+                  <a:txBody>
+                    <a:bodyPr/>
+                    <a:lstStyle/>
+                    <a:p>
+                      <a:r>
+                        <a:rPr sz="1500">
+                          <a:solidFill>
+                            <a:srgbClr val="12302D"/>
+                          </a:solidFill>
+                          <a:latin typeface="Calibri"/>
+                        </a:rPr>
+                        <a:t>21 req/s</a:t>
+                      </a:r>
+                    </a:p>
+                  </a:txBody>
+                  <a:tcPr marL="73152" marR="73152">
+                    <a:solidFill>
+                      <a:srgbClr val="D7ECE9"/>
+                    </a:solidFill>
+                  </a:tcPr>
+                </a:tc>
+                <a:tc>
+                  <a:txBody>
+                    <a:bodyPr/>
+                    <a:lstStyle/>
+                    <a:p>
+                      <a:r>
+                        <a:rPr sz="1500">
+                          <a:solidFill>
+                            <a:srgbClr val="12302D"/>
+                          </a:solidFill>
+                          <a:latin typeface="Calibri"/>
+                        </a:rPr>
+                        <a:t>113 req/s</a:t>
+                      </a:r>
+                    </a:p>
+                  </a:txBody>
+                  <a:tcPr marL="73152" marR="73152">
+                    <a:solidFill>
+                      <a:srgbClr val="D7ECE9"/>
+                    </a:solidFill>
+                  </a:tcPr>
+                </a:tc>
+              </a:tr>
+              <a:tr h="365760">
+                <a:tc>
+                  <a:txBody>
+                    <a:bodyPr/>
+                    <a:lstStyle/>
+                    <a:p>
+                      <a:r>
+                        <a:rPr sz="1500">
+                          <a:solidFill>
+                            <a:srgbClr val="12302D"/>
+                          </a:solidFill>
+                          <a:latin typeface="Calibri"/>
+                        </a:rPr>
+                        <a:t>One backend pod, room list</a:t>
+                      </a:r>
+                    </a:p>
+                  </a:txBody>
+                  <a:tcPr marL="73152" marR="73152">
+                    <a:solidFill>
+                      <a:srgbClr val="FFFFFF"/>
+                    </a:solidFill>
+                  </a:tcPr>
+                </a:tc>
+                <a:tc>
+                  <a:txBody>
+                    <a:bodyPr/>
+                    <a:lstStyle/>
+                    <a:p>
+                      <a:r>
+                        <a:rPr sz="1500">
+                          <a:solidFill>
+                            <a:srgbClr val="12302D"/>
+                          </a:solidFill>
+                          <a:latin typeface="Calibri"/>
+                        </a:rPr>
+                        <a:t>153 req/s</a:t>
+                      </a:r>
+                    </a:p>
+                  </a:txBody>
+                  <a:tcPr marL="73152" marR="73152">
+                    <a:solidFill>
+                      <a:srgbClr val="FFFFFF"/>
+                    </a:solidFill>
+                  </a:tcPr>
+                </a:tc>
+                <a:tc>
+                  <a:txBody>
+                    <a:bodyPr/>
+                    <a:lstStyle/>
+                    <a:p>
+                      <a:r>
+                        <a:rPr sz="1500">
+                          <a:solidFill>
+                            <a:srgbClr val="12302D"/>
+                          </a:solidFill>
+                          <a:latin typeface="Calibri"/>
+                        </a:rPr>
+                        <a:t>342 req/s</a:t>
+                      </a:r>
+                    </a:p>
+                  </a:txBody>
+                  <a:tcPr marL="73152" marR="73152">
+                    <a:solidFill>
+                      <a:srgbClr val="FFFFFF"/>
+                    </a:solidFill>
+                  </a:tcPr>
+                </a:tc>
+              </a:tr>
+              <a:tr h="365760">
+                <a:tc>
+                  <a:txBody>
+                    <a:bodyPr/>
+                    <a:lstStyle/>
+                    <a:p>
+                      <a:r>
+                        <a:rPr sz="1500">
+                          <a:solidFill>
+                            <a:srgbClr val="12302D"/>
+                          </a:solidFill>
+                          <a:latin typeface="Calibri"/>
+                        </a:rPr>
+                        <a:t>Pods needed for 60 req/s</a:t>
+                      </a:r>
+                    </a:p>
+                  </a:txBody>
+                  <a:tcPr marL="73152" marR="73152">
+                    <a:solidFill>
+                      <a:srgbClr val="D7ECE9"/>
+                    </a:solidFill>
+                  </a:tcPr>
+                </a:tc>
+                <a:tc>
+                  <a:txBody>
+                    <a:bodyPr/>
+                    <a:lstStyle/>
+                    <a:p>
+                      <a:r>
+                        <a:rPr sz="1500">
+                          <a:solidFill>
+                            <a:srgbClr val="12302D"/>
+                          </a:solidFill>
+                          <a:latin typeface="Calibri"/>
+                        </a:rPr>
+                        <a:t>5</a:t>
+                      </a:r>
+                    </a:p>
+                  </a:txBody>
+                  <a:tcPr marL="73152" marR="73152">
+                    <a:solidFill>
+                      <a:srgbClr val="D7ECE9"/>
+                    </a:solidFill>
+                  </a:tcPr>
+                </a:tc>
+                <a:tc>
+                  <a:txBody>
+                    <a:bodyPr/>
+                    <a:lstStyle/>
+                    <a:p>
+                      <a:r>
+                        <a:rPr sz="1500">
+                          <a:solidFill>
+                            <a:srgbClr val="12302D"/>
+                          </a:solidFill>
+                          <a:latin typeface="Calibri"/>
+                        </a:rPr>
+                        <a:t>2</a:t>
+                      </a:r>
+                    </a:p>
+                  </a:txBody>
+                  <a:tcPr marL="73152" marR="73152">
+                    <a:solidFill>
+                      <a:srgbClr val="D7ECE9"/>
+                    </a:solidFill>
+                  </a:tcPr>
+                </a:tc>
+              </a:tr>
+              <a:tr h="365760">
+                <a:tc>
+                  <a:txBody>
+                    <a:bodyPr/>
+                    <a:lstStyle/>
+                    <a:p>
+                      <a:r>
+                        <a:rPr sz="1500">
+                          <a:solidFill>
+                            <a:srgbClr val="12302D"/>
+                          </a:solidFill>
+                          <a:latin typeface="Calibri"/>
+                        </a:rPr>
+                        <a:t>Memory reserved for those pods</a:t>
+                      </a:r>
+                    </a:p>
+                  </a:txBody>
+                  <a:tcPr marL="73152" marR="73152">
+                    <a:solidFill>
+                      <a:srgbClr val="FFFFFF"/>
+                    </a:solidFill>
+                  </a:tcPr>
+                </a:tc>
+                <a:tc>
+                  <a:txBody>
+                    <a:bodyPr/>
+                    <a:lstStyle/>
+                    <a:p>
+                      <a:r>
+                        <a:rPr sz="1500">
+                          <a:solidFill>
+                            <a:srgbClr val="12302D"/>
+                          </a:solidFill>
+                          <a:latin typeface="Calibri"/>
+                        </a:rPr>
+                        <a:t>640 MiB</a:t>
+                      </a:r>
+                    </a:p>
+                  </a:txBody>
+                  <a:tcPr marL="73152" marR="73152">
+                    <a:solidFill>
+                      <a:srgbClr val="FFFFFF"/>
+                    </a:solidFill>
+                  </a:tcPr>
+                </a:tc>
+                <a:tc>
+                  <a:txBody>
+                    <a:bodyPr/>
+                    <a:lstStyle/>
+                    <a:p>
+                      <a:r>
+                        <a:rPr sz="1500">
+                          <a:solidFill>
+                            <a:srgbClr val="12302D"/>
+                          </a:solidFill>
+                          <a:latin typeface="Calibri"/>
+                        </a:rPr>
+                        <a:t>192 MiB</a:t>
+                      </a:r>
+                    </a:p>
+                  </a:txBody>
+                  <a:tcPr marL="73152" marR="73152">
+                    <a:solidFill>
+                      <a:srgbClr val="FFFFFF"/>
+                    </a:solidFill>
+                  </a:tcPr>
+                </a:tc>
+              </a:tr>
+            </a:tbl>
+          </a:graphicData>
+        </a:graphic>
+      </p:graphicFrame>
+      <p:sp>
+        <p:nvSpPr>
+          <p:cNvPr id="7" name="TextBox 6"/>
+          <p:cNvSpPr txBox="1"/>
+          <p:nvPr/>
+        </p:nvSpPr>
+        <p:spPr>
+          <a:xfrm>
+            <a:off x="8412480" y="1737360"/>
+            <a:ext cx="3474720" cy="3291840"/>
+          </a:xfrm>
+          <a:prstGeom prst="rect">
+            <a:avLst/>
+          </a:prstGeom>
+          <a:noFill/>
+        </p:spPr>
+        <p:txBody>
+          <a:bodyPr wrap="square">
+            <a:spAutoFit/>
+          </a:bodyPr>
+          <a:lstStyle/>
+          <a:p>
+            <a:pPr>
+              <a:spcAft>
+                <a:spcPts val="800"/>
+              </a:spcAft>
+            </a:pPr>
+            <a:r>
+              <a:rPr sz="1500" b="1">
+                <a:solidFill>
+                  <a:srgbClr val="12302D"/>
+                </a:solidFill>
+                <a:latin typeface="Calibri"/>
+              </a:rPr>
+              <a:t>•  Tried and rejected</a:t>
+            </a:r>
+          </a:p>
+          <a:p>
+            <a:pPr>
+              <a:spcAft>
+                <a:spcPts val="800"/>
+              </a:spcAft>
+            </a:pPr>
+            <a:r>
+              <a:rPr sz="1500" b="0">
+                <a:solidFill>
+                  <a:srgbClr val="12302D"/>
+                </a:solidFill>
+                <a:latin typeface="Calibri"/>
+              </a:rPr>
+              <a:t>•  Two workers: no gain, twice the memory, wrong metrics</a:t>
+            </a:r>
+          </a:p>
+          <a:p>
+            <a:pPr>
+              <a:spcAft>
+                <a:spcPts val="800"/>
+              </a:spcAft>
+            </a:pPr>
+            <a:r>
+              <a:rPr sz="1500" b="0">
+                <a:solidFill>
+                  <a:srgbClr val="12302D"/>
+                </a:solidFill>
+                <a:latin typeface="Calibri"/>
+              </a:rPr>
+              <a:t>•  ETag on the room list: no gain</a:t>
+            </a:r>
+          </a:p>
+          <a:p>
+            <a:pPr>
+              <a:spcAft>
+                <a:spcPts val="800"/>
+              </a:spcAft>
+            </a:pPr>
+            <a:r>
+              <a:rPr sz="1500" b="0">
+                <a:solidFill>
+                  <a:srgbClr val="12302D"/>
+                </a:solidFill>
+                <a:latin typeface="Calibri"/>
+              </a:rPr>
+              <a:t>•  Both removed from the code</a:t>
+            </a:r>
+          </a:p>
+        </p:txBody>
+      </p:sp>
+      <p:sp>
+        <p:nvSpPr>
+          <p:cNvPr id="8" name="TextBox 7"/>
+          <p:cNvSpPr txBox="1"/>
+          <p:nvPr/>
+        </p:nvSpPr>
+        <p:spPr>
+          <a:xfrm>
+            <a:off x="548640" y="5029200"/>
+            <a:ext cx="11155680" cy="1280160"/>
+          </a:xfrm>
+          <a:prstGeom prst="rect">
+            <a:avLst/>
+          </a:prstGeom>
+          <a:noFill/>
+        </p:spPr>
+        <p:txBody>
+          <a:bodyPr wrap="square">
+            <a:spAutoFit/>
+          </a:bodyPr>
+          <a:lstStyle/>
+          <a:p>
+            <a:pPr>
+              <a:spcAft>
+                <a:spcPts val="800"/>
+              </a:spcAft>
+            </a:pPr>
+            <a:r>
+              <a:rPr sz="1600" b="0">
+                <a:solidFill>
+                  <a:srgbClr val="12302D"/>
+                </a:solidFill>
+                <a:latin typeface="Calibri"/>
+              </a:rPr>
+              <a:t>•  The CPU limit that I wrote without measuring was the first bottleneck.</a:t>
+            </a:r>
+          </a:p>
+          <a:p>
+            <a:pPr>
+              <a:spcAft>
+                <a:spcPts val="800"/>
+              </a:spcAft>
+            </a:pPr>
+            <a:r>
+              <a:rPr sz="1600" b="0">
+                <a:solidFill>
+                  <a:srgbClr val="12302D"/>
+                </a:solidFill>
+                <a:latin typeface="Calibri"/>
+              </a:rPr>
+              <a:t>•  Right-sizing did not shrink everything: the CPU request went up, because the old one was too low.</a:t>
+            </a:r>
+          </a:p>
+        </p:txBody>
+      </p:sp>
+    </p:spTree>
+  </p:cSld>
+  <p:clrMapOvr>
+    <a:masterClrMapping/>
+  </p:clrMapOvr>
+</p:sld>
+</file>
+
+<file path=ppt/slides/slide15.xml><?xml version="1.0" encoding="utf-8"?>
+<p:sld xmlns:a="http://schemas.openxmlformats.org/drawingml/2006/main" xmlns:p="http://schemas.openxmlformats.org/presentationml/2006/main" xmlns:r="http://schemas.openxmlformats.org/officeDocument/2006/relationships">
+  <p:cSld>
+    <p:bg>
+      <p:bgPr>
+        <a:solidFill>
+          <a:srgbClr val="F4F7F6"/>
+        </a:solidFill>
+        <a:effectLst/>
+      </p:bgPr>
+    </p:bg>
+    <p:spTree>
+      <p:nvGrpSpPr>
+        <p:cNvPr id="1" name=""/>
+        <p:cNvGrpSpPr/>
+        <p:nvPr/>
+      </p:nvGrpSpPr>
+      <p:grpSpPr/>
+      <p:sp>
+        <p:nvSpPr>
+          <p:cNvPr id="2" name="Rectangle 1"/>
+          <p:cNvSpPr/>
+          <p:nvPr/>
+        </p:nvSpPr>
+        <p:spPr>
+          <a:xfrm>
+            <a:off x="0" y="0"/>
+            <a:ext cx="228600" cy="6858000"/>
+          </a:xfrm>
+          <a:prstGeom prst="rect">
+            <a:avLst/>
+          </a:prstGeom>
+          <a:solidFill>
+            <a:srgbClr val="0F766E"/>
+          </a:solidFill>
+          <a:ln>
+            <a:noFill/>
+          </a:ln>
+        </p:spPr>
+        <p:style>
+          <a:lnRef idx="1">
+            <a:schemeClr val="accent1"/>
+          </a:lnRef>
+          <a:fillRef idx="3">
+            <a:schemeClr val="accent1"/>
+          </a:fillRef>
+          <a:effectRef idx="2">
+            <a:schemeClr val="accent1"/>
+          </a:effectRef>
+          <a:fontRef idx="minor">
+            <a:schemeClr val="lt1"/>
+          </a:fontRef>
+        </p:style>
+        <p:txBody>
+          <a:bodyPr rtlCol="0" anchor="ctr"/>
+          <a:lstStyle/>
+          <a:p>
+            <a:pPr algn="ctr"/>
+          </a:p>
+        </p:txBody>
+      </p:sp>
+      <p:sp>
+        <p:nvSpPr>
+          <p:cNvPr id="3" name="TextBox 2"/>
+          <p:cNvSpPr txBox="1"/>
+          <p:nvPr/>
+        </p:nvSpPr>
+        <p:spPr>
+          <a:xfrm>
+            <a:off x="548640" y="320040"/>
+            <a:ext cx="11155680" cy="822960"/>
+          </a:xfrm>
+          <a:prstGeom prst="rect">
+            <a:avLst/>
+          </a:prstGeom>
+          <a:noFill/>
+        </p:spPr>
+        <p:txBody>
+          <a:bodyPr wrap="square">
+            <a:spAutoFit/>
+          </a:bodyPr>
+          <a:lstStyle/>
+          <a:p>
+            <a:r>
+              <a:rPr sz="3400" b="1">
+                <a:solidFill>
+                  <a:srgbClr val="12302D"/>
+                </a:solidFill>
+                <a:latin typeface="Calibri"/>
+              </a:rPr>
+              <a:t>From a change to a running system</a:t>
+            </a:r>
+          </a:p>
+        </p:txBody>
+      </p:sp>
+      <p:sp>
+        <p:nvSpPr>
+          <p:cNvPr id="4" name="TextBox 3"/>
+          <p:cNvSpPr txBox="1"/>
+          <p:nvPr/>
+        </p:nvSpPr>
+        <p:spPr>
+          <a:xfrm>
+            <a:off x="548640" y="1005840"/>
+            <a:ext cx="11155680" cy="457200"/>
+          </a:xfrm>
+          <a:prstGeom prst="rect">
+            <a:avLst/>
+          </a:prstGeom>
+          <a:noFill/>
+        </p:spPr>
+        <p:txBody>
+          <a:bodyPr wrap="square">
+            <a:spAutoFit/>
+          </a:bodyPr>
+          <a:lstStyle/>
+          <a:p>
+            <a:r>
+              <a:rPr sz="1800">
+                <a:solidFill>
+                  <a:srgbClr val="5B726F"/>
+                </a:solidFill>
+                <a:latin typeface="Calibri"/>
+              </a:rPr>
+              <a:t>I rehearsed the whole loop, and here is what I learned</a:t>
+            </a:r>
+          </a:p>
+        </p:txBody>
+      </p:sp>
+      <p:sp>
+        <p:nvSpPr>
+          <p:cNvPr id="5" name="TextBox 4"/>
+          <p:cNvSpPr txBox="1"/>
+          <p:nvPr/>
+        </p:nvSpPr>
+        <p:spPr>
+          <a:xfrm>
+            <a:off x="548640" y="6446520"/>
+            <a:ext cx="11155680" cy="320040"/>
+          </a:xfrm>
+          <a:prstGeom prst="rect">
+            <a:avLst/>
+          </a:prstGeom>
+          <a:noFill/>
+        </p:spPr>
+        <p:txBody>
+          <a:bodyPr wrap="none">
+            <a:spAutoFit/>
+          </a:bodyPr>
+          <a:lstStyle/>
+          <a:p>
+            <a:r>
+              <a:rPr sz="1100">
+                <a:solidFill>
+                  <a:srgbClr val="5B726F"/>
+                </a:solidFill>
+                <a:latin typeface="Calibri"/>
+              </a:rPr>
+              <a:t>CampusSlot   |   Ujjwal Jain   |   15 / 15</a:t>
             </a:r>
           </a:p>
         </p:txBody>
@@ -8403,7 +9222,7 @@
                 </a:solidFill>
                 <a:latin typeface="Calibri"/>
               </a:rPr>
-              <a:t>CampusSlot   |   Ujjwal Jain   |   2 / 14</a:t>
+              <a:t>CampusSlot   |   Ujjwal Jain   |   2 / 15</a:t>
             </a:r>
           </a:p>
         </p:txBody>
@@ -9738,7 +10557,7 @@
                 </a:solidFill>
                 <a:latin typeface="Calibri"/>
               </a:rPr>
-              <a:t>CampusSlot   |   Ujjwal Jain   |   3 / 14</a:t>
+              <a:t>CampusSlot   |   Ujjwal Jain   |   3 / 15</a:t>
             </a:r>
           </a:p>
         </p:txBody>
@@ -10187,7 +11006,7 @@
                 </a:solidFill>
                 <a:latin typeface="Calibri"/>
               </a:rPr>
-              <a:t>CampusSlot   |   Ujjwal Jain   |   4 / 14</a:t>
+              <a:t>CampusSlot   |   Ujjwal Jain   |   4 / 15</a:t>
             </a:r>
           </a:p>
         </p:txBody>
@@ -10609,7 +11428,7 @@
                 </a:solidFill>
                 <a:latin typeface="Calibri"/>
               </a:rPr>
-              <a:t>CampusSlot   |   Ujjwal Jain   |   5 / 14</a:t>
+              <a:t>CampusSlot   |   Ujjwal Jain   |   5 / 15</a:t>
             </a:r>
           </a:p>
         </p:txBody>
@@ -11055,7 +11874,7 @@
                 </a:solidFill>
                 <a:latin typeface="Calibri"/>
               </a:rPr>
-              <a:t>CampusSlot   |   Ujjwal Jain   |   6 / 14</a:t>
+              <a:t>CampusSlot   |   Ujjwal Jain   |   6 / 15</a:t>
             </a:r>
           </a:p>
         </p:txBody>
@@ -11658,7 +12477,7 @@
                 </a:solidFill>
                 <a:latin typeface="Calibri"/>
               </a:rPr>
-              <a:t>CampusSlot   |   Ujjwal Jain   |   7 / 14</a:t>
+              <a:t>CampusSlot   |   Ujjwal Jain   |   7 / 15</a:t>
             </a:r>
           </a:p>
         </p:txBody>
@@ -12152,7 +12971,7 @@
                 </a:solidFill>
                 <a:latin typeface="Calibri"/>
               </a:rPr>
-              <a:t>CampusSlot   |   Ujjwal Jain   |   8 / 14</a:t>
+              <a:t>CampusSlot   |   Ujjwal Jain   |   8 / 15</a:t>
             </a:r>
           </a:p>
         </p:txBody>
@@ -12714,7 +13533,7 @@
                 </a:solidFill>
                 <a:latin typeface="Calibri"/>
               </a:rPr>
-              <a:t>CampusSlot   |   Ujjwal Jain   |   9 / 14</a:t>
+              <a:t>CampusSlot   |   Ujjwal Jain   |   9 / 15</a:t>
             </a:r>
           </a:p>
         </p:txBody>

</xml_diff>

<commit_message>
Final audit: submission checklist, terraform init transcript, AWS sweep and refreshed test evidence
Adds docs/SUBMISSION-CHECKLIST.md mapping every rubric item to its evidence, a clean terraform init
transcript, an all-region AWS sweep with the account and key IDs masked, and test transcripts from a
current run (47 + 7 + 12). Corrects the stale test counts in the README and the deck.
</commit_message>
<xml_diff>
--- a/docs/presentation/CampusSlot-final-presentation.pptx
+++ b/docs/presentation/CampusSlot-final-presentation.pptx
@@ -8745,7 +8745,7 @@
                           </a:solidFill>
                           <a:latin typeface="Calibri"/>
                         </a:rPr>
-                        <a:t>46 + 4 + 12</a:t>
+                        <a:t>47 + 7 + 12</a:t>
                       </a:r>
                     </a:p>
                   </a:txBody>
@@ -10972,7 +10972,7 @@
                 </a:solidFill>
                 <a:latin typeface="Calibri"/>
               </a:rPr>
-              <a:t>74 meaningful commits, each one a small step that can be explained</a:t>
+              <a:t>77 meaningful commits, each one a small step that can be explained</a:t>
             </a:r>
           </a:p>
         </p:txBody>

</xml_diff>

<commit_message>
Final audit: submission checklist, terraform init transcript, AWS sweep and refreshed test evidence (#14)
Adds docs/SUBMISSION-CHECKLIST.md mapping every rubric item to its evidence, a clean terraform init
transcript, an all-region AWS sweep with the account and key IDs masked, and test transcripts from a
current run (47 + 7 + 12). Corrects the stale test counts in the README and the deck.
</commit_message>
<xml_diff>
--- a/docs/presentation/CampusSlot-final-presentation.pptx
+++ b/docs/presentation/CampusSlot-final-presentation.pptx
@@ -8745,7 +8745,7 @@
                           </a:solidFill>
                           <a:latin typeface="Calibri"/>
                         </a:rPr>
-                        <a:t>46 + 4 + 12</a:t>
+                        <a:t>47 + 7 + 12</a:t>
                       </a:r>
                     </a:p>
                   </a:txBody>
@@ -10972,7 +10972,7 @@
                 </a:solidFill>
                 <a:latin typeface="Calibri"/>
               </a:rPr>
-              <a:t>74 meaningful commits, each one a small step that can be explained</a:t>
+              <a:t>77 meaningful commits, each one a small step that can be explained</a:t>
             </a:r>
           </a:p>
         </p:txBody>

</xml_diff>

<commit_message>
Add the bad release drill: automatic rollback measured, with a control, and the demo guide
A deliberately broken release (the container listens on the wrong port) is deployed with helm upgrade
--atomic and a 60 s timeout chosen from measured rollouts. Three runs: first signal at 3.6 to 5.4 s,
automatic rollback at 62 s, previous release alone at 72 s, 0 of 4800 user requests failed. Without
--atomic the broken pod stays until a person acts. Adds the drill script, the transcripts, the demo
guide, and updates the README, the checklist and the deck.
</commit_message>
<xml_diff>
--- a/docs/presentation/CampusSlot-final-presentation.pptx
+++ b/docs/presentation/CampusSlot-final-presentation.pptx
@@ -726,7 +726,7 @@
           <a:lstStyle/>
           <a:p>
             <a:r>
-              <a:t>Meeting a checklist is the minimum. What I wanted to show is the habit behind it: measure, find the weak point, change one thing, measure again, and write down what it cost. The chart allowed no unavailable replicas during a rollout, but when I measured it, every rollout lost one or two requests. An eight second delay before a pod stops fixed that in six out of six repeats. When I killed the database, users got eighteen errors but Prometheus counted none, so my own alerts were blind to a database outage. I made the application answer with a handled error, and now all of them are counted. I also made an alert fire on purpose and resolve, and I restored a deleted table from a backup and compared a checksum. The numbers come from small samples on one laptop, and the documents say so.</a:t>
+              <a:t>Meeting a checklist is the minimum. What I wanted to show is the habit behind it: measure, find the weak point, change one thing, measure again, and write down what it cost. The chart allowed no unavailable replicas during a rollout, but when I measured it, every rollout lost one or two requests. An eight second delay before a pod stops fixed that in six out of six repeats. When I killed the database, users got eighteen errors but Prometheus counted none, so my own alerts were blind to a database outage. I made the application answer with a handled error, and now all of them are counted. I also made an alert fire on purpose and resolve, I restored a deleted table from a backup and compared a checksum, and I deployed a deliberately broken release: Helm rolled it back by itself in 72 seconds and none of 4800 user requests failed. The numbers come from small samples on one laptop, and the documents say so.</a:t>
             </a:r>
           </a:p>
         </p:txBody>
@@ -6058,7 +6058,7 @@
         </p:nvGraphicFramePr>
         <p:xfrm>
           <a:off x="548640" y="1645920"/>
-          <a:ext cx="6949440" cy="2194560"/>
+          <a:ext cx="6949440" cy="2560320"/>
         </p:xfrm>
         <a:graphic>
           <a:graphicData uri="http://schemas.openxmlformats.org/drawingml/2006/table">
@@ -6479,6 +6479,74 @@
                   </a:tcPr>
                 </a:tc>
               </a:tr>
+              <a:tr h="365760">
+                <a:tc>
+                  <a:txBody>
+                    <a:bodyPr/>
+                    <a:lstStyle/>
+                    <a:p>
+                      <a:r>
+                        <a:rPr sz="1500">
+                          <a:solidFill>
+                            <a:srgbClr val="12302D"/>
+                          </a:solidFill>
+                          <a:latin typeface="Calibri"/>
+                        </a:rPr>
+                        <a:t>Broken release recovery</a:t>
+                      </a:r>
+                    </a:p>
+                  </a:txBody>
+                  <a:tcPr marL="73152" marR="73152">
+                    <a:solidFill>
+                      <a:srgbClr val="D7ECE9"/>
+                    </a:solidFill>
+                  </a:tcPr>
+                </a:tc>
+                <a:tc>
+                  <a:txBody>
+                    <a:bodyPr/>
+                    <a:lstStyle/>
+                    <a:p>
+                      <a:r>
+                        <a:rPr sz="1500">
+                          <a:solidFill>
+                            <a:srgbClr val="12302D"/>
+                          </a:solidFill>
+                          <a:latin typeface="Calibri"/>
+                        </a:rPr>
+                        <a:t>by a person</a:t>
+                      </a:r>
+                    </a:p>
+                  </a:txBody>
+                  <a:tcPr marL="73152" marR="73152">
+                    <a:solidFill>
+                      <a:srgbClr val="D7ECE9"/>
+                    </a:solidFill>
+                  </a:tcPr>
+                </a:tc>
+                <a:tc>
+                  <a:txBody>
+                    <a:bodyPr/>
+                    <a:lstStyle/>
+                    <a:p>
+                      <a:r>
+                        <a:rPr sz="1500">
+                          <a:solidFill>
+                            <a:srgbClr val="12302D"/>
+                          </a:solidFill>
+                          <a:latin typeface="Calibri"/>
+                        </a:rPr>
+                        <a:t>automatic, 72 s</a:t>
+                      </a:r>
+                    </a:p>
+                  </a:txBody>
+                  <a:tcPr marL="73152" marR="73152">
+                    <a:solidFill>
+                      <a:srgbClr val="D7ECE9"/>
+                    </a:solidFill>
+                  </a:tcPr>
+                </a:tc>
+              </a:tr>
             </a:tbl>
           </a:graphicData>
         </a:graphic>
@@ -7099,7 +7167,7 @@
                 </a:solidFill>
                 <a:latin typeface="Calibri"/>
               </a:rPr>
-              <a:t>•  Rollback drill</a:t>
+              <a:t>•  Git revert vs Argo CD rollback</a:t>
             </a:r>
           </a:p>
           <a:p>
@@ -10972,7 +11040,7 @@
                 </a:solidFill>
                 <a:latin typeface="Calibri"/>
               </a:rPr>
-              <a:t>77 meaningful commits, each one a small step that can be explained</a:t>
+              <a:t>80 meaningful commits, each one a small step that can be explained</a:t>
             </a:r>
           </a:p>
         </p:txBody>

</xml_diff>

<commit_message>
Add the bad release drill: automatic rollback measured, with a control, and the demo guide (#17)
A deliberately broken release (the container listens on the wrong port) is deployed with helm upgrade
--atomic and a 60 s timeout chosen from measured rollouts. Three runs: first signal at 3.6 to 5.4 s,
automatic rollback at 62 s, previous release alone at 72 s, 0 of 4800 user requests failed. Without
--atomic the broken pod stays until a person acts. Adds the drill script, the transcripts, the demo
guide, and updates the README, the checklist and the deck.
</commit_message>
<xml_diff>
--- a/docs/presentation/CampusSlot-final-presentation.pptx
+++ b/docs/presentation/CampusSlot-final-presentation.pptx
@@ -726,7 +726,7 @@
           <a:lstStyle/>
           <a:p>
             <a:r>
-              <a:t>Meeting a checklist is the minimum. What I wanted to show is the habit behind it: measure, find the weak point, change one thing, measure again, and write down what it cost. The chart allowed no unavailable replicas during a rollout, but when I measured it, every rollout lost one or two requests. An eight second delay before a pod stops fixed that in six out of six repeats. When I killed the database, users got eighteen errors but Prometheus counted none, so my own alerts were blind to a database outage. I made the application answer with a handled error, and now all of them are counted. I also made an alert fire on purpose and resolve, and I restored a deleted table from a backup and compared a checksum. The numbers come from small samples on one laptop, and the documents say so.</a:t>
+              <a:t>Meeting a checklist is the minimum. What I wanted to show is the habit behind it: measure, find the weak point, change one thing, measure again, and write down what it cost. The chart allowed no unavailable replicas during a rollout, but when I measured it, every rollout lost one or two requests. An eight second delay before a pod stops fixed that in six out of six repeats. When I killed the database, users got eighteen errors but Prometheus counted none, so my own alerts were blind to a database outage. I made the application answer with a handled error, and now all of them are counted. I also made an alert fire on purpose and resolve, I restored a deleted table from a backup and compared a checksum, and I deployed a deliberately broken release: Helm rolled it back by itself in 72 seconds and none of 4800 user requests failed. The numbers come from small samples on one laptop, and the documents say so.</a:t>
             </a:r>
           </a:p>
         </p:txBody>
@@ -6058,7 +6058,7 @@
         </p:nvGraphicFramePr>
         <p:xfrm>
           <a:off x="548640" y="1645920"/>
-          <a:ext cx="6949440" cy="2194560"/>
+          <a:ext cx="6949440" cy="2560320"/>
         </p:xfrm>
         <a:graphic>
           <a:graphicData uri="http://schemas.openxmlformats.org/drawingml/2006/table">
@@ -6479,6 +6479,74 @@
                   </a:tcPr>
                 </a:tc>
               </a:tr>
+              <a:tr h="365760">
+                <a:tc>
+                  <a:txBody>
+                    <a:bodyPr/>
+                    <a:lstStyle/>
+                    <a:p>
+                      <a:r>
+                        <a:rPr sz="1500">
+                          <a:solidFill>
+                            <a:srgbClr val="12302D"/>
+                          </a:solidFill>
+                          <a:latin typeface="Calibri"/>
+                        </a:rPr>
+                        <a:t>Broken release recovery</a:t>
+                      </a:r>
+                    </a:p>
+                  </a:txBody>
+                  <a:tcPr marL="73152" marR="73152">
+                    <a:solidFill>
+                      <a:srgbClr val="D7ECE9"/>
+                    </a:solidFill>
+                  </a:tcPr>
+                </a:tc>
+                <a:tc>
+                  <a:txBody>
+                    <a:bodyPr/>
+                    <a:lstStyle/>
+                    <a:p>
+                      <a:r>
+                        <a:rPr sz="1500">
+                          <a:solidFill>
+                            <a:srgbClr val="12302D"/>
+                          </a:solidFill>
+                          <a:latin typeface="Calibri"/>
+                        </a:rPr>
+                        <a:t>by a person</a:t>
+                      </a:r>
+                    </a:p>
+                  </a:txBody>
+                  <a:tcPr marL="73152" marR="73152">
+                    <a:solidFill>
+                      <a:srgbClr val="D7ECE9"/>
+                    </a:solidFill>
+                  </a:tcPr>
+                </a:tc>
+                <a:tc>
+                  <a:txBody>
+                    <a:bodyPr/>
+                    <a:lstStyle/>
+                    <a:p>
+                      <a:r>
+                        <a:rPr sz="1500">
+                          <a:solidFill>
+                            <a:srgbClr val="12302D"/>
+                          </a:solidFill>
+                          <a:latin typeface="Calibri"/>
+                        </a:rPr>
+                        <a:t>automatic, 72 s</a:t>
+                      </a:r>
+                    </a:p>
+                  </a:txBody>
+                  <a:tcPr marL="73152" marR="73152">
+                    <a:solidFill>
+                      <a:srgbClr val="D7ECE9"/>
+                    </a:solidFill>
+                  </a:tcPr>
+                </a:tc>
+              </a:tr>
             </a:tbl>
           </a:graphicData>
         </a:graphic>
@@ -7099,7 +7167,7 @@
                 </a:solidFill>
                 <a:latin typeface="Calibri"/>
               </a:rPr>
-              <a:t>•  Rollback drill</a:t>
+              <a:t>•  Git revert vs Argo CD rollback</a:t>
             </a:r>
           </a:p>
           <a:p>
@@ -10972,7 +11040,7 @@
                 </a:solidFill>
                 <a:latin typeface="Calibri"/>
               </a:rPr>
-              <a:t>77 meaningful commits, each one a small step that can be explained</a:t>
+              <a:t>80 meaningful commits, each one a small step that can be explained</a:t>
             </a:r>
           </a:p>
         </p:txBody>

</xml_diff>

<commit_message>
Final audit: fix stale numbers, trim the repository to what is needed
Fixes the README, the deck and two decision records (migrations, template files, Node 26, pipeline
timings, cost, test counts). Moves the demo guide, the dashboard generator and two superseded
transcripts out of the repository.
</commit_message>
<xml_diff>
--- a/docs/presentation/CampusSlot-final-presentation.pptx
+++ b/docs/presentation/CampusSlot-final-presentation.pptx
@@ -1286,7 +1286,7 @@
           <a:lstStyle/>
           <a:p>
             <a:r>
-              <a:t>This is the pipeline in GitHub Actions. When I push code, the tests run, the dependencies and the history are checked for known problems, and the frontend is built. Only if all of that passes are the two images built, scanned and pushed to the registry, tagged with the exact commit. Then the chart is installed into a temporary Kubernetes cluster and the real application is tested through the ingress. A full green run took about four minutes. The pipeline was red a few times while I built it, and each failure taught me something that is written up in the README.</a:t>
+              <a:t>This is the pipeline in GitHub Actions. When I push code, the tests run, the dependencies and the history are checked for known problems, and the frontend is built. Only if all of that passes are the two images built, scanned and pushed to the registry, tagged with the exact commit. Then the chart is installed into a temporary Kubernetes cluster and the real application is tested through the ingress. The run in the screenshot took about four minutes. Today the jobs run side by side, with a static analysis job for the infrastructure code and signed provenance for the images, and a full run takes about three minutes. The pipeline was red a few times while I built it, and each failure taught me something that is written up in the README.</a:t>
             </a:r>
           </a:p>
         </p:txBody>
@@ -1426,7 +1426,7 @@
           <a:lstStyle/>
           <a:p>
             <a:r>
-              <a:t>Terraform describes the AWS network and a Kubernetes cluster as code. The plan listed 48 resources. I applied it for real, checked that the cluster and the node were healthy, and destroyed everything about 45 minutes later. The first apply failed, because I had not told the subnets to hand out public addresses, and I found that by asking EKS for the health of the node group. The network deliberately has no NAT gateway, to save money, and the README explains what a production design would do instead. A final check found nothing left running, and the estimated cost was about ten US cents.</a:t>
+              <a:t>Terraform describes the AWS network and a Kubernetes cluster as code. The plan listed 48 resources. I applied it for real, checked that the cluster and the node were healthy, and destroyed everything about 45 minutes later. The first apply failed, because I had not told the subnets to hand out public addresses, and I found that by asking EKS for the health of the node group. The network deliberately has no NAT gateway, to save money, and the README explains what a production design would do instead. A final check found nothing left running, and the measured cost was about six US cents of credit.</a:t>
             </a:r>
           </a:p>
         </p:txBody>
@@ -11040,7 +11040,7 @@
                 </a:solidFill>
                 <a:latin typeface="Calibri"/>
               </a:rPr>
-              <a:t>80 meaningful commits, each one a small step that can be explained</a:t>
+              <a:t>More than 80 meaningful commits, each one a small step that can be explained</a:t>
             </a:r>
           </a:p>
         </p:txBody>
@@ -12011,7 +12011,7 @@
                           </a:solidFill>
                           <a:latin typeface="Calibri"/>
                         </a:rPr>
-                        <a:t>Stage</a:t>
+                        <a:t>Run in the screenshot</a:t>
                       </a:r>
                     </a:p>
                   </a:txBody>
@@ -12377,6 +12377,22 @@
               <a:t>•  Images are tagged with the commit, never latest</a:t>
             </a:r>
           </a:p>
+          <a:p>
+            <a:pPr>
+              <a:spcAft>
+                <a:spcPts val="800"/>
+              </a:spcAft>
+            </a:pPr>
+            <a:r>
+              <a:rPr sz="1600" b="0">
+                <a:solidFill>
+                  <a:srgbClr val="12302D"/>
+                </a:solidFill>
+                <a:latin typeface="Calibri"/>
+              </a:rPr>
+              <a:t>•  Today: jobs side by side, about 3 minutes</a:t>
+            </a:r>
+          </a:p>
         </p:txBody>
       </p:sp>
     </p:spTree>
@@ -12788,7 +12804,7 @@
                 </a:solidFill>
                 <a:latin typeface="Calibri"/>
               </a:rPr>
-              <a:t>Five kinds of check</a:t>
+              <a:t>Six kinds of check</a:t>
             </a:r>
           </a:p>
           <a:p>
@@ -12853,6 +12869,38 @@
                 <a:latin typeface="Calibri"/>
               </a:rPr>
               <a:t>Images: Trivy, blocks the build</a:t>
+            </a:r>
+          </a:p>
+          <a:p>
+            <a:pPr>
+              <a:spcAft>
+                <a:spcPts val="900"/>
+              </a:spcAft>
+            </a:pPr>
+            <a:r>
+              <a:rPr sz="1500" b="0">
+                <a:solidFill>
+                  <a:srgbClr val="12302D"/>
+                </a:solidFill>
+                <a:latin typeface="Calibri"/>
+              </a:rPr>
+              <a:t>Terraform and Helm: Trivy</a:t>
+            </a:r>
+          </a:p>
+          <a:p>
+            <a:pPr>
+              <a:spcAft>
+                <a:spcPts val="900"/>
+              </a:spcAft>
+            </a:pPr>
+            <a:r>
+              <a:rPr sz="1500" b="0">
+                <a:solidFill>
+                  <a:srgbClr val="12302D"/>
+                </a:solidFill>
+                <a:latin typeface="Calibri"/>
+              </a:rPr>
+              <a:t>Origin: signed provenance</a:t>
             </a:r>
           </a:p>
           <a:p>
@@ -13398,7 +13446,7 @@
                 </a:solidFill>
                 <a:latin typeface="Calibri"/>
               </a:rPr>
-              <a:t>About 10 US cents</a:t>
+              <a:t>About 6 US cents</a:t>
             </a:r>
           </a:p>
           <a:p>
@@ -13777,7 +13825,7 @@
                           </a:solidFill>
                           <a:latin typeface="Calibri"/>
                         </a:rPr>
-                        <a:t>Autoscaling test</a:t>
+                        <a:t>Autoscaling test, first sizing</a:t>
                       </a:r>
                     </a:p>
                   </a:txBody>

</xml_diff>

<commit_message>
Final audit: fix stale numbers, trim the repository to what is needed (#21)
Fixes the README, the deck and two decision records (migrations, template files, Node 26, pipeline
timings, cost, test counts). Moves the demo guide, the dashboard generator and two superseded
transcripts out of the repository.
</commit_message>
<xml_diff>
--- a/docs/presentation/CampusSlot-final-presentation.pptx
+++ b/docs/presentation/CampusSlot-final-presentation.pptx
@@ -1286,7 +1286,7 @@
           <a:lstStyle/>
           <a:p>
             <a:r>
-              <a:t>This is the pipeline in GitHub Actions. When I push code, the tests run, the dependencies and the history are checked for known problems, and the frontend is built. Only if all of that passes are the two images built, scanned and pushed to the registry, tagged with the exact commit. Then the chart is installed into a temporary Kubernetes cluster and the real application is tested through the ingress. A full green run took about four minutes. The pipeline was red a few times while I built it, and each failure taught me something that is written up in the README.</a:t>
+              <a:t>This is the pipeline in GitHub Actions. When I push code, the tests run, the dependencies and the history are checked for known problems, and the frontend is built. Only if all of that passes are the two images built, scanned and pushed to the registry, tagged with the exact commit. Then the chart is installed into a temporary Kubernetes cluster and the real application is tested through the ingress. The run in the screenshot took about four minutes. Today the jobs run side by side, with a static analysis job for the infrastructure code and signed provenance for the images, and a full run takes about three minutes. The pipeline was red a few times while I built it, and each failure taught me something that is written up in the README.</a:t>
             </a:r>
           </a:p>
         </p:txBody>
@@ -1426,7 +1426,7 @@
           <a:lstStyle/>
           <a:p>
             <a:r>
-              <a:t>Terraform describes the AWS network and a Kubernetes cluster as code. The plan listed 48 resources. I applied it for real, checked that the cluster and the node were healthy, and destroyed everything about 45 minutes later. The first apply failed, because I had not told the subnets to hand out public addresses, and I found that by asking EKS for the health of the node group. The network deliberately has no NAT gateway, to save money, and the README explains what a production design would do instead. A final check found nothing left running, and the estimated cost was about ten US cents.</a:t>
+              <a:t>Terraform describes the AWS network and a Kubernetes cluster as code. The plan listed 48 resources. I applied it for real, checked that the cluster and the node were healthy, and destroyed everything about 45 minutes later. The first apply failed, because I had not told the subnets to hand out public addresses, and I found that by asking EKS for the health of the node group. The network deliberately has no NAT gateway, to save money, and the README explains what a production design would do instead. A final check found nothing left running, and the measured cost was about six US cents of credit.</a:t>
             </a:r>
           </a:p>
         </p:txBody>
@@ -11040,7 +11040,7 @@
                 </a:solidFill>
                 <a:latin typeface="Calibri"/>
               </a:rPr>
-              <a:t>80 meaningful commits, each one a small step that can be explained</a:t>
+              <a:t>More than 80 meaningful commits, each one a small step that can be explained</a:t>
             </a:r>
           </a:p>
         </p:txBody>
@@ -12011,7 +12011,7 @@
                           </a:solidFill>
                           <a:latin typeface="Calibri"/>
                         </a:rPr>
-                        <a:t>Stage</a:t>
+                        <a:t>Run in the screenshot</a:t>
                       </a:r>
                     </a:p>
                   </a:txBody>
@@ -12377,6 +12377,22 @@
               <a:t>•  Images are tagged with the commit, never latest</a:t>
             </a:r>
           </a:p>
+          <a:p>
+            <a:pPr>
+              <a:spcAft>
+                <a:spcPts val="800"/>
+              </a:spcAft>
+            </a:pPr>
+            <a:r>
+              <a:rPr sz="1600" b="0">
+                <a:solidFill>
+                  <a:srgbClr val="12302D"/>
+                </a:solidFill>
+                <a:latin typeface="Calibri"/>
+              </a:rPr>
+              <a:t>•  Today: jobs side by side, about 3 minutes</a:t>
+            </a:r>
+          </a:p>
         </p:txBody>
       </p:sp>
     </p:spTree>
@@ -12788,7 +12804,7 @@
                 </a:solidFill>
                 <a:latin typeface="Calibri"/>
               </a:rPr>
-              <a:t>Five kinds of check</a:t>
+              <a:t>Six kinds of check</a:t>
             </a:r>
           </a:p>
           <a:p>
@@ -12853,6 +12869,38 @@
                 <a:latin typeface="Calibri"/>
               </a:rPr>
               <a:t>Images: Trivy, blocks the build</a:t>
+            </a:r>
+          </a:p>
+          <a:p>
+            <a:pPr>
+              <a:spcAft>
+                <a:spcPts val="900"/>
+              </a:spcAft>
+            </a:pPr>
+            <a:r>
+              <a:rPr sz="1500" b="0">
+                <a:solidFill>
+                  <a:srgbClr val="12302D"/>
+                </a:solidFill>
+                <a:latin typeface="Calibri"/>
+              </a:rPr>
+              <a:t>Terraform and Helm: Trivy</a:t>
+            </a:r>
+          </a:p>
+          <a:p>
+            <a:pPr>
+              <a:spcAft>
+                <a:spcPts val="900"/>
+              </a:spcAft>
+            </a:pPr>
+            <a:r>
+              <a:rPr sz="1500" b="0">
+                <a:solidFill>
+                  <a:srgbClr val="12302D"/>
+                </a:solidFill>
+                <a:latin typeface="Calibri"/>
+              </a:rPr>
+              <a:t>Origin: signed provenance</a:t>
             </a:r>
           </a:p>
           <a:p>
@@ -13398,7 +13446,7 @@
                 </a:solidFill>
                 <a:latin typeface="Calibri"/>
               </a:rPr>
-              <a:t>About 10 US cents</a:t>
+              <a:t>About 6 US cents</a:t>
             </a:r>
           </a:p>
           <a:p>
@@ -13777,7 +13825,7 @@
                           </a:solidFill>
                           <a:latin typeface="Calibri"/>
                         </a:rPr>
-                        <a:t>Autoscaling test</a:t>
+                        <a:t>Autoscaling test, first sizing</a:t>
                       </a:r>
                     </a:p>
                   </a:txBody>

</xml_diff>